<commit_message>
docs: trechos de código das apresentações no tema padrão do VS Code
Os blocos de código passam a imitar o editor do VS Code (Dark Modern):
aba do arquivo, breadcrumb, números de linha e as cores de sintaxe do
tema padrão (palavras-chave, controle de fluxo, tipos, funções,
strings, números, comentários e chaves de JSON/YAML).

Co-Authored-By: Claude Opus 5.5 <noreply@anthropic.com>
</commit_message>
<xml_diff>
--- a/docs/apresentacoes/05-apps-fiori.pptx
+++ b/docs/apresentacoes/05-apps-fiori.pptx
@@ -120,13 +120,13 @@
   <p:extLst>
     <p:ext uri="{521415D9-36F7-43E2-AB2F-B90AF26B5E84}">
       <p14:sectionLst xmlns:p14="http://schemas.microsoft.com/office/powerpoint/2010/main">
-        <p14:section name="Abertura" id="{89303d4e-3643-9c5b-f320-4e355a3b121f}">
+        <p14:section name="Abertura" id="{7bdcec3f-c6a5-b67e-428f-ca76a991cdfe}">
           <p14:sldIdLst>
             <p14:sldId id="256"/>
             <p14:sldId id="257"/>
           </p14:sldIdLst>
         </p14:section>
-        <p14:section name="Fiori Elements" id="{f75b95aa-a234-84e5-c7a9-b3a86d8e0276}">
+        <p14:section name="Fiori Elements" id="{6dc25c47-41cb-75bb-5932-d4a585bfb5d9}">
           <p14:sldIdLst>
             <p14:sldId id="258"/>
             <p14:sldId id="259"/>
@@ -134,13 +134,13 @@
             <p14:sldId id="261"/>
           </p14:sldIdLst>
         </p14:section>
-        <p14:section name="Análises" id="{4ad9e6d8-c0ae-f0e1-f74b-a3c6e17ca7cd}">
+        <p14:section name="Análises" id="{c3f89920-05e9-7481-1dcd-ecbdc5039da4}">
           <p14:sldIdLst>
             <p14:sldId id="262"/>
             <p14:sldId id="263"/>
           </p14:sldIdLst>
         </p14:section>
-        <p14:section name="Launchpad e deploy" id="{f9e2ac4d-7f0d-2c00-d922-6790d448587b}">
+        <p14:section name="Launchpad e deploy" id="{dc8b314f-d1a9-c59f-3750-5fb4bfc5614d}">
           <p14:sldIdLst>
             <p14:sldId id="264"/>
             <p14:sldId id="265"/>
@@ -148,7 +148,7 @@
             <p14:sldId id="267"/>
           </p14:sldIdLst>
         </p14:section>
-        <p14:section name="Encerramento" id="{882b48d9-7d12-bb26-be6d-058c7be8977c}">
+        <p14:section name="Encerramento" id="{c7a41d33-0026-6044-b2e7-d75b50cf8e5b}">
           <p14:sldIdLst>
             <p14:sldId id="268"/>
             <p14:sldId id="269"/>
@@ -4481,7 +4481,7 @@
       </p:sp>
       <p:sp>
         <p:nvSpPr>
-          <p:cNvPr id="5" name="Código"/>
+          <p:cNvPr id="5" name="Editor"/>
           <p:cNvSpPr/>
           <p:nvPr/>
         </p:nvSpPr>
@@ -4496,9 +4496,14 @@
             </a:avLst>
           </a:prstGeom>
           <a:solidFill>
-            <a:srgbClr val="12171C"/>
+            <a:srgbClr val="181818"/>
           </a:solidFill>
-          <a:ln/>
+          <a:ln w="9525">
+            <a:solidFill>
+              <a:srgbClr val="2B2B2B"/>
+            </a:solidFill>
+            <a:prstDash val="solid"/>
+          </a:ln>
           <a:effectLst>
             <a:outerShdw sx="100000" sy="100000" kx="0" ky="0" algn="bl" rotWithShape="0" blurRad="101600" dist="25400" dir="5400000">
               <a:srgbClr val="223548">
@@ -4510,42 +4515,25 @@
       </p:sp>
       <p:sp>
         <p:nvSpPr>
-          <p:cNvPr id="6" name="Text 3"/>
-          <p:cNvSpPr txBox="1"/>
-          <p:nvPr/>
-        </p:nvSpPr>
-        <p:spPr>
-          <a:xfrm>
-            <a:off x="777240" y="1755648"/>
-            <a:ext cx="5303520" cy="256032"/>
-          </a:xfrm>
-          <a:prstGeom prst="rect">
-            <a:avLst/>
-          </a:prstGeom>
-          <a:noFill/>
-          <a:ln/>
-        </p:spPr>
-        <p:txBody>
-          <a:bodyPr wrap="square" lIns="0" tIns="0" rIns="0" bIns="0" rtlCol="0" anchor="ctr"/>
-          <a:lstStyle/>
-          <a:p>
-            <a:pPr indent="0" marL="0">
-              <a:buNone/>
-            </a:pPr>
-            <a:r>
-              <a:rPr lang="en-US" sz="1000" dirty="0">
-                <a:solidFill>
-                  <a:srgbClr val="A9B4BE"/>
-                </a:solidFill>
-                <a:latin typeface="Courier New" pitchFamily="34" charset="0"/>
-                <a:ea typeface="Courier New" pitchFamily="34" charset="-122"/>
-                <a:cs typeface="Courier New" pitchFamily="34" charset="-120"/>
-              </a:rPr>
-              <a:t>ui5/pedidos-compras/ui5-deploy.yaml</a:t>
-            </a:r>
-            <a:endParaRPr lang="en-US" sz="1000" dirty="0"/>
-          </a:p>
-        </p:txBody>
+          <p:cNvPr id="6" name="Área do editor"/>
+          <p:cNvSpPr/>
+          <p:nvPr/>
+        </p:nvSpPr>
+        <p:spPr>
+          <a:xfrm>
+            <a:off x="548640" y="1993392"/>
+            <a:ext cx="5760720" cy="4178808"/>
+          </a:xfrm>
+          <a:prstGeom prst="roundRect">
+            <a:avLst>
+              <a:gd name="adj" fmla="val 2188"/>
+            </a:avLst>
+          </a:prstGeom>
+          <a:solidFill>
+            <a:srgbClr val="1F1F1F"/>
+          </a:solidFill>
+          <a:ln/>
+        </p:spPr>
       </p:sp>
       <p:sp>
         <p:nvSpPr>
@@ -4555,16 +4543,36 @@
         </p:nvSpPr>
         <p:spPr>
           <a:xfrm>
-            <a:off x="777240" y="2066544"/>
-            <a:ext cx="5303520" cy="0"/>
+            <a:off x="557784" y="1993392"/>
+            <a:ext cx="5742432" cy="137160"/>
+          </a:xfrm>
+          <a:prstGeom prst="rect">
+            <a:avLst/>
+          </a:prstGeom>
+          <a:solidFill>
+            <a:srgbClr val="1F1F1F"/>
+          </a:solidFill>
+          <a:ln/>
+        </p:spPr>
+      </p:sp>
+      <p:sp>
+        <p:nvSpPr>
+          <p:cNvPr id="8" name="Shape 5"/>
+          <p:cNvSpPr/>
+          <p:nvPr/>
+        </p:nvSpPr>
+        <p:spPr>
+          <a:xfrm>
+            <a:off x="557784" y="1993392"/>
+            <a:ext cx="5742432" cy="0"/>
           </a:xfrm>
           <a:prstGeom prst="line">
             <a:avLst/>
           </a:prstGeom>
           <a:noFill/>
-          <a:ln w="12700">
+          <a:ln w="9525">
             <a:solidFill>
-              <a:srgbClr val="2E3A46"/>
+              <a:srgbClr val="2B2B2B"/>
             </a:solidFill>
             <a:prstDash val="solid"/>
           </a:ln>
@@ -4572,14 +4580,75 @@
       </p:sp>
       <p:sp>
         <p:nvSpPr>
-          <p:cNvPr id="8" name="Trecho de código"/>
+          <p:cNvPr id="9" name="Aba ui5-deploy.yaml"/>
+          <p:cNvSpPr/>
+          <p:nvPr/>
+        </p:nvSpPr>
+        <p:spPr>
+          <a:xfrm>
+            <a:off x="640080" y="1719072"/>
+            <a:ext cx="1531620" cy="274320"/>
+          </a:xfrm>
+          <a:prstGeom prst="rect">
+            <a:avLst/>
+          </a:prstGeom>
+          <a:solidFill>
+            <a:srgbClr val="1F1F1F"/>
+          </a:solidFill>
+          <a:ln/>
+        </p:spPr>
+        <p:txBody>
+          <a:bodyPr wrap="square" lIns="0" tIns="0" rIns="0" bIns="0" rtlCol="0" anchor="ctr"/>
+          <a:lstStyle/>
+          <a:p>
+            <a:pPr algn="ctr" indent="0" marL="0">
+              <a:buNone/>
+            </a:pPr>
+            <a:r>
+              <a:rPr lang="en-US" sz="1000" dirty="0">
+                <a:solidFill>
+                  <a:srgbClr val="FFFFFF"/>
+                </a:solidFill>
+              </a:rPr>
+              <a:t>ui5-deploy.yaml</a:t>
+            </a:r>
+            <a:endParaRPr lang="en-US" sz="1000" dirty="0"/>
+          </a:p>
+        </p:txBody>
+      </p:sp>
+      <p:sp>
+        <p:nvSpPr>
+          <p:cNvPr id="10" name="Shape 7"/>
+          <p:cNvSpPr/>
+          <p:nvPr/>
+        </p:nvSpPr>
+        <p:spPr>
+          <a:xfrm>
+            <a:off x="640080" y="1719072"/>
+            <a:ext cx="1531620" cy="0"/>
+          </a:xfrm>
+          <a:prstGeom prst="line">
+            <a:avLst/>
+          </a:prstGeom>
+          <a:noFill/>
+          <a:ln w="19050">
+            <a:solidFill>
+              <a:srgbClr val="0078D4"/>
+            </a:solidFill>
+            <a:prstDash val="solid"/>
+          </a:ln>
+        </p:spPr>
+      </p:sp>
+      <p:sp>
+        <p:nvSpPr>
+          <p:cNvPr id="11" name="Breadcrumb"/>
           <p:cNvSpPr txBox="1"/>
           <p:nvPr/>
         </p:nvSpPr>
         <p:spPr>
           <a:xfrm>
-            <a:off x="777240" y="2157984"/>
-            <a:ext cx="5303520" cy="3904488"/>
+            <a:off x="777240" y="2103120"/>
+            <a:ext cx="5303520" cy="219456"/>
           </a:xfrm>
           <a:prstGeom prst="rect">
             <a:avLst/>
@@ -4588,6 +4657,86 @@
           <a:ln/>
         </p:spPr>
         <p:txBody>
+          <a:bodyPr wrap="square" lIns="0" tIns="0" rIns="0" bIns="0" rtlCol="0" anchor="ctr"/>
+          <a:lstStyle/>
+          <a:p>
+            <a:pPr indent="0" marL="0">
+              <a:buNone/>
+            </a:pPr>
+            <a:r>
+              <a:rPr lang="en-US" sz="900" dirty="0">
+                <a:solidFill>
+                  <a:srgbClr val="A9A9A9"/>
+                </a:solidFill>
+              </a:rPr>
+              <a:t>ui5</a:t>
+            </a:r>
+            <a:pPr indent="0" marL="0">
+              <a:buNone/>
+            </a:pPr>
+            <a:r>
+              <a:rPr lang="en-US" sz="900" dirty="0">
+                <a:solidFill>
+                  <a:srgbClr val="6E7681"/>
+                </a:solidFill>
+              </a:rPr>
+              <a:t>  ›  </a:t>
+            </a:r>
+            <a:pPr indent="0" marL="0">
+              <a:buNone/>
+            </a:pPr>
+            <a:r>
+              <a:rPr lang="en-US" sz="900" dirty="0">
+                <a:solidFill>
+                  <a:srgbClr val="A9A9A9"/>
+                </a:solidFill>
+              </a:rPr>
+              <a:t>pedidos-compras</a:t>
+            </a:r>
+            <a:pPr indent="0" marL="0">
+              <a:buNone/>
+            </a:pPr>
+            <a:r>
+              <a:rPr lang="en-US" sz="900" dirty="0">
+                <a:solidFill>
+                  <a:srgbClr val="6E7681"/>
+                </a:solidFill>
+              </a:rPr>
+              <a:t>  ›  </a:t>
+            </a:r>
+            <a:pPr indent="0" marL="0">
+              <a:buNone/>
+            </a:pPr>
+            <a:r>
+              <a:rPr lang="en-US" sz="900" dirty="0">
+                <a:solidFill>
+                  <a:srgbClr val="A9A9A9"/>
+                </a:solidFill>
+              </a:rPr>
+              <a:t>ui5-deploy.yaml</a:t>
+            </a:r>
+            <a:endParaRPr lang="en-US" sz="900" dirty="0"/>
+          </a:p>
+        </p:txBody>
+      </p:sp>
+      <p:sp>
+        <p:nvSpPr>
+          <p:cNvPr id="12" name="Trecho de código"/>
+          <p:cNvSpPr txBox="1"/>
+          <p:nvPr/>
+        </p:nvSpPr>
+        <p:spPr>
+          <a:xfrm>
+            <a:off x="731520" y="2414016"/>
+            <a:ext cx="5440680" cy="3666744"/>
+          </a:xfrm>
+          <a:prstGeom prst="rect">
+            <a:avLst/>
+          </a:prstGeom>
+          <a:noFill/>
+          <a:ln/>
+        </p:spPr>
+        <p:txBody>
           <a:bodyPr wrap="square" lIns="0" tIns="0" rIns="0" bIns="0" rtlCol="0" anchor="t"/>
           <a:lstStyle/>
           <a:p>
@@ -4600,7 +4749,24 @@
             <a:r>
               <a:rPr lang="en-US" sz="1150" dirty="0">
                 <a:solidFill>
-                  <a:srgbClr val="4DB1FF"/>
+                  <a:srgbClr val="6E7681"/>
+                </a:solidFill>
+                <a:latin typeface="Courier New" pitchFamily="34" charset="0"/>
+                <a:ea typeface="Courier New" pitchFamily="34" charset="-122"/>
+                <a:cs typeface="Courier New" pitchFamily="34" charset="-120"/>
+              </a:rPr>
+              <a:t> 1  </a:t>
+            </a:r>
+            <a:pPr indent="0" marL="0">
+              <a:lnSpc>
+                <a:spcPct val="105000"/>
+              </a:lnSpc>
+              <a:buNone/>
+            </a:pPr>
+            <a:r>
+              <a:rPr lang="en-US" sz="1150" dirty="0">
+                <a:solidFill>
+                  <a:srgbClr val="569CD6"/>
                 </a:solidFill>
                 <a:latin typeface="Courier New" pitchFamily="34" charset="0"/>
                 <a:ea typeface="Courier New" pitchFamily="34" charset="-122"/>
@@ -4617,7 +4783,7 @@
             <a:r>
               <a:rPr lang="en-US" sz="1150" dirty="0">
                 <a:solidFill>
-                  <a:srgbClr val="E8ECEF"/>
+                  <a:srgbClr val="CCCCCC"/>
                 </a:solidFill>
                 <a:latin typeface="Courier New" pitchFamily="34" charset="0"/>
                 <a:ea typeface="Courier New" pitchFamily="34" charset="-122"/>
@@ -4637,13 +4803,13 @@
             <a:r>
               <a:rPr lang="en-US" sz="1150" dirty="0">
                 <a:solidFill>
-                  <a:srgbClr val="E8ECEF"/>
-                </a:solidFill>
-                <a:latin typeface="Courier New" pitchFamily="34" charset="0"/>
-                <a:ea typeface="Courier New" pitchFamily="34" charset="-122"/>
-                <a:cs typeface="Courier New" pitchFamily="34" charset="-120"/>
-              </a:rPr>
-              <a:t>  - </a:t>
+                  <a:srgbClr val="6E7681"/>
+                </a:solidFill>
+                <a:latin typeface="Courier New" pitchFamily="34" charset="0"/>
+                <a:ea typeface="Courier New" pitchFamily="34" charset="-122"/>
+                <a:cs typeface="Courier New" pitchFamily="34" charset="-120"/>
+              </a:rPr>
+              <a:t> 2  </a:t>
             </a:r>
             <a:pPr indent="0" marL="0">
               <a:lnSpc>
@@ -4654,7 +4820,58 @@
             <a:r>
               <a:rPr lang="en-US" sz="1150" dirty="0">
                 <a:solidFill>
-                  <a:srgbClr val="4DB1FF"/>
+                  <a:srgbClr val="CCCCCC"/>
+                </a:solidFill>
+                <a:latin typeface="Courier New" pitchFamily="34" charset="0"/>
+                <a:ea typeface="Courier New" pitchFamily="34" charset="-122"/>
+                <a:cs typeface="Courier New" pitchFamily="34" charset="-120"/>
+              </a:rPr>
+              <a:t>  </a:t>
+            </a:r>
+            <a:pPr indent="0" marL="0">
+              <a:lnSpc>
+                <a:spcPct val="105000"/>
+              </a:lnSpc>
+              <a:buNone/>
+            </a:pPr>
+            <a:r>
+              <a:rPr lang="en-US" sz="1150" dirty="0">
+                <a:solidFill>
+                  <a:srgbClr val="CCCCCC"/>
+                </a:solidFill>
+                <a:latin typeface="Courier New" pitchFamily="34" charset="0"/>
+                <a:ea typeface="Courier New" pitchFamily="34" charset="-122"/>
+                <a:cs typeface="Courier New" pitchFamily="34" charset="-120"/>
+              </a:rPr>
+              <a:t>-</a:t>
+            </a:r>
+            <a:pPr indent="0" marL="0">
+              <a:lnSpc>
+                <a:spcPct val="105000"/>
+              </a:lnSpc>
+              <a:buNone/>
+            </a:pPr>
+            <a:r>
+              <a:rPr lang="en-US" sz="1150" dirty="0">
+                <a:solidFill>
+                  <a:srgbClr val="CCCCCC"/>
+                </a:solidFill>
+                <a:latin typeface="Courier New" pitchFamily="34" charset="0"/>
+                <a:ea typeface="Courier New" pitchFamily="34" charset="-122"/>
+                <a:cs typeface="Courier New" pitchFamily="34" charset="-120"/>
+              </a:rPr>
+              <a:t> </a:t>
+            </a:r>
+            <a:pPr indent="0" marL="0">
+              <a:lnSpc>
+                <a:spcPct val="105000"/>
+              </a:lnSpc>
+              <a:buNone/>
+            </a:pPr>
+            <a:r>
+              <a:rPr lang="en-US" sz="1150" dirty="0">
+                <a:solidFill>
+                  <a:srgbClr val="569CD6"/>
                 </a:solidFill>
                 <a:latin typeface="Courier New" pitchFamily="34" charset="0"/>
                 <a:ea typeface="Courier New" pitchFamily="34" charset="-122"/>
@@ -4671,7 +4888,7 @@
             <a:r>
               <a:rPr lang="en-US" sz="1150" dirty="0">
                 <a:solidFill>
-                  <a:srgbClr val="E8ECEF"/>
+                  <a:srgbClr val="CCCCCC"/>
                 </a:solidFill>
                 <a:latin typeface="Courier New" pitchFamily="34" charset="0"/>
                 <a:ea typeface="Courier New" pitchFamily="34" charset="-122"/>
@@ -4688,7 +4905,7 @@
             <a:r>
               <a:rPr lang="en-US" sz="1150" dirty="0">
                 <a:solidFill>
-                  <a:srgbClr val="E8ECEF"/>
+                  <a:srgbClr val="CCCCCC"/>
                 </a:solidFill>
                 <a:latin typeface="Courier New" pitchFamily="34" charset="0"/>
                 <a:ea typeface="Courier New" pitchFamily="34" charset="-122"/>
@@ -4705,7 +4922,7 @@
             <a:r>
               <a:rPr lang="en-US" sz="1150" dirty="0">
                 <a:solidFill>
-                  <a:srgbClr val="E8ECEF"/>
+                  <a:srgbClr val="CE9178"/>
                 </a:solidFill>
                 <a:latin typeface="Courier New" pitchFamily="34" charset="0"/>
                 <a:ea typeface="Courier New" pitchFamily="34" charset="-122"/>
@@ -4725,7 +4942,24 @@
             <a:r>
               <a:rPr lang="en-US" sz="1150" dirty="0">
                 <a:solidFill>
-                  <a:srgbClr val="E8ECEF"/>
+                  <a:srgbClr val="6E7681"/>
+                </a:solidFill>
+                <a:latin typeface="Courier New" pitchFamily="34" charset="0"/>
+                <a:ea typeface="Courier New" pitchFamily="34" charset="-122"/>
+                <a:cs typeface="Courier New" pitchFamily="34" charset="-120"/>
+              </a:rPr>
+              <a:t> 3  </a:t>
+            </a:r>
+            <a:pPr indent="0" marL="0">
+              <a:lnSpc>
+                <a:spcPct val="105000"/>
+              </a:lnSpc>
+              <a:buNone/>
+            </a:pPr>
+            <a:r>
+              <a:rPr lang="en-US" sz="1150" dirty="0">
+                <a:solidFill>
+                  <a:srgbClr val="CCCCCC"/>
                 </a:solidFill>
                 <a:latin typeface="Courier New" pitchFamily="34" charset="0"/>
                 <a:ea typeface="Courier New" pitchFamily="34" charset="-122"/>
@@ -4742,7 +4976,7 @@
             <a:r>
               <a:rPr lang="en-US" sz="1150" dirty="0">
                 <a:solidFill>
-                  <a:srgbClr val="4DB1FF"/>
+                  <a:srgbClr val="569CD6"/>
                 </a:solidFill>
                 <a:latin typeface="Courier New" pitchFamily="34" charset="0"/>
                 <a:ea typeface="Courier New" pitchFamily="34" charset="-122"/>
@@ -4759,7 +4993,7 @@
             <a:r>
               <a:rPr lang="en-US" sz="1150" dirty="0">
                 <a:solidFill>
-                  <a:srgbClr val="E8ECEF"/>
+                  <a:srgbClr val="CCCCCC"/>
                 </a:solidFill>
                 <a:latin typeface="Courier New" pitchFamily="34" charset="0"/>
                 <a:ea typeface="Courier New" pitchFamily="34" charset="-122"/>
@@ -4776,7 +5010,7 @@
             <a:r>
               <a:rPr lang="en-US" sz="1150" dirty="0">
                 <a:solidFill>
-                  <a:srgbClr val="E8ECEF"/>
+                  <a:srgbClr val="CCCCCC"/>
                 </a:solidFill>
                 <a:latin typeface="Courier New" pitchFamily="34" charset="0"/>
                 <a:ea typeface="Courier New" pitchFamily="34" charset="-122"/>
@@ -4793,7 +5027,7 @@
             <a:r>
               <a:rPr lang="en-US" sz="1150" dirty="0">
                 <a:solidFill>
-                  <a:srgbClr val="E8ECEF"/>
+                  <a:srgbClr val="CE9178"/>
                 </a:solidFill>
                 <a:latin typeface="Courier New" pitchFamily="34" charset="0"/>
                 <a:ea typeface="Courier New" pitchFamily="34" charset="-122"/>
@@ -4813,7 +5047,24 @@
             <a:r>
               <a:rPr lang="en-US" sz="1150" dirty="0">
                 <a:solidFill>
-                  <a:srgbClr val="E8ECEF"/>
+                  <a:srgbClr val="6E7681"/>
+                </a:solidFill>
+                <a:latin typeface="Courier New" pitchFamily="34" charset="0"/>
+                <a:ea typeface="Courier New" pitchFamily="34" charset="-122"/>
+                <a:cs typeface="Courier New" pitchFamily="34" charset="-120"/>
+              </a:rPr>
+              <a:t> 4  </a:t>
+            </a:r>
+            <a:pPr indent="0" marL="0">
+              <a:lnSpc>
+                <a:spcPct val="105000"/>
+              </a:lnSpc>
+              <a:buNone/>
+            </a:pPr>
+            <a:r>
+              <a:rPr lang="en-US" sz="1150" dirty="0">
+                <a:solidFill>
+                  <a:srgbClr val="CCCCCC"/>
                 </a:solidFill>
                 <a:latin typeface="Courier New" pitchFamily="34" charset="0"/>
                 <a:ea typeface="Courier New" pitchFamily="34" charset="-122"/>
@@ -4830,7 +5081,7 @@
             <a:r>
               <a:rPr lang="en-US" sz="1150" dirty="0">
                 <a:solidFill>
-                  <a:srgbClr val="4DB1FF"/>
+                  <a:srgbClr val="569CD6"/>
                 </a:solidFill>
                 <a:latin typeface="Courier New" pitchFamily="34" charset="0"/>
                 <a:ea typeface="Courier New" pitchFamily="34" charset="-122"/>
@@ -4847,7 +5098,7 @@
             <a:r>
               <a:rPr lang="en-US" sz="1150" dirty="0">
                 <a:solidFill>
-                  <a:srgbClr val="E8ECEF"/>
+                  <a:srgbClr val="CCCCCC"/>
                 </a:solidFill>
                 <a:latin typeface="Courier New" pitchFamily="34" charset="0"/>
                 <a:ea typeface="Courier New" pitchFamily="34" charset="-122"/>
@@ -4867,7 +5118,24 @@
             <a:r>
               <a:rPr lang="en-US" sz="1150" dirty="0">
                 <a:solidFill>
-                  <a:srgbClr val="E8ECEF"/>
+                  <a:srgbClr val="6E7681"/>
+                </a:solidFill>
+                <a:latin typeface="Courier New" pitchFamily="34" charset="0"/>
+                <a:ea typeface="Courier New" pitchFamily="34" charset="-122"/>
+                <a:cs typeface="Courier New" pitchFamily="34" charset="-120"/>
+              </a:rPr>
+              <a:t> 5  </a:t>
+            </a:r>
+            <a:pPr indent="0" marL="0">
+              <a:lnSpc>
+                <a:spcPct val="105000"/>
+              </a:lnSpc>
+              <a:buNone/>
+            </a:pPr>
+            <a:r>
+              <a:rPr lang="en-US" sz="1150" dirty="0">
+                <a:solidFill>
+                  <a:srgbClr val="CCCCCC"/>
                 </a:solidFill>
                 <a:latin typeface="Courier New" pitchFamily="34" charset="0"/>
                 <a:ea typeface="Courier New" pitchFamily="34" charset="-122"/>
@@ -4884,7 +5152,7 @@
             <a:r>
               <a:rPr lang="en-US" sz="1150" dirty="0">
                 <a:solidFill>
-                  <a:srgbClr val="4DB1FF"/>
+                  <a:srgbClr val="569CD6"/>
                 </a:solidFill>
                 <a:latin typeface="Courier New" pitchFamily="34" charset="0"/>
                 <a:ea typeface="Courier New" pitchFamily="34" charset="-122"/>
@@ -4901,7 +5169,7 @@
             <a:r>
               <a:rPr lang="en-US" sz="1150" dirty="0">
                 <a:solidFill>
-                  <a:srgbClr val="E8ECEF"/>
+                  <a:srgbClr val="CCCCCC"/>
                 </a:solidFill>
                 <a:latin typeface="Courier New" pitchFamily="34" charset="0"/>
                 <a:ea typeface="Courier New" pitchFamily="34" charset="-122"/>
@@ -4921,7 +5189,24 @@
             <a:r>
               <a:rPr lang="en-US" sz="1150" dirty="0">
                 <a:solidFill>
-                  <a:srgbClr val="E8ECEF"/>
+                  <a:srgbClr val="6E7681"/>
+                </a:solidFill>
+                <a:latin typeface="Courier New" pitchFamily="34" charset="0"/>
+                <a:ea typeface="Courier New" pitchFamily="34" charset="-122"/>
+                <a:cs typeface="Courier New" pitchFamily="34" charset="-120"/>
+              </a:rPr>
+              <a:t> 6  </a:t>
+            </a:r>
+            <a:pPr indent="0" marL="0">
+              <a:lnSpc>
+                <a:spcPct val="105000"/>
+              </a:lnSpc>
+              <a:buNone/>
+            </a:pPr>
+            <a:r>
+              <a:rPr lang="en-US" sz="1150" dirty="0">
+                <a:solidFill>
+                  <a:srgbClr val="CCCCCC"/>
                 </a:solidFill>
                 <a:latin typeface="Courier New" pitchFamily="34" charset="0"/>
                 <a:ea typeface="Courier New" pitchFamily="34" charset="-122"/>
@@ -4938,7 +5223,7 @@
             <a:r>
               <a:rPr lang="en-US" sz="1150" dirty="0">
                 <a:solidFill>
-                  <a:srgbClr val="4DB1FF"/>
+                  <a:srgbClr val="569CD6"/>
                 </a:solidFill>
                 <a:latin typeface="Courier New" pitchFamily="34" charset="0"/>
                 <a:ea typeface="Courier New" pitchFamily="34" charset="-122"/>
@@ -4955,7 +5240,7 @@
             <a:r>
               <a:rPr lang="en-US" sz="1150" dirty="0">
                 <a:solidFill>
-                  <a:srgbClr val="E8ECEF"/>
+                  <a:srgbClr val="CCCCCC"/>
                 </a:solidFill>
                 <a:latin typeface="Courier New" pitchFamily="34" charset="0"/>
                 <a:ea typeface="Courier New" pitchFamily="34" charset="-122"/>
@@ -4972,7 +5257,7 @@
             <a:r>
               <a:rPr lang="en-US" sz="1150" dirty="0">
                 <a:solidFill>
-                  <a:srgbClr val="E8ECEF"/>
+                  <a:srgbClr val="CCCCCC"/>
                 </a:solidFill>
                 <a:latin typeface="Courier New" pitchFamily="34" charset="0"/>
                 <a:ea typeface="Courier New" pitchFamily="34" charset="-122"/>
@@ -4989,14 +5274,17 @@
             <a:r>
               <a:rPr lang="en-US" sz="1150" dirty="0">
                 <a:solidFill>
-                  <a:srgbClr val="4DB1FF"/>
-                </a:solidFill>
-                <a:latin typeface="Courier New" pitchFamily="34" charset="0"/>
-                <a:ea typeface="Courier New" pitchFamily="34" charset="-122"/>
-                <a:cs typeface="Courier New" pitchFamily="34" charset="-120"/>
-              </a:rPr>
-              <a:t>https</a:t>
-            </a:r>
+                  <a:srgbClr val="CE9178"/>
+                </a:solidFill>
+                <a:latin typeface="Courier New" pitchFamily="34" charset="0"/>
+                <a:ea typeface="Courier New" pitchFamily="34" charset="-122"/>
+                <a:cs typeface="Courier New" pitchFamily="34" charset="-120"/>
+              </a:rPr>
+              <a:t>https://&lt;id&gt;.abap.us10.hana.ondemand.com</a:t>
+            </a:r>
+            <a:endParaRPr lang="en-US" sz="1150" dirty="0"/>
+          </a:p>
+          <a:p>
             <a:pPr indent="0" marL="0">
               <a:lnSpc>
                 <a:spcPct val="105000"/>
@@ -5006,7 +5294,58 @@
             <a:r>
               <a:rPr lang="en-US" sz="1150" dirty="0">
                 <a:solidFill>
-                  <a:srgbClr val="E8ECEF"/>
+                  <a:srgbClr val="6E7681"/>
+                </a:solidFill>
+                <a:latin typeface="Courier New" pitchFamily="34" charset="0"/>
+                <a:ea typeface="Courier New" pitchFamily="34" charset="-122"/>
+                <a:cs typeface="Courier New" pitchFamily="34" charset="-120"/>
+              </a:rPr>
+              <a:t> 7  </a:t>
+            </a:r>
+            <a:pPr indent="0" marL="0">
+              <a:lnSpc>
+                <a:spcPct val="105000"/>
+              </a:lnSpc>
+              <a:buNone/>
+            </a:pPr>
+            <a:r>
+              <a:rPr lang="en-US" sz="1150" dirty="0">
+                <a:solidFill>
+                  <a:srgbClr val="CCCCCC"/>
+                </a:solidFill>
+                <a:latin typeface="Courier New" pitchFamily="34" charset="0"/>
+                <a:ea typeface="Courier New" pitchFamily="34" charset="-122"/>
+                <a:cs typeface="Courier New" pitchFamily="34" charset="-120"/>
+              </a:rPr>
+              <a:t>        </a:t>
+            </a:r>
+            <a:pPr indent="0" marL="0">
+              <a:lnSpc>
+                <a:spcPct val="105000"/>
+              </a:lnSpc>
+              <a:buNone/>
+            </a:pPr>
+            <a:r>
+              <a:rPr lang="en-US" sz="1150" dirty="0">
+                <a:solidFill>
+                  <a:srgbClr val="569CD6"/>
+                </a:solidFill>
+                <a:latin typeface="Courier New" pitchFamily="34" charset="0"/>
+                <a:ea typeface="Courier New" pitchFamily="34" charset="-122"/>
+                <a:cs typeface="Courier New" pitchFamily="34" charset="-120"/>
+              </a:rPr>
+              <a:t>client</a:t>
+            </a:r>
+            <a:pPr indent="0" marL="0">
+              <a:lnSpc>
+                <a:spcPct val="105000"/>
+              </a:lnSpc>
+              <a:buNone/>
+            </a:pPr>
+            <a:r>
+              <a:rPr lang="en-US" sz="1150" dirty="0">
+                <a:solidFill>
+                  <a:srgbClr val="CCCCCC"/>
                 </a:solidFill>
                 <a:latin typeface="Courier New" pitchFamily="34" charset="0"/>
                 <a:ea typeface="Courier New" pitchFamily="34" charset="-122"/>
@@ -5021,15 +5360,32 @@
               <a:buNone/>
             </a:pPr>
             <a:r>
-              <a:rPr lang="en-US" sz="1150" i="1" dirty="0">
-                <a:solidFill>
-                  <a:srgbClr val="8396A8"/>
-                </a:solidFill>
-                <a:latin typeface="Courier New" pitchFamily="34" charset="0"/>
-                <a:ea typeface="Courier New" pitchFamily="34" charset="-122"/>
-                <a:cs typeface="Courier New" pitchFamily="34" charset="-120"/>
-              </a:rPr>
-              <a:t>//&lt;id&gt;.abap.us10.hana.ondemand.com</a:t>
+              <a:rPr lang="en-US" sz="1150" dirty="0">
+                <a:solidFill>
+                  <a:srgbClr val="CCCCCC"/>
+                </a:solidFill>
+                <a:latin typeface="Courier New" pitchFamily="34" charset="0"/>
+                <a:ea typeface="Courier New" pitchFamily="34" charset="-122"/>
+                <a:cs typeface="Courier New" pitchFamily="34" charset="-120"/>
+              </a:rPr>
+              <a:t> </a:t>
+            </a:r>
+            <a:pPr indent="0" marL="0">
+              <a:lnSpc>
+                <a:spcPct val="105000"/>
+              </a:lnSpc>
+              <a:buNone/>
+            </a:pPr>
+            <a:r>
+              <a:rPr lang="en-US" sz="1150" dirty="0">
+                <a:solidFill>
+                  <a:srgbClr val="CE9178"/>
+                </a:solidFill>
+                <a:latin typeface="Courier New" pitchFamily="34" charset="0"/>
+                <a:ea typeface="Courier New" pitchFamily="34" charset="-122"/>
+                <a:cs typeface="Courier New" pitchFamily="34" charset="-120"/>
+              </a:rPr>
+              <a:t>"100"</a:t>
             </a:r>
             <a:endParaRPr lang="en-US" sz="1150" dirty="0"/>
           </a:p>
@@ -5043,7 +5399,24 @@
             <a:r>
               <a:rPr lang="en-US" sz="1150" dirty="0">
                 <a:solidFill>
-                  <a:srgbClr val="E8ECEF"/>
+                  <a:srgbClr val="6E7681"/>
+                </a:solidFill>
+                <a:latin typeface="Courier New" pitchFamily="34" charset="0"/>
+                <a:ea typeface="Courier New" pitchFamily="34" charset="-122"/>
+                <a:cs typeface="Courier New" pitchFamily="34" charset="-120"/>
+              </a:rPr>
+              <a:t> 8  </a:t>
+            </a:r>
+            <a:pPr indent="0" marL="0">
+              <a:lnSpc>
+                <a:spcPct val="105000"/>
+              </a:lnSpc>
+              <a:buNone/>
+            </a:pPr>
+            <a:r>
+              <a:rPr lang="en-US" sz="1150" dirty="0">
+                <a:solidFill>
+                  <a:srgbClr val="CCCCCC"/>
                 </a:solidFill>
                 <a:latin typeface="Courier New" pitchFamily="34" charset="0"/>
                 <a:ea typeface="Courier New" pitchFamily="34" charset="-122"/>
@@ -5060,13 +5433,13 @@
             <a:r>
               <a:rPr lang="en-US" sz="1150" dirty="0">
                 <a:solidFill>
-                  <a:srgbClr val="4DB1FF"/>
-                </a:solidFill>
-                <a:latin typeface="Courier New" pitchFamily="34" charset="0"/>
-                <a:ea typeface="Courier New" pitchFamily="34" charset="-122"/>
-                <a:cs typeface="Courier New" pitchFamily="34" charset="-120"/>
-              </a:rPr>
-              <a:t>client</a:t>
+                  <a:srgbClr val="569CD6"/>
+                </a:solidFill>
+                <a:latin typeface="Courier New" pitchFamily="34" charset="0"/>
+                <a:ea typeface="Courier New" pitchFamily="34" charset="-122"/>
+                <a:cs typeface="Courier New" pitchFamily="34" charset="-120"/>
+              </a:rPr>
+              <a:t>authenticationType</a:t>
             </a:r>
             <a:pPr indent="0" marL="0">
               <a:lnSpc>
@@ -5077,7 +5450,7 @@
             <a:r>
               <a:rPr lang="en-US" sz="1150" dirty="0">
                 <a:solidFill>
-                  <a:srgbClr val="E8ECEF"/>
+                  <a:srgbClr val="CCCCCC"/>
                 </a:solidFill>
                 <a:latin typeface="Courier New" pitchFamily="34" charset="0"/>
                 <a:ea typeface="Courier New" pitchFamily="34" charset="-122"/>
@@ -5094,7 +5467,7 @@
             <a:r>
               <a:rPr lang="en-US" sz="1150" dirty="0">
                 <a:solidFill>
-                  <a:srgbClr val="E8ECEF"/>
+                  <a:srgbClr val="CCCCCC"/>
                 </a:solidFill>
                 <a:latin typeface="Courier New" pitchFamily="34" charset="0"/>
                 <a:ea typeface="Courier New" pitchFamily="34" charset="-122"/>
@@ -5111,13 +5484,13 @@
             <a:r>
               <a:rPr lang="en-US" sz="1150" dirty="0">
                 <a:solidFill>
-                  <a:srgbClr val="8FD694"/>
-                </a:solidFill>
-                <a:latin typeface="Courier New" pitchFamily="34" charset="0"/>
-                <a:ea typeface="Courier New" pitchFamily="34" charset="-122"/>
-                <a:cs typeface="Courier New" pitchFamily="34" charset="-120"/>
-              </a:rPr>
-              <a:t>"100"</a:t>
+                  <a:srgbClr val="CE9178"/>
+                </a:solidFill>
+                <a:latin typeface="Courier New" pitchFamily="34" charset="0"/>
+                <a:ea typeface="Courier New" pitchFamily="34" charset="-122"/>
+                <a:cs typeface="Courier New" pitchFamily="34" charset="-120"/>
+              </a:rPr>
+              <a:t>reentranceTicket</a:t>
             </a:r>
             <a:endParaRPr lang="en-US" sz="1150" dirty="0"/>
           </a:p>
@@ -5131,7 +5504,95 @@
             <a:r>
               <a:rPr lang="en-US" sz="1150" dirty="0">
                 <a:solidFill>
-                  <a:srgbClr val="E8ECEF"/>
+                  <a:srgbClr val="6E7681"/>
+                </a:solidFill>
+                <a:latin typeface="Courier New" pitchFamily="34" charset="0"/>
+                <a:ea typeface="Courier New" pitchFamily="34" charset="-122"/>
+                <a:cs typeface="Courier New" pitchFamily="34" charset="-120"/>
+              </a:rPr>
+              <a:t> 9  </a:t>
+            </a:r>
+            <a:pPr indent="0" marL="0">
+              <a:lnSpc>
+                <a:spcPct val="105000"/>
+              </a:lnSpc>
+              <a:buNone/>
+            </a:pPr>
+            <a:r>
+              <a:rPr lang="en-US" sz="1150" dirty="0">
+                <a:solidFill>
+                  <a:srgbClr val="CCCCCC"/>
+                </a:solidFill>
+                <a:latin typeface="Courier New" pitchFamily="34" charset="0"/>
+                <a:ea typeface="Courier New" pitchFamily="34" charset="-122"/>
+                <a:cs typeface="Courier New" pitchFamily="34" charset="-120"/>
+              </a:rPr>
+              <a:t>      </a:t>
+            </a:r>
+            <a:pPr indent="0" marL="0">
+              <a:lnSpc>
+                <a:spcPct val="105000"/>
+              </a:lnSpc>
+              <a:buNone/>
+            </a:pPr>
+            <a:r>
+              <a:rPr lang="en-US" sz="1150" dirty="0">
+                <a:solidFill>
+                  <a:srgbClr val="569CD6"/>
+                </a:solidFill>
+                <a:latin typeface="Courier New" pitchFamily="34" charset="0"/>
+                <a:ea typeface="Courier New" pitchFamily="34" charset="-122"/>
+                <a:cs typeface="Courier New" pitchFamily="34" charset="-120"/>
+              </a:rPr>
+              <a:t>app</a:t>
+            </a:r>
+            <a:pPr indent="0" marL="0">
+              <a:lnSpc>
+                <a:spcPct val="105000"/>
+              </a:lnSpc>
+              <a:buNone/>
+            </a:pPr>
+            <a:r>
+              <a:rPr lang="en-US" sz="1150" dirty="0">
+                <a:solidFill>
+                  <a:srgbClr val="CCCCCC"/>
+                </a:solidFill>
+                <a:latin typeface="Courier New" pitchFamily="34" charset="0"/>
+                <a:ea typeface="Courier New" pitchFamily="34" charset="-122"/>
+                <a:cs typeface="Courier New" pitchFamily="34" charset="-120"/>
+              </a:rPr>
+              <a:t>:</a:t>
+            </a:r>
+            <a:endParaRPr lang="en-US" sz="1150" dirty="0"/>
+          </a:p>
+          <a:p>
+            <a:pPr indent="0" marL="0">
+              <a:lnSpc>
+                <a:spcPct val="105000"/>
+              </a:lnSpc>
+              <a:buNone/>
+            </a:pPr>
+            <a:r>
+              <a:rPr lang="en-US" sz="1150" dirty="0">
+                <a:solidFill>
+                  <a:srgbClr val="6E7681"/>
+                </a:solidFill>
+                <a:latin typeface="Courier New" pitchFamily="34" charset="0"/>
+                <a:ea typeface="Courier New" pitchFamily="34" charset="-122"/>
+                <a:cs typeface="Courier New" pitchFamily="34" charset="-120"/>
+              </a:rPr>
+              <a:t>10  </a:t>
+            </a:r>
+            <a:pPr indent="0" marL="0">
+              <a:lnSpc>
+                <a:spcPct val="105000"/>
+              </a:lnSpc>
+              <a:buNone/>
+            </a:pPr>
+            <a:r>
+              <a:rPr lang="en-US" sz="1150" dirty="0">
+                <a:solidFill>
+                  <a:srgbClr val="CCCCCC"/>
                 </a:solidFill>
                 <a:latin typeface="Courier New" pitchFamily="34" charset="0"/>
                 <a:ea typeface="Courier New" pitchFamily="34" charset="-122"/>
@@ -5148,13 +5609,13 @@
             <a:r>
               <a:rPr lang="en-US" sz="1150" dirty="0">
                 <a:solidFill>
-                  <a:srgbClr val="4DB1FF"/>
-                </a:solidFill>
-                <a:latin typeface="Courier New" pitchFamily="34" charset="0"/>
-                <a:ea typeface="Courier New" pitchFamily="34" charset="-122"/>
-                <a:cs typeface="Courier New" pitchFamily="34" charset="-120"/>
-              </a:rPr>
-              <a:t>authenticationType</a:t>
+                  <a:srgbClr val="569CD6"/>
+                </a:solidFill>
+                <a:latin typeface="Courier New" pitchFamily="34" charset="0"/>
+                <a:ea typeface="Courier New" pitchFamily="34" charset="-122"/>
+                <a:cs typeface="Courier New" pitchFamily="34" charset="-120"/>
+              </a:rPr>
+              <a:t>name</a:t>
             </a:r>
             <a:pPr indent="0" marL="0">
               <a:lnSpc>
@@ -5165,7 +5626,7 @@
             <a:r>
               <a:rPr lang="en-US" sz="1150" dirty="0">
                 <a:solidFill>
-                  <a:srgbClr val="E8ECEF"/>
+                  <a:srgbClr val="CCCCCC"/>
                 </a:solidFill>
                 <a:latin typeface="Courier New" pitchFamily="34" charset="0"/>
                 <a:ea typeface="Courier New" pitchFamily="34" charset="-122"/>
@@ -5182,7 +5643,7 @@
             <a:r>
               <a:rPr lang="en-US" sz="1150" dirty="0">
                 <a:solidFill>
-                  <a:srgbClr val="E8ECEF"/>
+                  <a:srgbClr val="CCCCCC"/>
                 </a:solidFill>
                 <a:latin typeface="Courier New" pitchFamily="34" charset="0"/>
                 <a:ea typeface="Courier New" pitchFamily="34" charset="-122"/>
@@ -5199,13 +5660,13 @@
             <a:r>
               <a:rPr lang="en-US" sz="1150" dirty="0">
                 <a:solidFill>
-                  <a:srgbClr val="E8ECEF"/>
-                </a:solidFill>
-                <a:latin typeface="Courier New" pitchFamily="34" charset="0"/>
-                <a:ea typeface="Courier New" pitchFamily="34" charset="-122"/>
-                <a:cs typeface="Courier New" pitchFamily="34" charset="-120"/>
-              </a:rPr>
-              <a:t>reentranceTicket</a:t>
+                  <a:srgbClr val="CE9178"/>
+                </a:solidFill>
+                <a:latin typeface="Courier New" pitchFamily="34" charset="0"/>
+                <a:ea typeface="Courier New" pitchFamily="34" charset="-122"/>
+                <a:cs typeface="Courier New" pitchFamily="34" charset="-120"/>
+              </a:rPr>
+              <a:t>ZPC_PEDIDOS</a:t>
             </a:r>
             <a:endParaRPr lang="en-US" sz="1150" dirty="0"/>
           </a:p>
@@ -5219,13 +5680,13 @@
             <a:r>
               <a:rPr lang="en-US" sz="1150" dirty="0">
                 <a:solidFill>
-                  <a:srgbClr val="E8ECEF"/>
-                </a:solidFill>
-                <a:latin typeface="Courier New" pitchFamily="34" charset="0"/>
-                <a:ea typeface="Courier New" pitchFamily="34" charset="-122"/>
-                <a:cs typeface="Courier New" pitchFamily="34" charset="-120"/>
-              </a:rPr>
-              <a:t>      </a:t>
+                  <a:srgbClr val="6E7681"/>
+                </a:solidFill>
+                <a:latin typeface="Courier New" pitchFamily="34" charset="0"/>
+                <a:ea typeface="Courier New" pitchFamily="34" charset="-122"/>
+                <a:cs typeface="Courier New" pitchFamily="34" charset="-120"/>
+              </a:rPr>
+              <a:t>11  </a:t>
             </a:r>
             <a:pPr indent="0" marL="0">
               <a:lnSpc>
@@ -5236,13 +5697,13 @@
             <a:r>
               <a:rPr lang="en-US" sz="1150" dirty="0">
                 <a:solidFill>
-                  <a:srgbClr val="4DB1FF"/>
-                </a:solidFill>
-                <a:latin typeface="Courier New" pitchFamily="34" charset="0"/>
-                <a:ea typeface="Courier New" pitchFamily="34" charset="-122"/>
-                <a:cs typeface="Courier New" pitchFamily="34" charset="-120"/>
-              </a:rPr>
-              <a:t>app</a:t>
+                  <a:srgbClr val="CCCCCC"/>
+                </a:solidFill>
+                <a:latin typeface="Courier New" pitchFamily="34" charset="0"/>
+                <a:ea typeface="Courier New" pitchFamily="34" charset="-122"/>
+                <a:cs typeface="Courier New" pitchFamily="34" charset="-120"/>
+              </a:rPr>
+              <a:t>        </a:t>
             </a:r>
             <a:pPr indent="0" marL="0">
               <a:lnSpc>
@@ -5253,7 +5714,24 @@
             <a:r>
               <a:rPr lang="en-US" sz="1150" dirty="0">
                 <a:solidFill>
-                  <a:srgbClr val="E8ECEF"/>
+                  <a:srgbClr val="569CD6"/>
+                </a:solidFill>
+                <a:latin typeface="Courier New" pitchFamily="34" charset="0"/>
+                <a:ea typeface="Courier New" pitchFamily="34" charset="-122"/>
+                <a:cs typeface="Courier New" pitchFamily="34" charset="-120"/>
+              </a:rPr>
+              <a:t>description</a:t>
+            </a:r>
+            <a:pPr indent="0" marL="0">
+              <a:lnSpc>
+                <a:spcPct val="105000"/>
+              </a:lnSpc>
+              <a:buNone/>
+            </a:pPr>
+            <a:r>
+              <a:rPr lang="en-US" sz="1150" dirty="0">
+                <a:solidFill>
+                  <a:srgbClr val="CCCCCC"/>
                 </a:solidFill>
                 <a:latin typeface="Courier New" pitchFamily="34" charset="0"/>
                 <a:ea typeface="Courier New" pitchFamily="34" charset="-122"/>
@@ -5261,6 +5739,40 @@
               </a:rPr>
               <a:t>:</a:t>
             </a:r>
+            <a:pPr indent="0" marL="0">
+              <a:lnSpc>
+                <a:spcPct val="105000"/>
+              </a:lnSpc>
+              <a:buNone/>
+            </a:pPr>
+            <a:r>
+              <a:rPr lang="en-US" sz="1150" dirty="0">
+                <a:solidFill>
+                  <a:srgbClr val="CCCCCC"/>
+                </a:solidFill>
+                <a:latin typeface="Courier New" pitchFamily="34" charset="0"/>
+                <a:ea typeface="Courier New" pitchFamily="34" charset="-122"/>
+                <a:cs typeface="Courier New" pitchFamily="34" charset="-120"/>
+              </a:rPr>
+              <a:t> </a:t>
+            </a:r>
+            <a:pPr indent="0" marL="0">
+              <a:lnSpc>
+                <a:spcPct val="105000"/>
+              </a:lnSpc>
+              <a:buNone/>
+            </a:pPr>
+            <a:r>
+              <a:rPr lang="en-US" sz="1150" dirty="0">
+                <a:solidFill>
+                  <a:srgbClr val="CE9178"/>
+                </a:solidFill>
+                <a:latin typeface="Courier New" pitchFamily="34" charset="0"/>
+                <a:ea typeface="Courier New" pitchFamily="34" charset="-122"/>
+                <a:cs typeface="Courier New" pitchFamily="34" charset="-120"/>
+              </a:rPr>
+              <a:t>Pedidos de Compras</a:t>
+            </a:r>
             <a:endParaRPr lang="en-US" sz="1150" dirty="0"/>
           </a:p>
           <a:p>
@@ -5273,7 +5785,24 @@
             <a:r>
               <a:rPr lang="en-US" sz="1150" dirty="0">
                 <a:solidFill>
-                  <a:srgbClr val="E8ECEF"/>
+                  <a:srgbClr val="6E7681"/>
+                </a:solidFill>
+                <a:latin typeface="Courier New" pitchFamily="34" charset="0"/>
+                <a:ea typeface="Courier New" pitchFamily="34" charset="-122"/>
+                <a:cs typeface="Courier New" pitchFamily="34" charset="-120"/>
+              </a:rPr>
+              <a:t>12  </a:t>
+            </a:r>
+            <a:pPr indent="0" marL="0">
+              <a:lnSpc>
+                <a:spcPct val="105000"/>
+              </a:lnSpc>
+              <a:buNone/>
+            </a:pPr>
+            <a:r>
+              <a:rPr lang="en-US" sz="1150" dirty="0">
+                <a:solidFill>
+                  <a:srgbClr val="CCCCCC"/>
                 </a:solidFill>
                 <a:latin typeface="Courier New" pitchFamily="34" charset="0"/>
                 <a:ea typeface="Courier New" pitchFamily="34" charset="-122"/>
@@ -5290,13 +5819,13 @@
             <a:r>
               <a:rPr lang="en-US" sz="1150" dirty="0">
                 <a:solidFill>
-                  <a:srgbClr val="4DB1FF"/>
-                </a:solidFill>
-                <a:latin typeface="Courier New" pitchFamily="34" charset="0"/>
-                <a:ea typeface="Courier New" pitchFamily="34" charset="-122"/>
-                <a:cs typeface="Courier New" pitchFamily="34" charset="-120"/>
-              </a:rPr>
-              <a:t>name</a:t>
+                  <a:srgbClr val="569CD6"/>
+                </a:solidFill>
+                <a:latin typeface="Courier New" pitchFamily="34" charset="0"/>
+                <a:ea typeface="Courier New" pitchFamily="34" charset="-122"/>
+                <a:cs typeface="Courier New" pitchFamily="34" charset="-120"/>
+              </a:rPr>
+              <a:t>package</a:t>
             </a:r>
             <a:pPr indent="0" marL="0">
               <a:lnSpc>
@@ -5307,7 +5836,7 @@
             <a:r>
               <a:rPr lang="en-US" sz="1150" dirty="0">
                 <a:solidFill>
-                  <a:srgbClr val="E8ECEF"/>
+                  <a:srgbClr val="CCCCCC"/>
                 </a:solidFill>
                 <a:latin typeface="Courier New" pitchFamily="34" charset="0"/>
                 <a:ea typeface="Courier New" pitchFamily="34" charset="-122"/>
@@ -5324,7 +5853,7 @@
             <a:r>
               <a:rPr lang="en-US" sz="1150" dirty="0">
                 <a:solidFill>
-                  <a:srgbClr val="E8ECEF"/>
+                  <a:srgbClr val="CCCCCC"/>
                 </a:solidFill>
                 <a:latin typeface="Courier New" pitchFamily="34" charset="0"/>
                 <a:ea typeface="Courier New" pitchFamily="34" charset="-122"/>
@@ -5341,13 +5870,13 @@
             <a:r>
               <a:rPr lang="en-US" sz="1150" dirty="0">
                 <a:solidFill>
-                  <a:srgbClr val="E8ECEF"/>
-                </a:solidFill>
-                <a:latin typeface="Courier New" pitchFamily="34" charset="0"/>
-                <a:ea typeface="Courier New" pitchFamily="34" charset="-122"/>
-                <a:cs typeface="Courier New" pitchFamily="34" charset="-120"/>
-              </a:rPr>
-              <a:t>ZPC_PEDIDOS</a:t>
+                  <a:srgbClr val="CE9178"/>
+                </a:solidFill>
+                <a:latin typeface="Courier New" pitchFamily="34" charset="0"/>
+                <a:ea typeface="Courier New" pitchFamily="34" charset="-122"/>
+                <a:cs typeface="Courier New" pitchFamily="34" charset="-120"/>
+              </a:rPr>
+              <a:t>ZAVBS_PC_PEDIDOS</a:t>
             </a:r>
             <a:endParaRPr lang="en-US" sz="1150" dirty="0"/>
           </a:p>
@@ -5361,7 +5890,24 @@
             <a:r>
               <a:rPr lang="en-US" sz="1150" dirty="0">
                 <a:solidFill>
-                  <a:srgbClr val="E8ECEF"/>
+                  <a:srgbClr val="6E7681"/>
+                </a:solidFill>
+                <a:latin typeface="Courier New" pitchFamily="34" charset="0"/>
+                <a:ea typeface="Courier New" pitchFamily="34" charset="-122"/>
+                <a:cs typeface="Courier New" pitchFamily="34" charset="-120"/>
+              </a:rPr>
+              <a:t>13  </a:t>
+            </a:r>
+            <a:pPr indent="0" marL="0">
+              <a:lnSpc>
+                <a:spcPct val="105000"/>
+              </a:lnSpc>
+              <a:buNone/>
+            </a:pPr>
+            <a:r>
+              <a:rPr lang="en-US" sz="1150" dirty="0">
+                <a:solidFill>
+                  <a:srgbClr val="CCCCCC"/>
                 </a:solidFill>
                 <a:latin typeface="Courier New" pitchFamily="34" charset="0"/>
                 <a:ea typeface="Courier New" pitchFamily="34" charset="-122"/>
@@ -5378,13 +5924,13 @@
             <a:r>
               <a:rPr lang="en-US" sz="1150" dirty="0">
                 <a:solidFill>
-                  <a:srgbClr val="4DB1FF"/>
-                </a:solidFill>
-                <a:latin typeface="Courier New" pitchFamily="34" charset="0"/>
-                <a:ea typeface="Courier New" pitchFamily="34" charset="-122"/>
-                <a:cs typeface="Courier New" pitchFamily="34" charset="-120"/>
-              </a:rPr>
-              <a:t>description</a:t>
+                  <a:srgbClr val="569CD6"/>
+                </a:solidFill>
+                <a:latin typeface="Courier New" pitchFamily="34" charset="0"/>
+                <a:ea typeface="Courier New" pitchFamily="34" charset="-122"/>
+                <a:cs typeface="Courier New" pitchFamily="34" charset="-120"/>
+              </a:rPr>
+              <a:t>transport</a:t>
             </a:r>
             <a:pPr indent="0" marL="0">
               <a:lnSpc>
@@ -5395,7 +5941,7 @@
             <a:r>
               <a:rPr lang="en-US" sz="1150" dirty="0">
                 <a:solidFill>
-                  <a:srgbClr val="E8ECEF"/>
+                  <a:srgbClr val="CCCCCC"/>
                 </a:solidFill>
                 <a:latin typeface="Courier New" pitchFamily="34" charset="0"/>
                 <a:ea typeface="Courier New" pitchFamily="34" charset="-122"/>
@@ -5412,7 +5958,7 @@
             <a:r>
               <a:rPr lang="en-US" sz="1150" dirty="0">
                 <a:solidFill>
-                  <a:srgbClr val="E8ECEF"/>
+                  <a:srgbClr val="CCCCCC"/>
                 </a:solidFill>
                 <a:latin typeface="Courier New" pitchFamily="34" charset="0"/>
                 <a:ea typeface="Courier New" pitchFamily="34" charset="-122"/>
@@ -5429,265 +5975,21 @@
             <a:r>
               <a:rPr lang="en-US" sz="1150" dirty="0">
                 <a:solidFill>
-                  <a:srgbClr val="E8ECEF"/>
-                </a:solidFill>
-                <a:latin typeface="Courier New" pitchFamily="34" charset="0"/>
-                <a:ea typeface="Courier New" pitchFamily="34" charset="-122"/>
-                <a:cs typeface="Courier New" pitchFamily="34" charset="-120"/>
-              </a:rPr>
-              <a:t>Pedidos</a:t>
-            </a:r>
-            <a:pPr indent="0" marL="0">
-              <a:lnSpc>
-                <a:spcPct val="105000"/>
-              </a:lnSpc>
-              <a:buNone/>
-            </a:pPr>
-            <a:r>
-              <a:rPr lang="en-US" sz="1150" dirty="0">
-                <a:solidFill>
-                  <a:srgbClr val="E8ECEF"/>
-                </a:solidFill>
-                <a:latin typeface="Courier New" pitchFamily="34" charset="0"/>
-                <a:ea typeface="Courier New" pitchFamily="34" charset="-122"/>
-                <a:cs typeface="Courier New" pitchFamily="34" charset="-120"/>
-              </a:rPr>
-              <a:t> </a:t>
-            </a:r>
-            <a:pPr indent="0" marL="0">
-              <a:lnSpc>
-                <a:spcPct val="105000"/>
-              </a:lnSpc>
-              <a:buNone/>
-            </a:pPr>
-            <a:r>
-              <a:rPr lang="en-US" sz="1150" dirty="0">
-                <a:solidFill>
-                  <a:srgbClr val="E8ECEF"/>
-                </a:solidFill>
-                <a:latin typeface="Courier New" pitchFamily="34" charset="0"/>
-                <a:ea typeface="Courier New" pitchFamily="34" charset="-122"/>
-                <a:cs typeface="Courier New" pitchFamily="34" charset="-120"/>
-              </a:rPr>
-              <a:t>de</a:t>
-            </a:r>
-            <a:pPr indent="0" marL="0">
-              <a:lnSpc>
-                <a:spcPct val="105000"/>
-              </a:lnSpc>
-              <a:buNone/>
-            </a:pPr>
-            <a:r>
-              <a:rPr lang="en-US" sz="1150" dirty="0">
-                <a:solidFill>
-                  <a:srgbClr val="E8ECEF"/>
-                </a:solidFill>
-                <a:latin typeface="Courier New" pitchFamily="34" charset="0"/>
-                <a:ea typeface="Courier New" pitchFamily="34" charset="-122"/>
-                <a:cs typeface="Courier New" pitchFamily="34" charset="-120"/>
-              </a:rPr>
-              <a:t> </a:t>
-            </a:r>
-            <a:pPr indent="0" marL="0">
-              <a:lnSpc>
-                <a:spcPct val="105000"/>
-              </a:lnSpc>
-              <a:buNone/>
-            </a:pPr>
-            <a:r>
-              <a:rPr lang="en-US" sz="1150" dirty="0">
-                <a:solidFill>
-                  <a:srgbClr val="E8ECEF"/>
-                </a:solidFill>
-                <a:latin typeface="Courier New" pitchFamily="34" charset="0"/>
-                <a:ea typeface="Courier New" pitchFamily="34" charset="-122"/>
-                <a:cs typeface="Courier New" pitchFamily="34" charset="-120"/>
-              </a:rPr>
-              <a:t>Compras</a:t>
+                  <a:srgbClr val="CE9178"/>
+                </a:solidFill>
+                <a:latin typeface="Courier New" pitchFamily="34" charset="0"/>
+                <a:ea typeface="Courier New" pitchFamily="34" charset="-122"/>
+                <a:cs typeface="Courier New" pitchFamily="34" charset="-120"/>
+              </a:rPr>
+              <a:t>""</a:t>
             </a:r>
             <a:endParaRPr lang="en-US" sz="1150" dirty="0"/>
           </a:p>
-          <a:p>
-            <a:pPr indent="0" marL="0">
-              <a:lnSpc>
-                <a:spcPct val="105000"/>
-              </a:lnSpc>
-              <a:buNone/>
-            </a:pPr>
-            <a:r>
-              <a:rPr lang="en-US" sz="1150" dirty="0">
-                <a:solidFill>
-                  <a:srgbClr val="E8ECEF"/>
-                </a:solidFill>
-                <a:latin typeface="Courier New" pitchFamily="34" charset="0"/>
-                <a:ea typeface="Courier New" pitchFamily="34" charset="-122"/>
-                <a:cs typeface="Courier New" pitchFamily="34" charset="-120"/>
-              </a:rPr>
-              <a:t>        </a:t>
-            </a:r>
-            <a:pPr indent="0" marL="0">
-              <a:lnSpc>
-                <a:spcPct val="105000"/>
-              </a:lnSpc>
-              <a:buNone/>
-            </a:pPr>
-            <a:r>
-              <a:rPr lang="en-US" sz="1150" dirty="0">
-                <a:solidFill>
-                  <a:srgbClr val="4DB1FF"/>
-                </a:solidFill>
-                <a:latin typeface="Courier New" pitchFamily="34" charset="0"/>
-                <a:ea typeface="Courier New" pitchFamily="34" charset="-122"/>
-                <a:cs typeface="Courier New" pitchFamily="34" charset="-120"/>
-              </a:rPr>
-              <a:t>package</a:t>
-            </a:r>
-            <a:pPr indent="0" marL="0">
-              <a:lnSpc>
-                <a:spcPct val="105000"/>
-              </a:lnSpc>
-              <a:buNone/>
-            </a:pPr>
-            <a:r>
-              <a:rPr lang="en-US" sz="1150" dirty="0">
-                <a:solidFill>
-                  <a:srgbClr val="E8ECEF"/>
-                </a:solidFill>
-                <a:latin typeface="Courier New" pitchFamily="34" charset="0"/>
-                <a:ea typeface="Courier New" pitchFamily="34" charset="-122"/>
-                <a:cs typeface="Courier New" pitchFamily="34" charset="-120"/>
-              </a:rPr>
-              <a:t>:</a:t>
-            </a:r>
-            <a:pPr indent="0" marL="0">
-              <a:lnSpc>
-                <a:spcPct val="105000"/>
-              </a:lnSpc>
-              <a:buNone/>
-            </a:pPr>
-            <a:r>
-              <a:rPr lang="en-US" sz="1150" dirty="0">
-                <a:solidFill>
-                  <a:srgbClr val="E8ECEF"/>
-                </a:solidFill>
-                <a:latin typeface="Courier New" pitchFamily="34" charset="0"/>
-                <a:ea typeface="Courier New" pitchFamily="34" charset="-122"/>
-                <a:cs typeface="Courier New" pitchFamily="34" charset="-120"/>
-              </a:rPr>
-              <a:t> </a:t>
-            </a:r>
-            <a:pPr indent="0" marL="0">
-              <a:lnSpc>
-                <a:spcPct val="105000"/>
-              </a:lnSpc>
-              <a:buNone/>
-            </a:pPr>
-            <a:r>
-              <a:rPr lang="en-US" sz="1150" dirty="0">
-                <a:solidFill>
-                  <a:srgbClr val="E8ECEF"/>
-                </a:solidFill>
-                <a:latin typeface="Courier New" pitchFamily="34" charset="0"/>
-                <a:ea typeface="Courier New" pitchFamily="34" charset="-122"/>
-                <a:cs typeface="Courier New" pitchFamily="34" charset="-120"/>
-              </a:rPr>
-              <a:t>ZAVBS_PC_PEDIDOS</a:t>
-            </a:r>
-            <a:endParaRPr lang="en-US" sz="1150" dirty="0"/>
-          </a:p>
-          <a:p>
-            <a:pPr indent="0" marL="0">
-              <a:lnSpc>
-                <a:spcPct val="105000"/>
-              </a:lnSpc>
-              <a:buNone/>
-            </a:pPr>
-            <a:r>
-              <a:rPr lang="en-US" sz="1150" dirty="0">
-                <a:solidFill>
-                  <a:srgbClr val="E8ECEF"/>
-                </a:solidFill>
-                <a:latin typeface="Courier New" pitchFamily="34" charset="0"/>
-                <a:ea typeface="Courier New" pitchFamily="34" charset="-122"/>
-                <a:cs typeface="Courier New" pitchFamily="34" charset="-120"/>
-              </a:rPr>
-              <a:t>        </a:t>
-            </a:r>
-            <a:pPr indent="0" marL="0">
-              <a:lnSpc>
-                <a:spcPct val="105000"/>
-              </a:lnSpc>
-              <a:buNone/>
-            </a:pPr>
-            <a:r>
-              <a:rPr lang="en-US" sz="1150" dirty="0">
-                <a:solidFill>
-                  <a:srgbClr val="4DB1FF"/>
-                </a:solidFill>
-                <a:latin typeface="Courier New" pitchFamily="34" charset="0"/>
-                <a:ea typeface="Courier New" pitchFamily="34" charset="-122"/>
-                <a:cs typeface="Courier New" pitchFamily="34" charset="-120"/>
-              </a:rPr>
-              <a:t>transport</a:t>
-            </a:r>
-            <a:pPr indent="0" marL="0">
-              <a:lnSpc>
-                <a:spcPct val="105000"/>
-              </a:lnSpc>
-              <a:buNone/>
-            </a:pPr>
-            <a:r>
-              <a:rPr lang="en-US" sz="1150" dirty="0">
-                <a:solidFill>
-                  <a:srgbClr val="E8ECEF"/>
-                </a:solidFill>
-                <a:latin typeface="Courier New" pitchFamily="34" charset="0"/>
-                <a:ea typeface="Courier New" pitchFamily="34" charset="-122"/>
-                <a:cs typeface="Courier New" pitchFamily="34" charset="-120"/>
-              </a:rPr>
-              <a:t>:</a:t>
-            </a:r>
-            <a:pPr indent="0" marL="0">
-              <a:lnSpc>
-                <a:spcPct val="105000"/>
-              </a:lnSpc>
-              <a:buNone/>
-            </a:pPr>
-            <a:r>
-              <a:rPr lang="en-US" sz="1150" dirty="0">
-                <a:solidFill>
-                  <a:srgbClr val="E8ECEF"/>
-                </a:solidFill>
-                <a:latin typeface="Courier New" pitchFamily="34" charset="0"/>
-                <a:ea typeface="Courier New" pitchFamily="34" charset="-122"/>
-                <a:cs typeface="Courier New" pitchFamily="34" charset="-120"/>
-              </a:rPr>
-              <a:t> </a:t>
-            </a:r>
-            <a:pPr indent="0" marL="0">
-              <a:lnSpc>
-                <a:spcPct val="105000"/>
-              </a:lnSpc>
-              <a:buNone/>
-            </a:pPr>
-            <a:r>
-              <a:rPr lang="en-US" sz="1150" dirty="0">
-                <a:solidFill>
-                  <a:srgbClr val="8FD694"/>
-                </a:solidFill>
-                <a:latin typeface="Courier New" pitchFamily="34" charset="0"/>
-                <a:ea typeface="Courier New" pitchFamily="34" charset="-122"/>
-                <a:cs typeface="Courier New" pitchFamily="34" charset="-120"/>
-              </a:rPr>
-              <a:t>""</a:t>
-            </a:r>
-            <a:endParaRPr lang="en-US" sz="1150" dirty="0"/>
-          </a:p>
-        </p:txBody>
-      </p:sp>
-      <p:sp>
-        <p:nvSpPr>
-          <p:cNvPr id="9" name="Cartão"/>
+        </p:txBody>
+      </p:sp>
+      <p:sp>
+        <p:nvSpPr>
+          <p:cNvPr id="13" name="Cartão"/>
           <p:cNvSpPr/>
           <p:nvPr/>
         </p:nvSpPr>
@@ -5716,7 +6018,7 @@
       </p:sp>
       <p:sp>
         <p:nvSpPr>
-          <p:cNvPr id="10" name="Ícone upload-to-cloud"/>
+          <p:cNvPr id="14" name="Ícone upload-to-cloud"/>
           <p:cNvSpPr/>
           <p:nvPr/>
         </p:nvSpPr>
@@ -5738,7 +6040,7 @@
       </p:sp>
       <p:pic>
         <p:nvPicPr>
-          <p:cNvPr id="11" name="Image 0" descr="upload-to-cloud">    </p:cNvPr>
+          <p:cNvPr id="15" name="Image 0" descr="upload-to-cloud">    </p:cNvPr>
           <p:cNvPicPr>
             <a:picLocks noChangeAspect="1"/>
           </p:cNvPicPr>
@@ -5762,7 +6064,7 @@
       </p:pic>
       <p:sp>
         <p:nvSpPr>
-          <p:cNvPr id="12" name="Text 8"/>
+          <p:cNvPr id="16" name="Text 12"/>
           <p:cNvSpPr txBox="1"/>
           <p:nvPr/>
         </p:nvSpPr>
@@ -5798,7 +6100,7 @@
       </p:sp>
       <p:sp>
         <p:nvSpPr>
-          <p:cNvPr id="13" name="Text 9"/>
+          <p:cNvPr id="17" name="Text 13"/>
           <p:cNvSpPr txBox="1"/>
           <p:nvPr/>
         </p:nvSpPr>
@@ -5834,7 +6136,7 @@
       </p:sp>
       <p:sp>
         <p:nvSpPr>
-          <p:cNvPr id="14" name="Shape 10"/>
+          <p:cNvPr id="18" name="Shape 14"/>
           <p:cNvSpPr/>
           <p:nvPr/>
         </p:nvSpPr>
@@ -5858,7 +6160,7 @@
       </p:sp>
       <p:sp>
         <p:nvSpPr>
-          <p:cNvPr id="15" name="Cartão"/>
+          <p:cNvPr id="19" name="Cartão"/>
           <p:cNvSpPr/>
           <p:nvPr/>
         </p:nvSpPr>
@@ -5887,7 +6189,7 @@
       </p:sp>
       <p:sp>
         <p:nvSpPr>
-          <p:cNvPr id="16" name="Ícone sap-box"/>
+          <p:cNvPr id="20" name="Ícone sap-box"/>
           <p:cNvSpPr/>
           <p:nvPr/>
         </p:nvSpPr>
@@ -5909,7 +6211,7 @@
       </p:sp>
       <p:pic>
         <p:nvPicPr>
-          <p:cNvPr id="17" name="Image 1" descr="sap-box">    </p:cNvPr>
+          <p:cNvPr id="21" name="Image 1" descr="sap-box">    </p:cNvPr>
           <p:cNvPicPr>
             <a:picLocks noChangeAspect="1"/>
           </p:cNvPicPr>
@@ -5933,7 +6235,7 @@
       </p:pic>
       <p:sp>
         <p:nvSpPr>
-          <p:cNvPr id="18" name="Text 13"/>
+          <p:cNvPr id="22" name="Text 17"/>
           <p:cNvSpPr txBox="1"/>
           <p:nvPr/>
         </p:nvSpPr>
@@ -5969,7 +6271,7 @@
       </p:sp>
       <p:sp>
         <p:nvSpPr>
-          <p:cNvPr id="19" name="Text 14"/>
+          <p:cNvPr id="23" name="Text 18"/>
           <p:cNvSpPr txBox="1"/>
           <p:nvPr/>
         </p:nvSpPr>
@@ -6005,7 +6307,7 @@
       </p:sp>
       <p:sp>
         <p:nvSpPr>
-          <p:cNvPr id="20" name="Shape 15"/>
+          <p:cNvPr id="24" name="Shape 19"/>
           <p:cNvSpPr/>
           <p:nvPr/>
         </p:nvSpPr>
@@ -6029,7 +6331,7 @@
       </p:sp>
       <p:sp>
         <p:nvSpPr>
-          <p:cNvPr id="21" name="Cartão"/>
+          <p:cNvPr id="25" name="Cartão"/>
           <p:cNvSpPr/>
           <p:nvPr/>
         </p:nvSpPr>
@@ -6058,7 +6360,7 @@
       </p:sp>
       <p:sp>
         <p:nvSpPr>
-          <p:cNvPr id="22" name="Ícone list"/>
+          <p:cNvPr id="26" name="Ícone list"/>
           <p:cNvSpPr/>
           <p:nvPr/>
         </p:nvSpPr>
@@ -6080,7 +6382,7 @@
       </p:sp>
       <p:pic>
         <p:nvPicPr>
-          <p:cNvPr id="23" name="Image 2" descr="list">    </p:cNvPr>
+          <p:cNvPr id="27" name="Image 2" descr="list">    </p:cNvPr>
           <p:cNvPicPr>
             <a:picLocks noChangeAspect="1"/>
           </p:cNvPicPr>
@@ -6104,7 +6406,7 @@
       </p:pic>
       <p:sp>
         <p:nvSpPr>
-          <p:cNvPr id="24" name="Text 18"/>
+          <p:cNvPr id="28" name="Text 22"/>
           <p:cNvSpPr txBox="1"/>
           <p:nvPr/>
         </p:nvSpPr>
@@ -6140,7 +6442,7 @@
       </p:sp>
       <p:sp>
         <p:nvSpPr>
-          <p:cNvPr id="25" name="Text 19"/>
+          <p:cNvPr id="29" name="Text 23"/>
           <p:cNvSpPr txBox="1"/>
           <p:nvPr/>
         </p:nvSpPr>
@@ -6176,7 +6478,7 @@
       </p:sp>
       <p:sp>
         <p:nvSpPr>
-          <p:cNvPr id="26" name="Shape 20"/>
+          <p:cNvPr id="30" name="Shape 24"/>
           <p:cNvSpPr/>
           <p:nvPr/>
         </p:nvSpPr>
@@ -6200,7 +6502,7 @@
       </p:sp>
       <p:sp>
         <p:nvSpPr>
-          <p:cNvPr id="27" name="Cartão"/>
+          <p:cNvPr id="31" name="Cartão"/>
           <p:cNvSpPr/>
           <p:nvPr/>
         </p:nvSpPr>
@@ -6229,7 +6531,7 @@
       </p:sp>
       <p:sp>
         <p:nvSpPr>
-          <p:cNvPr id="28" name="Ícone home"/>
+          <p:cNvPr id="32" name="Ícone home"/>
           <p:cNvSpPr/>
           <p:nvPr/>
         </p:nvSpPr>
@@ -6251,7 +6553,7 @@
       </p:sp>
       <p:pic>
         <p:nvPicPr>
-          <p:cNvPr id="29" name="Image 3" descr="home">    </p:cNvPr>
+          <p:cNvPr id="33" name="Image 3" descr="home">    </p:cNvPr>
           <p:cNvPicPr>
             <a:picLocks noChangeAspect="1"/>
           </p:cNvPicPr>
@@ -6275,7 +6577,7 @@
       </p:pic>
       <p:sp>
         <p:nvSpPr>
-          <p:cNvPr id="30" name="Text 23"/>
+          <p:cNvPr id="34" name="Text 27"/>
           <p:cNvSpPr txBox="1"/>
           <p:nvPr/>
         </p:nvSpPr>
@@ -6311,7 +6613,7 @@
       </p:sp>
       <p:sp>
         <p:nvSpPr>
-          <p:cNvPr id="31" name="Text 24"/>
+          <p:cNvPr id="35" name="Text 28"/>
           <p:cNvSpPr txBox="1"/>
           <p:nvPr/>
         </p:nvSpPr>
@@ -11320,7 +11622,7 @@
       </p:sp>
       <p:sp>
         <p:nvSpPr>
-          <p:cNvPr id="25" name="Código"/>
+          <p:cNvPr id="25" name="Editor"/>
           <p:cNvSpPr/>
           <p:nvPr/>
         </p:nvSpPr>
@@ -11335,9 +11637,14 @@
             </a:avLst>
           </a:prstGeom>
           <a:solidFill>
-            <a:srgbClr val="12171C"/>
+            <a:srgbClr val="181818"/>
           </a:solidFill>
-          <a:ln/>
+          <a:ln w="9525">
+            <a:solidFill>
+              <a:srgbClr val="2B2B2B"/>
+            </a:solidFill>
+            <a:prstDash val="solid"/>
+          </a:ln>
           <a:effectLst>
             <a:outerShdw sx="100000" sy="100000" kx="0" ky="0" algn="bl" rotWithShape="0" blurRad="101600" dist="25400" dir="5400000">
               <a:srgbClr val="223548">
@@ -11349,42 +11656,25 @@
       </p:sp>
       <p:sp>
         <p:nvSpPr>
-          <p:cNvPr id="26" name="Text 23"/>
-          <p:cNvSpPr txBox="1"/>
-          <p:nvPr/>
-        </p:nvSpPr>
-        <p:spPr>
-          <a:xfrm>
-            <a:off x="5852160" y="1755648"/>
-            <a:ext cx="5562295" cy="256032"/>
-          </a:xfrm>
-          <a:prstGeom prst="rect">
-            <a:avLst/>
-          </a:prstGeom>
-          <a:noFill/>
-          <a:ln/>
-        </p:spPr>
-        <p:txBody>
-          <a:bodyPr wrap="square" lIns="0" tIns="0" rIns="0" bIns="0" rtlCol="0" anchor="ctr"/>
-          <a:lstStyle/>
-          <a:p>
-            <a:pPr indent="0" marL="0">
-              <a:buNone/>
-            </a:pPr>
-            <a:r>
-              <a:rPr lang="en-US" sz="1000" dirty="0">
-                <a:solidFill>
-                  <a:srgbClr val="A9B4BE"/>
-                </a:solidFill>
-                <a:latin typeface="Courier New" pitchFamily="34" charset="0"/>
-                <a:ea typeface="Courier New" pitchFamily="34" charset="-122"/>
-                <a:cs typeface="Courier New" pitchFamily="34" charset="-120"/>
-              </a:rPr>
-              <a:t>ui5/pedidos-compras/webapp/manifest.json</a:t>
-            </a:r>
-            <a:endParaRPr lang="en-US" sz="1000" dirty="0"/>
-          </a:p>
-        </p:txBody>
+          <p:cNvPr id="26" name="Área do editor"/>
+          <p:cNvSpPr/>
+          <p:nvPr/>
+        </p:nvSpPr>
+        <p:spPr>
+          <a:xfrm>
+            <a:off x="5623560" y="1993392"/>
+            <a:ext cx="6019495" cy="4178808"/>
+          </a:xfrm>
+          <a:prstGeom prst="roundRect">
+            <a:avLst>
+              <a:gd name="adj" fmla="val 2188"/>
+            </a:avLst>
+          </a:prstGeom>
+          <a:solidFill>
+            <a:srgbClr val="1F1F1F"/>
+          </a:solidFill>
+          <a:ln/>
+        </p:spPr>
       </p:sp>
       <p:sp>
         <p:nvSpPr>
@@ -11394,16 +11684,36 @@
         </p:nvSpPr>
         <p:spPr>
           <a:xfrm>
-            <a:off x="5852160" y="2066544"/>
-            <a:ext cx="5562295" cy="0"/>
+            <a:off x="5632704" y="1993392"/>
+            <a:ext cx="6001207" cy="137160"/>
+          </a:xfrm>
+          <a:prstGeom prst="rect">
+            <a:avLst/>
+          </a:prstGeom>
+          <a:solidFill>
+            <a:srgbClr val="1F1F1F"/>
+          </a:solidFill>
+          <a:ln/>
+        </p:spPr>
+      </p:sp>
+      <p:sp>
+        <p:nvSpPr>
+          <p:cNvPr id="28" name="Shape 25"/>
+          <p:cNvSpPr/>
+          <p:nvPr/>
+        </p:nvSpPr>
+        <p:spPr>
+          <a:xfrm>
+            <a:off x="5632704" y="1993392"/>
+            <a:ext cx="6001207" cy="0"/>
           </a:xfrm>
           <a:prstGeom prst="line">
             <a:avLst/>
           </a:prstGeom>
           <a:noFill/>
-          <a:ln w="12700">
+          <a:ln w="9525">
             <a:solidFill>
-              <a:srgbClr val="2E3A46"/>
+              <a:srgbClr val="2B2B2B"/>
             </a:solidFill>
             <a:prstDash val="solid"/>
           </a:ln>
@@ -11411,14 +11721,75 @@
       </p:sp>
       <p:sp>
         <p:nvSpPr>
-          <p:cNvPr id="28" name="Trecho de código"/>
+          <p:cNvPr id="29" name="Aba manifest.json"/>
+          <p:cNvSpPr/>
+          <p:nvPr/>
+        </p:nvSpPr>
+        <p:spPr>
+          <a:xfrm>
+            <a:off x="5715000" y="1719072"/>
+            <a:ext cx="1394460" cy="274320"/>
+          </a:xfrm>
+          <a:prstGeom prst="rect">
+            <a:avLst/>
+          </a:prstGeom>
+          <a:solidFill>
+            <a:srgbClr val="1F1F1F"/>
+          </a:solidFill>
+          <a:ln/>
+        </p:spPr>
+        <p:txBody>
+          <a:bodyPr wrap="square" lIns="0" tIns="0" rIns="0" bIns="0" rtlCol="0" anchor="ctr"/>
+          <a:lstStyle/>
+          <a:p>
+            <a:pPr algn="ctr" indent="0" marL="0">
+              <a:buNone/>
+            </a:pPr>
+            <a:r>
+              <a:rPr lang="en-US" sz="1000" dirty="0">
+                <a:solidFill>
+                  <a:srgbClr val="FFFFFF"/>
+                </a:solidFill>
+              </a:rPr>
+              <a:t>manifest.json</a:t>
+            </a:r>
+            <a:endParaRPr lang="en-US" sz="1000" dirty="0"/>
+          </a:p>
+        </p:txBody>
+      </p:sp>
+      <p:sp>
+        <p:nvSpPr>
+          <p:cNvPr id="30" name="Shape 27"/>
+          <p:cNvSpPr/>
+          <p:nvPr/>
+        </p:nvSpPr>
+        <p:spPr>
+          <a:xfrm>
+            <a:off x="5715000" y="1719072"/>
+            <a:ext cx="1394460" cy="0"/>
+          </a:xfrm>
+          <a:prstGeom prst="line">
+            <a:avLst/>
+          </a:prstGeom>
+          <a:noFill/>
+          <a:ln w="19050">
+            <a:solidFill>
+              <a:srgbClr val="0078D4"/>
+            </a:solidFill>
+            <a:prstDash val="solid"/>
+          </a:ln>
+        </p:spPr>
+      </p:sp>
+      <p:sp>
+        <p:nvSpPr>
+          <p:cNvPr id="31" name="Breadcrumb"/>
           <p:cNvSpPr txBox="1"/>
           <p:nvPr/>
         </p:nvSpPr>
         <p:spPr>
           <a:xfrm>
-            <a:off x="5852160" y="2157984"/>
-            <a:ext cx="5562295" cy="3904488"/>
+            <a:off x="5852160" y="2103120"/>
+            <a:ext cx="5562295" cy="219456"/>
           </a:xfrm>
           <a:prstGeom prst="rect">
             <a:avLst/>
@@ -11427,6 +11798,108 @@
           <a:ln/>
         </p:spPr>
         <p:txBody>
+          <a:bodyPr wrap="square" lIns="0" tIns="0" rIns="0" bIns="0" rtlCol="0" anchor="ctr"/>
+          <a:lstStyle/>
+          <a:p>
+            <a:pPr indent="0" marL="0">
+              <a:buNone/>
+            </a:pPr>
+            <a:r>
+              <a:rPr lang="en-US" sz="900" dirty="0">
+                <a:solidFill>
+                  <a:srgbClr val="A9A9A9"/>
+                </a:solidFill>
+              </a:rPr>
+              <a:t>ui5</a:t>
+            </a:r>
+            <a:pPr indent="0" marL="0">
+              <a:buNone/>
+            </a:pPr>
+            <a:r>
+              <a:rPr lang="en-US" sz="900" dirty="0">
+                <a:solidFill>
+                  <a:srgbClr val="6E7681"/>
+                </a:solidFill>
+              </a:rPr>
+              <a:t>  ›  </a:t>
+            </a:r>
+            <a:pPr indent="0" marL="0">
+              <a:buNone/>
+            </a:pPr>
+            <a:r>
+              <a:rPr lang="en-US" sz="900" dirty="0">
+                <a:solidFill>
+                  <a:srgbClr val="A9A9A9"/>
+                </a:solidFill>
+              </a:rPr>
+              <a:t>pedidos-compras</a:t>
+            </a:r>
+            <a:pPr indent="0" marL="0">
+              <a:buNone/>
+            </a:pPr>
+            <a:r>
+              <a:rPr lang="en-US" sz="900" dirty="0">
+                <a:solidFill>
+                  <a:srgbClr val="6E7681"/>
+                </a:solidFill>
+              </a:rPr>
+              <a:t>  ›  </a:t>
+            </a:r>
+            <a:pPr indent="0" marL="0">
+              <a:buNone/>
+            </a:pPr>
+            <a:r>
+              <a:rPr lang="en-US" sz="900" dirty="0">
+                <a:solidFill>
+                  <a:srgbClr val="A9A9A9"/>
+                </a:solidFill>
+              </a:rPr>
+              <a:t>webapp</a:t>
+            </a:r>
+            <a:pPr indent="0" marL="0">
+              <a:buNone/>
+            </a:pPr>
+            <a:r>
+              <a:rPr lang="en-US" sz="900" dirty="0">
+                <a:solidFill>
+                  <a:srgbClr val="6E7681"/>
+                </a:solidFill>
+              </a:rPr>
+              <a:t>  ›  </a:t>
+            </a:r>
+            <a:pPr indent="0" marL="0">
+              <a:buNone/>
+            </a:pPr>
+            <a:r>
+              <a:rPr lang="en-US" sz="900" dirty="0">
+                <a:solidFill>
+                  <a:srgbClr val="A9A9A9"/>
+                </a:solidFill>
+              </a:rPr>
+              <a:t>manifest.json</a:t>
+            </a:r>
+            <a:endParaRPr lang="en-US" sz="900" dirty="0"/>
+          </a:p>
+        </p:txBody>
+      </p:sp>
+      <p:sp>
+        <p:nvSpPr>
+          <p:cNvPr id="32" name="Trecho de código"/>
+          <p:cNvSpPr txBox="1"/>
+          <p:nvPr/>
+        </p:nvSpPr>
+        <p:spPr>
+          <a:xfrm>
+            <a:off x="5806440" y="2414016"/>
+            <a:ext cx="5699455" cy="3666744"/>
+          </a:xfrm>
+          <a:prstGeom prst="rect">
+            <a:avLst/>
+          </a:prstGeom>
+          <a:noFill/>
+          <a:ln/>
+        </p:spPr>
+        <p:txBody>
           <a:bodyPr wrap="square" lIns="0" tIns="0" rIns="0" bIns="0" rtlCol="0" anchor="t"/>
           <a:lstStyle/>
           <a:p>
@@ -11439,7 +11912,24 @@
             <a:r>
               <a:rPr lang="en-US" sz="1050" dirty="0">
                 <a:solidFill>
-                  <a:srgbClr val="4DB1FF"/>
+                  <a:srgbClr val="6E7681"/>
+                </a:solidFill>
+                <a:latin typeface="Courier New" pitchFamily="34" charset="0"/>
+                <a:ea typeface="Courier New" pitchFamily="34" charset="-122"/>
+                <a:cs typeface="Courier New" pitchFamily="34" charset="-120"/>
+              </a:rPr>
+              <a:t> 1  </a:t>
+            </a:r>
+            <a:pPr indent="0" marL="0">
+              <a:lnSpc>
+                <a:spcPct val="105000"/>
+              </a:lnSpc>
+              <a:buNone/>
+            </a:pPr>
+            <a:r>
+              <a:rPr lang="en-US" sz="1050" dirty="0">
+                <a:solidFill>
+                  <a:srgbClr val="9CDCFE"/>
                 </a:solidFill>
                 <a:latin typeface="Courier New" pitchFamily="34" charset="0"/>
                 <a:ea typeface="Courier New" pitchFamily="34" charset="-122"/>
@@ -11456,13 +11946,47 @@
             <a:r>
               <a:rPr lang="en-US" sz="1050" dirty="0">
                 <a:solidFill>
-                  <a:srgbClr val="E8ECEF"/>
-                </a:solidFill>
-                <a:latin typeface="Courier New" pitchFamily="34" charset="0"/>
-                <a:ea typeface="Courier New" pitchFamily="34" charset="-122"/>
-                <a:cs typeface="Courier New" pitchFamily="34" charset="-120"/>
-              </a:rPr>
-              <a:t>: {</a:t>
+                  <a:srgbClr val="CCCCCC"/>
+                </a:solidFill>
+                <a:latin typeface="Courier New" pitchFamily="34" charset="0"/>
+                <a:ea typeface="Courier New" pitchFamily="34" charset="-122"/>
+                <a:cs typeface="Courier New" pitchFamily="34" charset="-120"/>
+              </a:rPr>
+              <a:t>:</a:t>
+            </a:r>
+            <a:pPr indent="0" marL="0">
+              <a:lnSpc>
+                <a:spcPct val="105000"/>
+              </a:lnSpc>
+              <a:buNone/>
+            </a:pPr>
+            <a:r>
+              <a:rPr lang="en-US" sz="1050" dirty="0">
+                <a:solidFill>
+                  <a:srgbClr val="CCCCCC"/>
+                </a:solidFill>
+                <a:latin typeface="Courier New" pitchFamily="34" charset="0"/>
+                <a:ea typeface="Courier New" pitchFamily="34" charset="-122"/>
+                <a:cs typeface="Courier New" pitchFamily="34" charset="-120"/>
+              </a:rPr>
+              <a:t> </a:t>
+            </a:r>
+            <a:pPr indent="0" marL="0">
+              <a:lnSpc>
+                <a:spcPct val="105000"/>
+              </a:lnSpc>
+              <a:buNone/>
+            </a:pPr>
+            <a:r>
+              <a:rPr lang="en-US" sz="1050" dirty="0">
+                <a:solidFill>
+                  <a:srgbClr val="CCCCCC"/>
+                </a:solidFill>
+                <a:latin typeface="Courier New" pitchFamily="34" charset="0"/>
+                <a:ea typeface="Courier New" pitchFamily="34" charset="-122"/>
+                <a:cs typeface="Courier New" pitchFamily="34" charset="-120"/>
+              </a:rPr>
+              <a:t>{</a:t>
             </a:r>
             <a:endParaRPr lang="en-US" sz="1050" dirty="0"/>
           </a:p>
@@ -11476,7 +12000,24 @@
             <a:r>
               <a:rPr lang="en-US" sz="1050" dirty="0">
                 <a:solidFill>
-                  <a:srgbClr val="E8ECEF"/>
+                  <a:srgbClr val="6E7681"/>
+                </a:solidFill>
+                <a:latin typeface="Courier New" pitchFamily="34" charset="0"/>
+                <a:ea typeface="Courier New" pitchFamily="34" charset="-122"/>
+                <a:cs typeface="Courier New" pitchFamily="34" charset="-120"/>
+              </a:rPr>
+              <a:t> 2  </a:t>
+            </a:r>
+            <a:pPr indent="0" marL="0">
+              <a:lnSpc>
+                <a:spcPct val="105000"/>
+              </a:lnSpc>
+              <a:buNone/>
+            </a:pPr>
+            <a:r>
+              <a:rPr lang="en-US" sz="1050" dirty="0">
+                <a:solidFill>
+                  <a:srgbClr val="CCCCCC"/>
                 </a:solidFill>
                 <a:latin typeface="Courier New" pitchFamily="34" charset="0"/>
                 <a:ea typeface="Courier New" pitchFamily="34" charset="-122"/>
@@ -11493,7 +12034,7 @@
             <a:r>
               <a:rPr lang="en-US" sz="1050" dirty="0">
                 <a:solidFill>
-                  <a:srgbClr val="4DB1FF"/>
+                  <a:srgbClr val="9CDCFE"/>
                 </a:solidFill>
                 <a:latin typeface="Courier New" pitchFamily="34" charset="0"/>
                 <a:ea typeface="Courier New" pitchFamily="34" charset="-122"/>
@@ -11510,13 +12051,47 @@
             <a:r>
               <a:rPr lang="en-US" sz="1050" dirty="0">
                 <a:solidFill>
-                  <a:srgbClr val="E8ECEF"/>
-                </a:solidFill>
-                <a:latin typeface="Courier New" pitchFamily="34" charset="0"/>
-                <a:ea typeface="Courier New" pitchFamily="34" charset="-122"/>
-                <a:cs typeface="Courier New" pitchFamily="34" charset="-120"/>
-              </a:rPr>
-              <a:t>: {</a:t>
+                  <a:srgbClr val="CCCCCC"/>
+                </a:solidFill>
+                <a:latin typeface="Courier New" pitchFamily="34" charset="0"/>
+                <a:ea typeface="Courier New" pitchFamily="34" charset="-122"/>
+                <a:cs typeface="Courier New" pitchFamily="34" charset="-120"/>
+              </a:rPr>
+              <a:t>:</a:t>
+            </a:r>
+            <a:pPr indent="0" marL="0">
+              <a:lnSpc>
+                <a:spcPct val="105000"/>
+              </a:lnSpc>
+              <a:buNone/>
+            </a:pPr>
+            <a:r>
+              <a:rPr lang="en-US" sz="1050" dirty="0">
+                <a:solidFill>
+                  <a:srgbClr val="CCCCCC"/>
+                </a:solidFill>
+                <a:latin typeface="Courier New" pitchFamily="34" charset="0"/>
+                <a:ea typeface="Courier New" pitchFamily="34" charset="-122"/>
+                <a:cs typeface="Courier New" pitchFamily="34" charset="-120"/>
+              </a:rPr>
+              <a:t> </a:t>
+            </a:r>
+            <a:pPr indent="0" marL="0">
+              <a:lnSpc>
+                <a:spcPct val="105000"/>
+              </a:lnSpc>
+              <a:buNone/>
+            </a:pPr>
+            <a:r>
+              <a:rPr lang="en-US" sz="1050" dirty="0">
+                <a:solidFill>
+                  <a:srgbClr val="CCCCCC"/>
+                </a:solidFill>
+                <a:latin typeface="Courier New" pitchFamily="34" charset="0"/>
+                <a:ea typeface="Courier New" pitchFamily="34" charset="-122"/>
+                <a:cs typeface="Courier New" pitchFamily="34" charset="-120"/>
+              </a:rPr>
+              <a:t>{</a:t>
             </a:r>
             <a:endParaRPr lang="en-US" sz="1050" dirty="0"/>
           </a:p>
@@ -11530,7 +12105,24 @@
             <a:r>
               <a:rPr lang="en-US" sz="1050" dirty="0">
                 <a:solidFill>
-                  <a:srgbClr val="E8ECEF"/>
+                  <a:srgbClr val="6E7681"/>
+                </a:solidFill>
+                <a:latin typeface="Courier New" pitchFamily="34" charset="0"/>
+                <a:ea typeface="Courier New" pitchFamily="34" charset="-122"/>
+                <a:cs typeface="Courier New" pitchFamily="34" charset="-120"/>
+              </a:rPr>
+              <a:t> 3  </a:t>
+            </a:r>
+            <a:pPr indent="0" marL="0">
+              <a:lnSpc>
+                <a:spcPct val="105000"/>
+              </a:lnSpc>
+              <a:buNone/>
+            </a:pPr>
+            <a:r>
+              <a:rPr lang="en-US" sz="1050" dirty="0">
+                <a:solidFill>
+                  <a:srgbClr val="CCCCCC"/>
                 </a:solidFill>
                 <a:latin typeface="Courier New" pitchFamily="34" charset="0"/>
                 <a:ea typeface="Courier New" pitchFamily="34" charset="-122"/>
@@ -11547,7 +12139,7 @@
             <a:r>
               <a:rPr lang="en-US" sz="1050" dirty="0">
                 <a:solidFill>
-                  <a:srgbClr val="4DB1FF"/>
+                  <a:srgbClr val="9CDCFE"/>
                 </a:solidFill>
                 <a:latin typeface="Courier New" pitchFamily="34" charset="0"/>
                 <a:ea typeface="Courier New" pitchFamily="34" charset="-122"/>
@@ -11564,13 +12156,47 @@
             <a:r>
               <a:rPr lang="en-US" sz="1050" dirty="0">
                 <a:solidFill>
-                  <a:srgbClr val="E8ECEF"/>
-                </a:solidFill>
-                <a:latin typeface="Courier New" pitchFamily="34" charset="0"/>
-                <a:ea typeface="Courier New" pitchFamily="34" charset="-122"/>
-                <a:cs typeface="Courier New" pitchFamily="34" charset="-120"/>
-              </a:rPr>
-              <a:t>: {</a:t>
+                  <a:srgbClr val="CCCCCC"/>
+                </a:solidFill>
+                <a:latin typeface="Courier New" pitchFamily="34" charset="0"/>
+                <a:ea typeface="Courier New" pitchFamily="34" charset="-122"/>
+                <a:cs typeface="Courier New" pitchFamily="34" charset="-120"/>
+              </a:rPr>
+              <a:t>:</a:t>
+            </a:r>
+            <a:pPr indent="0" marL="0">
+              <a:lnSpc>
+                <a:spcPct val="105000"/>
+              </a:lnSpc>
+              <a:buNone/>
+            </a:pPr>
+            <a:r>
+              <a:rPr lang="en-US" sz="1050" dirty="0">
+                <a:solidFill>
+                  <a:srgbClr val="CCCCCC"/>
+                </a:solidFill>
+                <a:latin typeface="Courier New" pitchFamily="34" charset="0"/>
+                <a:ea typeface="Courier New" pitchFamily="34" charset="-122"/>
+                <a:cs typeface="Courier New" pitchFamily="34" charset="-120"/>
+              </a:rPr>
+              <a:t> </a:t>
+            </a:r>
+            <a:pPr indent="0" marL="0">
+              <a:lnSpc>
+                <a:spcPct val="105000"/>
+              </a:lnSpc>
+              <a:buNone/>
+            </a:pPr>
+            <a:r>
+              <a:rPr lang="en-US" sz="1050" dirty="0">
+                <a:solidFill>
+                  <a:srgbClr val="CCCCCC"/>
+                </a:solidFill>
+                <a:latin typeface="Courier New" pitchFamily="34" charset="0"/>
+                <a:ea typeface="Courier New" pitchFamily="34" charset="-122"/>
+                <a:cs typeface="Courier New" pitchFamily="34" charset="-120"/>
+              </a:rPr>
+              <a:t>{</a:t>
             </a:r>
             <a:endParaRPr lang="en-US" sz="1050" dirty="0"/>
           </a:p>
@@ -11584,7 +12210,24 @@
             <a:r>
               <a:rPr lang="en-US" sz="1050" dirty="0">
                 <a:solidFill>
-                  <a:srgbClr val="E8ECEF"/>
+                  <a:srgbClr val="6E7681"/>
+                </a:solidFill>
+                <a:latin typeface="Courier New" pitchFamily="34" charset="0"/>
+                <a:ea typeface="Courier New" pitchFamily="34" charset="-122"/>
+                <a:cs typeface="Courier New" pitchFamily="34" charset="-120"/>
+              </a:rPr>
+              <a:t> 4  </a:t>
+            </a:r>
+            <a:pPr indent="0" marL="0">
+              <a:lnSpc>
+                <a:spcPct val="105000"/>
+              </a:lnSpc>
+              <a:buNone/>
+            </a:pPr>
+            <a:r>
+              <a:rPr lang="en-US" sz="1050" dirty="0">
+                <a:solidFill>
+                  <a:srgbClr val="CCCCCC"/>
                 </a:solidFill>
                 <a:latin typeface="Courier New" pitchFamily="34" charset="0"/>
                 <a:ea typeface="Courier New" pitchFamily="34" charset="-122"/>
@@ -11601,7 +12244,7 @@
             <a:r>
               <a:rPr lang="en-US" sz="1050" dirty="0">
                 <a:solidFill>
-                  <a:srgbClr val="4DB1FF"/>
+                  <a:srgbClr val="9CDCFE"/>
                 </a:solidFill>
                 <a:latin typeface="Courier New" pitchFamily="34" charset="0"/>
                 <a:ea typeface="Courier New" pitchFamily="34" charset="-122"/>
@@ -11618,13 +12261,13 @@
             <a:r>
               <a:rPr lang="en-US" sz="1050" dirty="0">
                 <a:solidFill>
-                  <a:srgbClr val="E8ECEF"/>
-                </a:solidFill>
-                <a:latin typeface="Courier New" pitchFamily="34" charset="0"/>
-                <a:ea typeface="Courier New" pitchFamily="34" charset="-122"/>
-                <a:cs typeface="Courier New" pitchFamily="34" charset="-120"/>
-              </a:rPr>
-              <a:t>: </a:t>
+                  <a:srgbClr val="CCCCCC"/>
+                </a:solidFill>
+                <a:latin typeface="Courier New" pitchFamily="34" charset="0"/>
+                <a:ea typeface="Courier New" pitchFamily="34" charset="-122"/>
+                <a:cs typeface="Courier New" pitchFamily="34" charset="-120"/>
+              </a:rPr>
+              <a:t>:</a:t>
             </a:r>
             <a:pPr indent="0" marL="0">
               <a:lnSpc>
@@ -11635,7 +12278,24 @@
             <a:r>
               <a:rPr lang="en-US" sz="1050" dirty="0">
                 <a:solidFill>
-                  <a:srgbClr val="8FD694"/>
+                  <a:srgbClr val="CCCCCC"/>
+                </a:solidFill>
+                <a:latin typeface="Courier New" pitchFamily="34" charset="0"/>
+                <a:ea typeface="Courier New" pitchFamily="34" charset="-122"/>
+                <a:cs typeface="Courier New" pitchFamily="34" charset="-120"/>
+              </a:rPr>
+              <a:t> </a:t>
+            </a:r>
+            <a:pPr indent="0" marL="0">
+              <a:lnSpc>
+                <a:spcPct val="105000"/>
+              </a:lnSpc>
+              <a:buNone/>
+            </a:pPr>
+            <a:r>
+              <a:rPr lang="en-US" sz="1050" dirty="0">
+                <a:solidFill>
+                  <a:srgbClr val="CE9178"/>
                 </a:solidFill>
                 <a:latin typeface="Courier New" pitchFamily="34" charset="0"/>
                 <a:ea typeface="Courier New" pitchFamily="34" charset="-122"/>
@@ -11652,7 +12312,7 @@
             <a:r>
               <a:rPr lang="en-US" sz="1050" dirty="0">
                 <a:solidFill>
-                  <a:srgbClr val="E8ECEF"/>
+                  <a:srgbClr val="CCCCCC"/>
                 </a:solidFill>
                 <a:latin typeface="Courier New" pitchFamily="34" charset="0"/>
                 <a:ea typeface="Courier New" pitchFamily="34" charset="-122"/>
@@ -11672,7 +12332,24 @@
             <a:r>
               <a:rPr lang="en-US" sz="1050" dirty="0">
                 <a:solidFill>
-                  <a:srgbClr val="E8ECEF"/>
+                  <a:srgbClr val="6E7681"/>
+                </a:solidFill>
+                <a:latin typeface="Courier New" pitchFamily="34" charset="0"/>
+                <a:ea typeface="Courier New" pitchFamily="34" charset="-122"/>
+                <a:cs typeface="Courier New" pitchFamily="34" charset="-120"/>
+              </a:rPr>
+              <a:t> 5  </a:t>
+            </a:r>
+            <a:pPr indent="0" marL="0">
+              <a:lnSpc>
+                <a:spcPct val="105000"/>
+              </a:lnSpc>
+              <a:buNone/>
+            </a:pPr>
+            <a:r>
+              <a:rPr lang="en-US" sz="1050" dirty="0">
+                <a:solidFill>
+                  <a:srgbClr val="CCCCCC"/>
                 </a:solidFill>
                 <a:latin typeface="Courier New" pitchFamily="34" charset="0"/>
                 <a:ea typeface="Courier New" pitchFamily="34" charset="-122"/>
@@ -11689,7 +12366,7 @@
             <a:r>
               <a:rPr lang="en-US" sz="1050" dirty="0">
                 <a:solidFill>
-                  <a:srgbClr val="4DB1FF"/>
+                  <a:srgbClr val="9CDCFE"/>
                 </a:solidFill>
                 <a:latin typeface="Courier New" pitchFamily="34" charset="0"/>
                 <a:ea typeface="Courier New" pitchFamily="34" charset="-122"/>
@@ -11706,13 +12383,13 @@
             <a:r>
               <a:rPr lang="en-US" sz="1050" dirty="0">
                 <a:solidFill>
-                  <a:srgbClr val="E8ECEF"/>
-                </a:solidFill>
-                <a:latin typeface="Courier New" pitchFamily="34" charset="0"/>
-                <a:ea typeface="Courier New" pitchFamily="34" charset="-122"/>
-                <a:cs typeface="Courier New" pitchFamily="34" charset="-120"/>
-              </a:rPr>
-              <a:t>: </a:t>
+                  <a:srgbClr val="CCCCCC"/>
+                </a:solidFill>
+                <a:latin typeface="Courier New" pitchFamily="34" charset="0"/>
+                <a:ea typeface="Courier New" pitchFamily="34" charset="-122"/>
+                <a:cs typeface="Courier New" pitchFamily="34" charset="-120"/>
+              </a:rPr>
+              <a:t>:</a:t>
             </a:r>
             <a:pPr indent="0" marL="0">
               <a:lnSpc>
@@ -11723,7 +12400,24 @@
             <a:r>
               <a:rPr lang="en-US" sz="1050" dirty="0">
                 <a:solidFill>
-                  <a:srgbClr val="8FD694"/>
+                  <a:srgbClr val="CCCCCC"/>
+                </a:solidFill>
+                <a:latin typeface="Courier New" pitchFamily="34" charset="0"/>
+                <a:ea typeface="Courier New" pitchFamily="34" charset="-122"/>
+                <a:cs typeface="Courier New" pitchFamily="34" charset="-120"/>
+              </a:rPr>
+              <a:t> </a:t>
+            </a:r>
+            <a:pPr indent="0" marL="0">
+              <a:lnSpc>
+                <a:spcPct val="105000"/>
+              </a:lnSpc>
+              <a:buNone/>
+            </a:pPr>
+            <a:r>
+              <a:rPr lang="en-US" sz="1050" dirty="0">
+                <a:solidFill>
+                  <a:srgbClr val="CE9178"/>
                 </a:solidFill>
                 <a:latin typeface="Courier New" pitchFamily="34" charset="0"/>
                 <a:ea typeface="Courier New" pitchFamily="34" charset="-122"/>
@@ -11740,7 +12434,7 @@
             <a:r>
               <a:rPr lang="en-US" sz="1050" dirty="0">
                 <a:solidFill>
-                  <a:srgbClr val="E8ECEF"/>
+                  <a:srgbClr val="CCCCCC"/>
                 </a:solidFill>
                 <a:latin typeface="Courier New" pitchFamily="34" charset="0"/>
                 <a:ea typeface="Courier New" pitchFamily="34" charset="-122"/>
@@ -11760,7 +12454,24 @@
             <a:r>
               <a:rPr lang="en-US" sz="1050" dirty="0">
                 <a:solidFill>
-                  <a:srgbClr val="E8ECEF"/>
+                  <a:srgbClr val="6E7681"/>
+                </a:solidFill>
+                <a:latin typeface="Courier New" pitchFamily="34" charset="0"/>
+                <a:ea typeface="Courier New" pitchFamily="34" charset="-122"/>
+                <a:cs typeface="Courier New" pitchFamily="34" charset="-120"/>
+              </a:rPr>
+              <a:t> 6  </a:t>
+            </a:r>
+            <a:pPr indent="0" marL="0">
+              <a:lnSpc>
+                <a:spcPct val="105000"/>
+              </a:lnSpc>
+              <a:buNone/>
+            </a:pPr>
+            <a:r>
+              <a:rPr lang="en-US" sz="1050" dirty="0">
+                <a:solidFill>
+                  <a:srgbClr val="CCCCCC"/>
                 </a:solidFill>
                 <a:latin typeface="Courier New" pitchFamily="34" charset="0"/>
                 <a:ea typeface="Courier New" pitchFamily="34" charset="-122"/>
@@ -11777,7 +12488,7 @@
             <a:r>
               <a:rPr lang="en-US" sz="1050" dirty="0">
                 <a:solidFill>
-                  <a:srgbClr val="4DB1FF"/>
+                  <a:srgbClr val="9CDCFE"/>
                 </a:solidFill>
                 <a:latin typeface="Courier New" pitchFamily="34" charset="0"/>
                 <a:ea typeface="Courier New" pitchFamily="34" charset="-122"/>
@@ -11794,13 +12505,13 @@
             <a:r>
               <a:rPr lang="en-US" sz="1050" dirty="0">
                 <a:solidFill>
-                  <a:srgbClr val="E8ECEF"/>
-                </a:solidFill>
-                <a:latin typeface="Courier New" pitchFamily="34" charset="0"/>
-                <a:ea typeface="Courier New" pitchFamily="34" charset="-122"/>
-                <a:cs typeface="Courier New" pitchFamily="34" charset="-120"/>
-              </a:rPr>
-              <a:t>: { </a:t>
+                  <a:srgbClr val="CCCCCC"/>
+                </a:solidFill>
+                <a:latin typeface="Courier New" pitchFamily="34" charset="0"/>
+                <a:ea typeface="Courier New" pitchFamily="34" charset="-122"/>
+                <a:cs typeface="Courier New" pitchFamily="34" charset="-120"/>
+              </a:rPr>
+              <a:t>:</a:t>
             </a:r>
             <a:pPr indent="0" marL="0">
               <a:lnSpc>
@@ -11811,7 +12522,58 @@
             <a:r>
               <a:rPr lang="en-US" sz="1050" dirty="0">
                 <a:solidFill>
-                  <a:srgbClr val="4DB1FF"/>
+                  <a:srgbClr val="CCCCCC"/>
+                </a:solidFill>
+                <a:latin typeface="Courier New" pitchFamily="34" charset="0"/>
+                <a:ea typeface="Courier New" pitchFamily="34" charset="-122"/>
+                <a:cs typeface="Courier New" pitchFamily="34" charset="-120"/>
+              </a:rPr>
+              <a:t> </a:t>
+            </a:r>
+            <a:pPr indent="0" marL="0">
+              <a:lnSpc>
+                <a:spcPct val="105000"/>
+              </a:lnSpc>
+              <a:buNone/>
+            </a:pPr>
+            <a:r>
+              <a:rPr lang="en-US" sz="1050" dirty="0">
+                <a:solidFill>
+                  <a:srgbClr val="CCCCCC"/>
+                </a:solidFill>
+                <a:latin typeface="Courier New" pitchFamily="34" charset="0"/>
+                <a:ea typeface="Courier New" pitchFamily="34" charset="-122"/>
+                <a:cs typeface="Courier New" pitchFamily="34" charset="-120"/>
+              </a:rPr>
+              <a:t>{</a:t>
+            </a:r>
+            <a:pPr indent="0" marL="0">
+              <a:lnSpc>
+                <a:spcPct val="105000"/>
+              </a:lnSpc>
+              <a:buNone/>
+            </a:pPr>
+            <a:r>
+              <a:rPr lang="en-US" sz="1050" dirty="0">
+                <a:solidFill>
+                  <a:srgbClr val="CCCCCC"/>
+                </a:solidFill>
+                <a:latin typeface="Courier New" pitchFamily="34" charset="0"/>
+                <a:ea typeface="Courier New" pitchFamily="34" charset="-122"/>
+                <a:cs typeface="Courier New" pitchFamily="34" charset="-120"/>
+              </a:rPr>
+              <a:t> </a:t>
+            </a:r>
+            <a:pPr indent="0" marL="0">
+              <a:lnSpc>
+                <a:spcPct val="105000"/>
+              </a:lnSpc>
+              <a:buNone/>
+            </a:pPr>
+            <a:r>
+              <a:rPr lang="en-US" sz="1050" dirty="0">
+                <a:solidFill>
+                  <a:srgbClr val="9CDCFE"/>
                 </a:solidFill>
                 <a:latin typeface="Courier New" pitchFamily="34" charset="0"/>
                 <a:ea typeface="Courier New" pitchFamily="34" charset="-122"/>
@@ -11828,13 +12590,47 @@
             <a:r>
               <a:rPr lang="en-US" sz="1050" dirty="0">
                 <a:solidFill>
-                  <a:srgbClr val="E8ECEF"/>
-                </a:solidFill>
-                <a:latin typeface="Courier New" pitchFamily="34" charset="0"/>
-                <a:ea typeface="Courier New" pitchFamily="34" charset="-122"/>
-                <a:cs typeface="Courier New" pitchFamily="34" charset="-120"/>
-              </a:rPr>
-              <a:t>: {</a:t>
+                  <a:srgbClr val="CCCCCC"/>
+                </a:solidFill>
+                <a:latin typeface="Courier New" pitchFamily="34" charset="0"/>
+                <a:ea typeface="Courier New" pitchFamily="34" charset="-122"/>
+                <a:cs typeface="Courier New" pitchFamily="34" charset="-120"/>
+              </a:rPr>
+              <a:t>:</a:t>
+            </a:r>
+            <a:pPr indent="0" marL="0">
+              <a:lnSpc>
+                <a:spcPct val="105000"/>
+              </a:lnSpc>
+              <a:buNone/>
+            </a:pPr>
+            <a:r>
+              <a:rPr lang="en-US" sz="1050" dirty="0">
+                <a:solidFill>
+                  <a:srgbClr val="CCCCCC"/>
+                </a:solidFill>
+                <a:latin typeface="Courier New" pitchFamily="34" charset="0"/>
+                <a:ea typeface="Courier New" pitchFamily="34" charset="-122"/>
+                <a:cs typeface="Courier New" pitchFamily="34" charset="-120"/>
+              </a:rPr>
+              <a:t> </a:t>
+            </a:r>
+            <a:pPr indent="0" marL="0">
+              <a:lnSpc>
+                <a:spcPct val="105000"/>
+              </a:lnSpc>
+              <a:buNone/>
+            </a:pPr>
+            <a:r>
+              <a:rPr lang="en-US" sz="1050" dirty="0">
+                <a:solidFill>
+                  <a:srgbClr val="CCCCCC"/>
+                </a:solidFill>
+                <a:latin typeface="Courier New" pitchFamily="34" charset="0"/>
+                <a:ea typeface="Courier New" pitchFamily="34" charset="-122"/>
+                <a:cs typeface="Courier New" pitchFamily="34" charset="-120"/>
+              </a:rPr>
+              <a:t>{</a:t>
             </a:r>
             <a:endParaRPr lang="en-US" sz="1050" dirty="0"/>
           </a:p>
@@ -11848,7 +12644,24 @@
             <a:r>
               <a:rPr lang="en-US" sz="1050" dirty="0">
                 <a:solidFill>
-                  <a:srgbClr val="E8ECEF"/>
+                  <a:srgbClr val="6E7681"/>
+                </a:solidFill>
+                <a:latin typeface="Courier New" pitchFamily="34" charset="0"/>
+                <a:ea typeface="Courier New" pitchFamily="34" charset="-122"/>
+                <a:cs typeface="Courier New" pitchFamily="34" charset="-120"/>
+              </a:rPr>
+              <a:t> 7  </a:t>
+            </a:r>
+            <a:pPr indent="0" marL="0">
+              <a:lnSpc>
+                <a:spcPct val="105000"/>
+              </a:lnSpc>
+              <a:buNone/>
+            </a:pPr>
+            <a:r>
+              <a:rPr lang="en-US" sz="1050" dirty="0">
+                <a:solidFill>
+                  <a:srgbClr val="CCCCCC"/>
                 </a:solidFill>
                 <a:latin typeface="Courier New" pitchFamily="34" charset="0"/>
                 <a:ea typeface="Courier New" pitchFamily="34" charset="-122"/>
@@ -11865,7 +12678,7 @@
             <a:r>
               <a:rPr lang="en-US" sz="1050" dirty="0">
                 <a:solidFill>
-                  <a:srgbClr val="4DB1FF"/>
+                  <a:srgbClr val="9CDCFE"/>
                 </a:solidFill>
                 <a:latin typeface="Courier New" pitchFamily="34" charset="0"/>
                 <a:ea typeface="Courier New" pitchFamily="34" charset="-122"/>
@@ -11882,13 +12695,13 @@
             <a:r>
               <a:rPr lang="en-US" sz="1050" dirty="0">
                 <a:solidFill>
-                  <a:srgbClr val="E8ECEF"/>
-                </a:solidFill>
-                <a:latin typeface="Courier New" pitchFamily="34" charset="0"/>
-                <a:ea typeface="Courier New" pitchFamily="34" charset="-122"/>
-                <a:cs typeface="Courier New" pitchFamily="34" charset="-120"/>
-              </a:rPr>
-              <a:t>: </a:t>
+                  <a:srgbClr val="CCCCCC"/>
+                </a:solidFill>
+                <a:latin typeface="Courier New" pitchFamily="34" charset="0"/>
+                <a:ea typeface="Courier New" pitchFamily="34" charset="-122"/>
+                <a:cs typeface="Courier New" pitchFamily="34" charset="-120"/>
+              </a:rPr>
+              <a:t>:</a:t>
             </a:r>
             <a:pPr indent="0" marL="0">
               <a:lnSpc>
@@ -11899,7 +12712,24 @@
             <a:r>
               <a:rPr lang="en-US" sz="1050" dirty="0">
                 <a:solidFill>
-                  <a:srgbClr val="8FD694"/>
+                  <a:srgbClr val="CCCCCC"/>
+                </a:solidFill>
+                <a:latin typeface="Courier New" pitchFamily="34" charset="0"/>
+                <a:ea typeface="Courier New" pitchFamily="34" charset="-122"/>
+                <a:cs typeface="Courier New" pitchFamily="34" charset="-120"/>
+              </a:rPr>
+              <a:t> </a:t>
+            </a:r>
+            <a:pPr indent="0" marL="0">
+              <a:lnSpc>
+                <a:spcPct val="105000"/>
+              </a:lnSpc>
+              <a:buNone/>
+            </a:pPr>
+            <a:r>
+              <a:rPr lang="en-US" sz="1050" dirty="0">
+                <a:solidFill>
+                  <a:srgbClr val="CE9178"/>
                 </a:solidFill>
                 <a:latin typeface="Courier New" pitchFamily="34" charset="0"/>
                 <a:ea typeface="Courier New" pitchFamily="34" charset="-122"/>
@@ -11916,7 +12746,7 @@
             <a:r>
               <a:rPr lang="en-US" sz="1050" dirty="0">
                 <a:solidFill>
-                  <a:srgbClr val="E8ECEF"/>
+                  <a:srgbClr val="CCCCCC"/>
                 </a:solidFill>
                 <a:latin typeface="Courier New" pitchFamily="34" charset="0"/>
                 <a:ea typeface="Courier New" pitchFamily="34" charset="-122"/>
@@ -11936,7 +12766,24 @@
             <a:r>
               <a:rPr lang="en-US" sz="1050" dirty="0">
                 <a:solidFill>
-                  <a:srgbClr val="E8ECEF"/>
+                  <a:srgbClr val="6E7681"/>
+                </a:solidFill>
+                <a:latin typeface="Courier New" pitchFamily="34" charset="0"/>
+                <a:ea typeface="Courier New" pitchFamily="34" charset="-122"/>
+                <a:cs typeface="Courier New" pitchFamily="34" charset="-120"/>
+              </a:rPr>
+              <a:t> 8  </a:t>
+            </a:r>
+            <a:pPr indent="0" marL="0">
+              <a:lnSpc>
+                <a:spcPct val="105000"/>
+              </a:lnSpc>
+              <a:buNone/>
+            </a:pPr>
+            <a:r>
+              <a:rPr lang="en-US" sz="1050" dirty="0">
+                <a:solidFill>
+                  <a:srgbClr val="CCCCCC"/>
                 </a:solidFill>
                 <a:latin typeface="Courier New" pitchFamily="34" charset="0"/>
                 <a:ea typeface="Courier New" pitchFamily="34" charset="-122"/>
@@ -11953,7 +12800,7 @@
             <a:r>
               <a:rPr lang="en-US" sz="1050" dirty="0">
                 <a:solidFill>
-                  <a:srgbClr val="4DB1FF"/>
+                  <a:srgbClr val="9CDCFE"/>
                 </a:solidFill>
                 <a:latin typeface="Courier New" pitchFamily="34" charset="0"/>
                 <a:ea typeface="Courier New" pitchFamily="34" charset="-122"/>
@@ -11970,13 +12817,13 @@
             <a:r>
               <a:rPr lang="en-US" sz="1050" dirty="0">
                 <a:solidFill>
-                  <a:srgbClr val="E8ECEF"/>
-                </a:solidFill>
-                <a:latin typeface="Courier New" pitchFamily="34" charset="0"/>
-                <a:ea typeface="Courier New" pitchFamily="34" charset="-122"/>
-                <a:cs typeface="Courier New" pitchFamily="34" charset="-120"/>
-              </a:rPr>
-              <a:t>: </a:t>
+                  <a:srgbClr val="CCCCCC"/>
+                </a:solidFill>
+                <a:latin typeface="Courier New" pitchFamily="34" charset="0"/>
+                <a:ea typeface="Courier New" pitchFamily="34" charset="-122"/>
+                <a:cs typeface="Courier New" pitchFamily="34" charset="-120"/>
+              </a:rPr>
+              <a:t>:</a:t>
             </a:r>
             <a:pPr indent="0" marL="0">
               <a:lnSpc>
@@ -11987,7 +12834,24 @@
             <a:r>
               <a:rPr lang="en-US" sz="1050" dirty="0">
                 <a:solidFill>
-                  <a:srgbClr val="8FD694"/>
+                  <a:srgbClr val="CCCCCC"/>
+                </a:solidFill>
+                <a:latin typeface="Courier New" pitchFamily="34" charset="0"/>
+                <a:ea typeface="Courier New" pitchFamily="34" charset="-122"/>
+                <a:cs typeface="Courier New" pitchFamily="34" charset="-120"/>
+              </a:rPr>
+              <a:t> </a:t>
+            </a:r>
+            <a:pPr indent="0" marL="0">
+              <a:lnSpc>
+                <a:spcPct val="105000"/>
+              </a:lnSpc>
+              <a:buNone/>
+            </a:pPr>
+            <a:r>
+              <a:rPr lang="en-US" sz="1050" dirty="0">
+                <a:solidFill>
+                  <a:srgbClr val="CE9178"/>
                 </a:solidFill>
                 <a:latin typeface="Courier New" pitchFamily="34" charset="0"/>
                 <a:ea typeface="Courier New" pitchFamily="34" charset="-122"/>
@@ -12004,7 +12868,7 @@
             <a:r>
               <a:rPr lang="en-US" sz="1050" dirty="0">
                 <a:solidFill>
-                  <a:srgbClr val="E8ECEF"/>
+                  <a:srgbClr val="CCCCCC"/>
                 </a:solidFill>
                 <a:latin typeface="Courier New" pitchFamily="34" charset="0"/>
                 <a:ea typeface="Courier New" pitchFamily="34" charset="-122"/>
@@ -12024,7 +12888,24 @@
             <a:r>
               <a:rPr lang="en-US" sz="1050" dirty="0">
                 <a:solidFill>
-                  <a:srgbClr val="E8ECEF"/>
+                  <a:srgbClr val="6E7681"/>
+                </a:solidFill>
+                <a:latin typeface="Courier New" pitchFamily="34" charset="0"/>
+                <a:ea typeface="Courier New" pitchFamily="34" charset="-122"/>
+                <a:cs typeface="Courier New" pitchFamily="34" charset="-120"/>
+              </a:rPr>
+              <a:t> 9  </a:t>
+            </a:r>
+            <a:pPr indent="0" marL="0">
+              <a:lnSpc>
+                <a:spcPct val="105000"/>
+              </a:lnSpc>
+              <a:buNone/>
+            </a:pPr>
+            <a:r>
+              <a:rPr lang="en-US" sz="1050" dirty="0">
+                <a:solidFill>
+                  <a:srgbClr val="CCCCCC"/>
                 </a:solidFill>
                 <a:latin typeface="Courier New" pitchFamily="34" charset="0"/>
                 <a:ea typeface="Courier New" pitchFamily="34" charset="-122"/>
@@ -12041,7 +12922,7 @@
             <a:r>
               <a:rPr lang="en-US" sz="1050" dirty="0">
                 <a:solidFill>
-                  <a:srgbClr val="4DB1FF"/>
+                  <a:srgbClr val="9CDCFE"/>
                 </a:solidFill>
                 <a:latin typeface="Courier New" pitchFamily="34" charset="0"/>
                 <a:ea typeface="Courier New" pitchFamily="34" charset="-122"/>
@@ -12058,13 +12939,13 @@
             <a:r>
               <a:rPr lang="en-US" sz="1050" dirty="0">
                 <a:solidFill>
-                  <a:srgbClr val="E8ECEF"/>
-                </a:solidFill>
-                <a:latin typeface="Courier New" pitchFamily="34" charset="0"/>
-                <a:ea typeface="Courier New" pitchFamily="34" charset="-122"/>
-                <a:cs typeface="Courier New" pitchFamily="34" charset="-120"/>
-              </a:rPr>
-              <a:t>: { </a:t>
+                  <a:srgbClr val="CCCCCC"/>
+                </a:solidFill>
+                <a:latin typeface="Courier New" pitchFamily="34" charset="0"/>
+                <a:ea typeface="Courier New" pitchFamily="34" charset="-122"/>
+                <a:cs typeface="Courier New" pitchFamily="34" charset="-120"/>
+              </a:rPr>
+              <a:t>:</a:t>
             </a:r>
             <a:pPr indent="0" marL="0">
               <a:lnSpc>
@@ -12075,7 +12956,58 @@
             <a:r>
               <a:rPr lang="en-US" sz="1050" dirty="0">
                 <a:solidFill>
-                  <a:srgbClr val="4DB1FF"/>
+                  <a:srgbClr val="CCCCCC"/>
+                </a:solidFill>
+                <a:latin typeface="Courier New" pitchFamily="34" charset="0"/>
+                <a:ea typeface="Courier New" pitchFamily="34" charset="-122"/>
+                <a:cs typeface="Courier New" pitchFamily="34" charset="-120"/>
+              </a:rPr>
+              <a:t> </a:t>
+            </a:r>
+            <a:pPr indent="0" marL="0">
+              <a:lnSpc>
+                <a:spcPct val="105000"/>
+              </a:lnSpc>
+              <a:buNone/>
+            </a:pPr>
+            <a:r>
+              <a:rPr lang="en-US" sz="1050" dirty="0">
+                <a:solidFill>
+                  <a:srgbClr val="CCCCCC"/>
+                </a:solidFill>
+                <a:latin typeface="Courier New" pitchFamily="34" charset="0"/>
+                <a:ea typeface="Courier New" pitchFamily="34" charset="-122"/>
+                <a:cs typeface="Courier New" pitchFamily="34" charset="-120"/>
+              </a:rPr>
+              <a:t>{</a:t>
+            </a:r>
+            <a:pPr indent="0" marL="0">
+              <a:lnSpc>
+                <a:spcPct val="105000"/>
+              </a:lnSpc>
+              <a:buNone/>
+            </a:pPr>
+            <a:r>
+              <a:rPr lang="en-US" sz="1050" dirty="0">
+                <a:solidFill>
+                  <a:srgbClr val="CCCCCC"/>
+                </a:solidFill>
+                <a:latin typeface="Courier New" pitchFamily="34" charset="0"/>
+                <a:ea typeface="Courier New" pitchFamily="34" charset="-122"/>
+                <a:cs typeface="Courier New" pitchFamily="34" charset="-120"/>
+              </a:rPr>
+              <a:t> </a:t>
+            </a:r>
+            <a:pPr indent="0" marL="0">
+              <a:lnSpc>
+                <a:spcPct val="105000"/>
+              </a:lnSpc>
+              <a:buNone/>
+            </a:pPr>
+            <a:r>
+              <a:rPr lang="en-US" sz="1050" dirty="0">
+                <a:solidFill>
+                  <a:srgbClr val="9CDCFE"/>
                 </a:solidFill>
                 <a:latin typeface="Courier New" pitchFamily="34" charset="0"/>
                 <a:ea typeface="Courier New" pitchFamily="34" charset="-122"/>
@@ -12092,13 +13024,47 @@
             <a:r>
               <a:rPr lang="en-US" sz="1050" dirty="0">
                 <a:solidFill>
-                  <a:srgbClr val="E8ECEF"/>
-                </a:solidFill>
-                <a:latin typeface="Courier New" pitchFamily="34" charset="0"/>
-                <a:ea typeface="Courier New" pitchFamily="34" charset="-122"/>
-                <a:cs typeface="Courier New" pitchFamily="34" charset="-120"/>
-              </a:rPr>
-              <a:t>: {</a:t>
+                  <a:srgbClr val="CCCCCC"/>
+                </a:solidFill>
+                <a:latin typeface="Courier New" pitchFamily="34" charset="0"/>
+                <a:ea typeface="Courier New" pitchFamily="34" charset="-122"/>
+                <a:cs typeface="Courier New" pitchFamily="34" charset="-120"/>
+              </a:rPr>
+              <a:t>:</a:t>
+            </a:r>
+            <a:pPr indent="0" marL="0">
+              <a:lnSpc>
+                <a:spcPct val="105000"/>
+              </a:lnSpc>
+              <a:buNone/>
+            </a:pPr>
+            <a:r>
+              <a:rPr lang="en-US" sz="1050" dirty="0">
+                <a:solidFill>
+                  <a:srgbClr val="CCCCCC"/>
+                </a:solidFill>
+                <a:latin typeface="Courier New" pitchFamily="34" charset="0"/>
+                <a:ea typeface="Courier New" pitchFamily="34" charset="-122"/>
+                <a:cs typeface="Courier New" pitchFamily="34" charset="-120"/>
+              </a:rPr>
+              <a:t> </a:t>
+            </a:r>
+            <a:pPr indent="0" marL="0">
+              <a:lnSpc>
+                <a:spcPct val="105000"/>
+              </a:lnSpc>
+              <a:buNone/>
+            </a:pPr>
+            <a:r>
+              <a:rPr lang="en-US" sz="1050" dirty="0">
+                <a:solidFill>
+                  <a:srgbClr val="CCCCCC"/>
+                </a:solidFill>
+                <a:latin typeface="Courier New" pitchFamily="34" charset="0"/>
+                <a:ea typeface="Courier New" pitchFamily="34" charset="-122"/>
+                <a:cs typeface="Courier New" pitchFamily="34" charset="-120"/>
+              </a:rPr>
+              <a:t>{</a:t>
             </a:r>
             <a:endParaRPr lang="en-US" sz="1050" dirty="0"/>
           </a:p>
@@ -12112,7 +13078,24 @@
             <a:r>
               <a:rPr lang="en-US" sz="1050" dirty="0">
                 <a:solidFill>
-                  <a:srgbClr val="E8ECEF"/>
+                  <a:srgbClr val="6E7681"/>
+                </a:solidFill>
+                <a:latin typeface="Courier New" pitchFamily="34" charset="0"/>
+                <a:ea typeface="Courier New" pitchFamily="34" charset="-122"/>
+                <a:cs typeface="Courier New" pitchFamily="34" charset="-120"/>
+              </a:rPr>
+              <a:t>10  </a:t>
+            </a:r>
+            <a:pPr indent="0" marL="0">
+              <a:lnSpc>
+                <a:spcPct val="105000"/>
+              </a:lnSpc>
+              <a:buNone/>
+            </a:pPr>
+            <a:r>
+              <a:rPr lang="en-US" sz="1050" dirty="0">
+                <a:solidFill>
+                  <a:srgbClr val="CCCCCC"/>
                 </a:solidFill>
                 <a:latin typeface="Courier New" pitchFamily="34" charset="0"/>
                 <a:ea typeface="Courier New" pitchFamily="34" charset="-122"/>
@@ -12129,7 +13112,7 @@
             <a:r>
               <a:rPr lang="en-US" sz="1050" dirty="0">
                 <a:solidFill>
-                  <a:srgbClr val="4DB1FF"/>
+                  <a:srgbClr val="9CDCFE"/>
                 </a:solidFill>
                 <a:latin typeface="Courier New" pitchFamily="34" charset="0"/>
                 <a:ea typeface="Courier New" pitchFamily="34" charset="-122"/>
@@ -12146,13 +13129,13 @@
             <a:r>
               <a:rPr lang="en-US" sz="1050" dirty="0">
                 <a:solidFill>
-                  <a:srgbClr val="E8ECEF"/>
-                </a:solidFill>
-                <a:latin typeface="Courier New" pitchFamily="34" charset="0"/>
-                <a:ea typeface="Courier New" pitchFamily="34" charset="-122"/>
-                <a:cs typeface="Courier New" pitchFamily="34" charset="-120"/>
-              </a:rPr>
-              <a:t>: { </a:t>
+                  <a:srgbClr val="CCCCCC"/>
+                </a:solidFill>
+                <a:latin typeface="Courier New" pitchFamily="34" charset="0"/>
+                <a:ea typeface="Courier New" pitchFamily="34" charset="-122"/>
+                <a:cs typeface="Courier New" pitchFamily="34" charset="-120"/>
+              </a:rPr>
+              <a:t>:</a:t>
             </a:r>
             <a:pPr indent="0" marL="0">
               <a:lnSpc>
@@ -12163,7 +13146,58 @@
             <a:r>
               <a:rPr lang="en-US" sz="1050" dirty="0">
                 <a:solidFill>
-                  <a:srgbClr val="4DB1FF"/>
+                  <a:srgbClr val="CCCCCC"/>
+                </a:solidFill>
+                <a:latin typeface="Courier New" pitchFamily="34" charset="0"/>
+                <a:ea typeface="Courier New" pitchFamily="34" charset="-122"/>
+                <a:cs typeface="Courier New" pitchFamily="34" charset="-120"/>
+              </a:rPr>
+              <a:t> </a:t>
+            </a:r>
+            <a:pPr indent="0" marL="0">
+              <a:lnSpc>
+                <a:spcPct val="105000"/>
+              </a:lnSpc>
+              <a:buNone/>
+            </a:pPr>
+            <a:r>
+              <a:rPr lang="en-US" sz="1050" dirty="0">
+                <a:solidFill>
+                  <a:srgbClr val="CCCCCC"/>
+                </a:solidFill>
+                <a:latin typeface="Courier New" pitchFamily="34" charset="0"/>
+                <a:ea typeface="Courier New" pitchFamily="34" charset="-122"/>
+                <a:cs typeface="Courier New" pitchFamily="34" charset="-120"/>
+              </a:rPr>
+              <a:t>{</a:t>
+            </a:r>
+            <a:pPr indent="0" marL="0">
+              <a:lnSpc>
+                <a:spcPct val="105000"/>
+              </a:lnSpc>
+              <a:buNone/>
+            </a:pPr>
+            <a:r>
+              <a:rPr lang="en-US" sz="1050" dirty="0">
+                <a:solidFill>
+                  <a:srgbClr val="CCCCCC"/>
+                </a:solidFill>
+                <a:latin typeface="Courier New" pitchFamily="34" charset="0"/>
+                <a:ea typeface="Courier New" pitchFamily="34" charset="-122"/>
+                <a:cs typeface="Courier New" pitchFamily="34" charset="-120"/>
+              </a:rPr>
+              <a:t> </a:t>
+            </a:r>
+            <a:pPr indent="0" marL="0">
+              <a:lnSpc>
+                <a:spcPct val="105000"/>
+              </a:lnSpc>
+              <a:buNone/>
+            </a:pPr>
+            <a:r>
+              <a:rPr lang="en-US" sz="1050" dirty="0">
+                <a:solidFill>
+                  <a:srgbClr val="9CDCFE"/>
                 </a:solidFill>
                 <a:latin typeface="Courier New" pitchFamily="34" charset="0"/>
                 <a:ea typeface="Courier New" pitchFamily="34" charset="-122"/>
@@ -12180,13 +13214,13 @@
             <a:r>
               <a:rPr lang="en-US" sz="1050" dirty="0">
                 <a:solidFill>
-                  <a:srgbClr val="E8ECEF"/>
-                </a:solidFill>
-                <a:latin typeface="Courier New" pitchFamily="34" charset="0"/>
-                <a:ea typeface="Courier New" pitchFamily="34" charset="-122"/>
-                <a:cs typeface="Courier New" pitchFamily="34" charset="-120"/>
-              </a:rPr>
-              <a:t>: </a:t>
+                  <a:srgbClr val="CCCCCC"/>
+                </a:solidFill>
+                <a:latin typeface="Courier New" pitchFamily="34" charset="0"/>
+                <a:ea typeface="Courier New" pitchFamily="34" charset="-122"/>
+                <a:cs typeface="Courier New" pitchFamily="34" charset="-120"/>
+              </a:rPr>
+              <a:t>:</a:t>
             </a:r>
             <a:pPr indent="0" marL="0">
               <a:lnSpc>
@@ -12197,7 +13231,24 @@
             <a:r>
               <a:rPr lang="en-US" sz="1050" dirty="0">
                 <a:solidFill>
-                  <a:srgbClr val="8FD694"/>
+                  <a:srgbClr val="CCCCCC"/>
+                </a:solidFill>
+                <a:latin typeface="Courier New" pitchFamily="34" charset="0"/>
+                <a:ea typeface="Courier New" pitchFamily="34" charset="-122"/>
+                <a:cs typeface="Courier New" pitchFamily="34" charset="-120"/>
+              </a:rPr>
+              <a:t> </a:t>
+            </a:r>
+            <a:pPr indent="0" marL="0">
+              <a:lnSpc>
+                <a:spcPct val="105000"/>
+              </a:lnSpc>
+              <a:buNone/>
+            </a:pPr>
+            <a:r>
+              <a:rPr lang="en-US" sz="1050" dirty="0">
+                <a:solidFill>
+                  <a:srgbClr val="CE9178"/>
                 </a:solidFill>
                 <a:latin typeface="Courier New" pitchFamily="34" charset="0"/>
                 <a:ea typeface="Courier New" pitchFamily="34" charset="-122"/>
@@ -12214,13 +13265,98 @@
             <a:r>
               <a:rPr lang="en-US" sz="1050" dirty="0">
                 <a:solidFill>
-                  <a:srgbClr val="E8ECEF"/>
-                </a:solidFill>
-                <a:latin typeface="Courier New" pitchFamily="34" charset="0"/>
-                <a:ea typeface="Courier New" pitchFamily="34" charset="-122"/>
-                <a:cs typeface="Courier New" pitchFamily="34" charset="-120"/>
-              </a:rPr>
-              <a:t> } } },</a:t>
+                  <a:srgbClr val="CCCCCC"/>
+                </a:solidFill>
+                <a:latin typeface="Courier New" pitchFamily="34" charset="0"/>
+                <a:ea typeface="Courier New" pitchFamily="34" charset="-122"/>
+                <a:cs typeface="Courier New" pitchFamily="34" charset="-120"/>
+              </a:rPr>
+              <a:t> </a:t>
+            </a:r>
+            <a:pPr indent="0" marL="0">
+              <a:lnSpc>
+                <a:spcPct val="105000"/>
+              </a:lnSpc>
+              <a:buNone/>
+            </a:pPr>
+            <a:r>
+              <a:rPr lang="en-US" sz="1050" dirty="0">
+                <a:solidFill>
+                  <a:srgbClr val="CCCCCC"/>
+                </a:solidFill>
+                <a:latin typeface="Courier New" pitchFamily="34" charset="0"/>
+                <a:ea typeface="Courier New" pitchFamily="34" charset="-122"/>
+                <a:cs typeface="Courier New" pitchFamily="34" charset="-120"/>
+              </a:rPr>
+              <a:t>}</a:t>
+            </a:r>
+            <a:pPr indent="0" marL="0">
+              <a:lnSpc>
+                <a:spcPct val="105000"/>
+              </a:lnSpc>
+              <a:buNone/>
+            </a:pPr>
+            <a:r>
+              <a:rPr lang="en-US" sz="1050" dirty="0">
+                <a:solidFill>
+                  <a:srgbClr val="CCCCCC"/>
+                </a:solidFill>
+                <a:latin typeface="Courier New" pitchFamily="34" charset="0"/>
+                <a:ea typeface="Courier New" pitchFamily="34" charset="-122"/>
+                <a:cs typeface="Courier New" pitchFamily="34" charset="-120"/>
+              </a:rPr>
+              <a:t> </a:t>
+            </a:r>
+            <a:pPr indent="0" marL="0">
+              <a:lnSpc>
+                <a:spcPct val="105000"/>
+              </a:lnSpc>
+              <a:buNone/>
+            </a:pPr>
+            <a:r>
+              <a:rPr lang="en-US" sz="1050" dirty="0">
+                <a:solidFill>
+                  <a:srgbClr val="CCCCCC"/>
+                </a:solidFill>
+                <a:latin typeface="Courier New" pitchFamily="34" charset="0"/>
+                <a:ea typeface="Courier New" pitchFamily="34" charset="-122"/>
+                <a:cs typeface="Courier New" pitchFamily="34" charset="-120"/>
+              </a:rPr>
+              <a:t>}</a:t>
+            </a:r>
+            <a:pPr indent="0" marL="0">
+              <a:lnSpc>
+                <a:spcPct val="105000"/>
+              </a:lnSpc>
+              <a:buNone/>
+            </a:pPr>
+            <a:r>
+              <a:rPr lang="en-US" sz="1050" dirty="0">
+                <a:solidFill>
+                  <a:srgbClr val="CCCCCC"/>
+                </a:solidFill>
+                <a:latin typeface="Courier New" pitchFamily="34" charset="0"/>
+                <a:ea typeface="Courier New" pitchFamily="34" charset="-122"/>
+                <a:cs typeface="Courier New" pitchFamily="34" charset="-120"/>
+              </a:rPr>
+              <a:t> </a:t>
+            </a:r>
+            <a:pPr indent="0" marL="0">
+              <a:lnSpc>
+                <a:spcPct val="105000"/>
+              </a:lnSpc>
+              <a:buNone/>
+            </a:pPr>
+            <a:r>
+              <a:rPr lang="en-US" sz="1050" dirty="0">
+                <a:solidFill>
+                  <a:srgbClr val="CCCCCC"/>
+                </a:solidFill>
+                <a:latin typeface="Courier New" pitchFamily="34" charset="0"/>
+                <a:ea typeface="Courier New" pitchFamily="34" charset="-122"/>
+                <a:cs typeface="Courier New" pitchFamily="34" charset="-120"/>
+              </a:rPr>
+              <a:t>},</a:t>
             </a:r>
             <a:endParaRPr lang="en-US" sz="1050" dirty="0"/>
           </a:p>
@@ -12234,7 +13370,24 @@
             <a:r>
               <a:rPr lang="en-US" sz="1050" dirty="0">
                 <a:solidFill>
-                  <a:srgbClr val="E8ECEF"/>
+                  <a:srgbClr val="6E7681"/>
+                </a:solidFill>
+                <a:latin typeface="Courier New" pitchFamily="34" charset="0"/>
+                <a:ea typeface="Courier New" pitchFamily="34" charset="-122"/>
+                <a:cs typeface="Courier New" pitchFamily="34" charset="-120"/>
+              </a:rPr>
+              <a:t>11  </a:t>
+            </a:r>
+            <a:pPr indent="0" marL="0">
+              <a:lnSpc>
+                <a:spcPct val="105000"/>
+              </a:lnSpc>
+              <a:buNone/>
+            </a:pPr>
+            <a:r>
+              <a:rPr lang="en-US" sz="1050" dirty="0">
+                <a:solidFill>
+                  <a:srgbClr val="CCCCCC"/>
                 </a:solidFill>
                 <a:latin typeface="Courier New" pitchFamily="34" charset="0"/>
                 <a:ea typeface="Courier New" pitchFamily="34" charset="-122"/>
@@ -12251,7 +13404,7 @@
             <a:r>
               <a:rPr lang="en-US" sz="1050" dirty="0">
                 <a:solidFill>
-                  <a:srgbClr val="4DB1FF"/>
+                  <a:srgbClr val="9CDCFE"/>
                 </a:solidFill>
                 <a:latin typeface="Courier New" pitchFamily="34" charset="0"/>
                 <a:ea typeface="Courier New" pitchFamily="34" charset="-122"/>
@@ -12268,13 +13421,13 @@
             <a:r>
               <a:rPr lang="en-US" sz="1050" dirty="0">
                 <a:solidFill>
-                  <a:srgbClr val="E8ECEF"/>
-                </a:solidFill>
-                <a:latin typeface="Courier New" pitchFamily="34" charset="0"/>
-                <a:ea typeface="Courier New" pitchFamily="34" charset="-122"/>
-                <a:cs typeface="Courier New" pitchFamily="34" charset="-120"/>
-              </a:rPr>
-              <a:t>: </a:t>
+                  <a:srgbClr val="CCCCCC"/>
+                </a:solidFill>
+                <a:latin typeface="Courier New" pitchFamily="34" charset="0"/>
+                <a:ea typeface="Courier New" pitchFamily="34" charset="-122"/>
+                <a:cs typeface="Courier New" pitchFamily="34" charset="-120"/>
+              </a:rPr>
+              <a:t>:</a:t>
             </a:r>
             <a:pPr indent="0" marL="0">
               <a:lnSpc>
@@ -12285,7 +13438,24 @@
             <a:r>
               <a:rPr lang="en-US" sz="1050" dirty="0">
                 <a:solidFill>
-                  <a:srgbClr val="8FD694"/>
+                  <a:srgbClr val="CCCCCC"/>
+                </a:solidFill>
+                <a:latin typeface="Courier New" pitchFamily="34" charset="0"/>
+                <a:ea typeface="Courier New" pitchFamily="34" charset="-122"/>
+                <a:cs typeface="Courier New" pitchFamily="34" charset="-120"/>
+              </a:rPr>
+              <a:t> </a:t>
+            </a:r>
+            <a:pPr indent="0" marL="0">
+              <a:lnSpc>
+                <a:spcPct val="105000"/>
+              </a:lnSpc>
+              <a:buNone/>
+            </a:pPr>
+            <a:r>
+              <a:rPr lang="en-US" sz="1050" dirty="0">
+                <a:solidFill>
+                  <a:srgbClr val="CE9178"/>
                 </a:solidFill>
                 <a:latin typeface="Courier New" pitchFamily="34" charset="0"/>
                 <a:ea typeface="Courier New" pitchFamily="34" charset="-122"/>
@@ -12305,13 +13475,81 @@
             <a:r>
               <a:rPr lang="en-US" sz="1050" dirty="0">
                 <a:solidFill>
-                  <a:srgbClr val="E8ECEF"/>
-                </a:solidFill>
-                <a:latin typeface="Courier New" pitchFamily="34" charset="0"/>
-                <a:ea typeface="Courier New" pitchFamily="34" charset="-122"/>
-                <a:cs typeface="Courier New" pitchFamily="34" charset="-120"/>
-              </a:rPr>
-              <a:t>      } }</a:t>
+                  <a:srgbClr val="6E7681"/>
+                </a:solidFill>
+                <a:latin typeface="Courier New" pitchFamily="34" charset="0"/>
+                <a:ea typeface="Courier New" pitchFamily="34" charset="-122"/>
+                <a:cs typeface="Courier New" pitchFamily="34" charset="-120"/>
+              </a:rPr>
+              <a:t>12  </a:t>
+            </a:r>
+            <a:pPr indent="0" marL="0">
+              <a:lnSpc>
+                <a:spcPct val="105000"/>
+              </a:lnSpc>
+              <a:buNone/>
+            </a:pPr>
+            <a:r>
+              <a:rPr lang="en-US" sz="1050" dirty="0">
+                <a:solidFill>
+                  <a:srgbClr val="CCCCCC"/>
+                </a:solidFill>
+                <a:latin typeface="Courier New" pitchFamily="34" charset="0"/>
+                <a:ea typeface="Courier New" pitchFamily="34" charset="-122"/>
+                <a:cs typeface="Courier New" pitchFamily="34" charset="-120"/>
+              </a:rPr>
+              <a:t>      </a:t>
+            </a:r>
+            <a:pPr indent="0" marL="0">
+              <a:lnSpc>
+                <a:spcPct val="105000"/>
+              </a:lnSpc>
+              <a:buNone/>
+            </a:pPr>
+            <a:r>
+              <a:rPr lang="en-US" sz="1050" dirty="0">
+                <a:solidFill>
+                  <a:srgbClr val="CCCCCC"/>
+                </a:solidFill>
+                <a:latin typeface="Courier New" pitchFamily="34" charset="0"/>
+                <a:ea typeface="Courier New" pitchFamily="34" charset="-122"/>
+                <a:cs typeface="Courier New" pitchFamily="34" charset="-120"/>
+              </a:rPr>
+              <a:t>}</a:t>
+            </a:r>
+            <a:pPr indent="0" marL="0">
+              <a:lnSpc>
+                <a:spcPct val="105000"/>
+              </a:lnSpc>
+              <a:buNone/>
+            </a:pPr>
+            <a:r>
+              <a:rPr lang="en-US" sz="1050" dirty="0">
+                <a:solidFill>
+                  <a:srgbClr val="CCCCCC"/>
+                </a:solidFill>
+                <a:latin typeface="Courier New" pitchFamily="34" charset="0"/>
+                <a:ea typeface="Courier New" pitchFamily="34" charset="-122"/>
+                <a:cs typeface="Courier New" pitchFamily="34" charset="-120"/>
+              </a:rPr>
+              <a:t> </a:t>
+            </a:r>
+            <a:pPr indent="0" marL="0">
+              <a:lnSpc>
+                <a:spcPct val="105000"/>
+              </a:lnSpc>
+              <a:buNone/>
+            </a:pPr>
+            <a:r>
+              <a:rPr lang="en-US" sz="1050" dirty="0">
+                <a:solidFill>
+                  <a:srgbClr val="CCCCCC"/>
+                </a:solidFill>
+                <a:latin typeface="Courier New" pitchFamily="34" charset="0"/>
+                <a:ea typeface="Courier New" pitchFamily="34" charset="-122"/>
+                <a:cs typeface="Courier New" pitchFamily="34" charset="-120"/>
+              </a:rPr>
+              <a:t>}</a:t>
             </a:r>
             <a:endParaRPr lang="en-US" sz="1050" dirty="0"/>
           </a:p>
@@ -12325,13 +13563,47 @@
             <a:r>
               <a:rPr lang="en-US" sz="1050" dirty="0">
                 <a:solidFill>
-                  <a:srgbClr val="E8ECEF"/>
-                </a:solidFill>
-                <a:latin typeface="Courier New" pitchFamily="34" charset="0"/>
-                <a:ea typeface="Courier New" pitchFamily="34" charset="-122"/>
-                <a:cs typeface="Courier New" pitchFamily="34" charset="-120"/>
-              </a:rPr>
-              <a:t>    },</a:t>
+                  <a:srgbClr val="6E7681"/>
+                </a:solidFill>
+                <a:latin typeface="Courier New" pitchFamily="34" charset="0"/>
+                <a:ea typeface="Courier New" pitchFamily="34" charset="-122"/>
+                <a:cs typeface="Courier New" pitchFamily="34" charset="-120"/>
+              </a:rPr>
+              <a:t>13  </a:t>
+            </a:r>
+            <a:pPr indent="0" marL="0">
+              <a:lnSpc>
+                <a:spcPct val="105000"/>
+              </a:lnSpc>
+              <a:buNone/>
+            </a:pPr>
+            <a:r>
+              <a:rPr lang="en-US" sz="1050" dirty="0">
+                <a:solidFill>
+                  <a:srgbClr val="CCCCCC"/>
+                </a:solidFill>
+                <a:latin typeface="Courier New" pitchFamily="34" charset="0"/>
+                <a:ea typeface="Courier New" pitchFamily="34" charset="-122"/>
+                <a:cs typeface="Courier New" pitchFamily="34" charset="-120"/>
+              </a:rPr>
+              <a:t>    </a:t>
+            </a:r>
+            <a:pPr indent="0" marL="0">
+              <a:lnSpc>
+                <a:spcPct val="105000"/>
+              </a:lnSpc>
+              <a:buNone/>
+            </a:pPr>
+            <a:r>
+              <a:rPr lang="en-US" sz="1050" dirty="0">
+                <a:solidFill>
+                  <a:srgbClr val="CCCCCC"/>
+                </a:solidFill>
+                <a:latin typeface="Courier New" pitchFamily="34" charset="0"/>
+                <a:ea typeface="Courier New" pitchFamily="34" charset="-122"/>
+                <a:cs typeface="Courier New" pitchFamily="34" charset="-120"/>
+              </a:rPr>
+              <a:t>},</a:t>
             </a:r>
             <a:endParaRPr lang="en-US" sz="1050" dirty="0"/>
           </a:p>
@@ -12345,7 +13617,24 @@
             <a:r>
               <a:rPr lang="en-US" sz="1050" dirty="0">
                 <a:solidFill>
-                  <a:srgbClr val="E8ECEF"/>
+                  <a:srgbClr val="6E7681"/>
+                </a:solidFill>
+                <a:latin typeface="Courier New" pitchFamily="34" charset="0"/>
+                <a:ea typeface="Courier New" pitchFamily="34" charset="-122"/>
+                <a:cs typeface="Courier New" pitchFamily="34" charset="-120"/>
+              </a:rPr>
+              <a:t>14  </a:t>
+            </a:r>
+            <a:pPr indent="0" marL="0">
+              <a:lnSpc>
+                <a:spcPct val="105000"/>
+              </a:lnSpc>
+              <a:buNone/>
+            </a:pPr>
+            <a:r>
+              <a:rPr lang="en-US" sz="1050" dirty="0">
+                <a:solidFill>
+                  <a:srgbClr val="CCCCCC"/>
                 </a:solidFill>
                 <a:latin typeface="Courier New" pitchFamily="34" charset="0"/>
                 <a:ea typeface="Courier New" pitchFamily="34" charset="-122"/>
@@ -12362,7 +13651,7 @@
             <a:r>
               <a:rPr lang="en-US" sz="1050" dirty="0">
                 <a:solidFill>
-                  <a:srgbClr val="4DB1FF"/>
+                  <a:srgbClr val="9CDCFE"/>
                 </a:solidFill>
                 <a:latin typeface="Courier New" pitchFamily="34" charset="0"/>
                 <a:ea typeface="Courier New" pitchFamily="34" charset="-122"/>
@@ -12379,13 +13668,47 @@
             <a:r>
               <a:rPr lang="en-US" sz="1050" dirty="0">
                 <a:solidFill>
-                  <a:srgbClr val="E8ECEF"/>
-                </a:solidFill>
-                <a:latin typeface="Courier New" pitchFamily="34" charset="0"/>
-                <a:ea typeface="Courier New" pitchFamily="34" charset="-122"/>
-                <a:cs typeface="Courier New" pitchFamily="34" charset="-120"/>
-              </a:rPr>
-              <a:t>: {</a:t>
+                  <a:srgbClr val="CCCCCC"/>
+                </a:solidFill>
+                <a:latin typeface="Courier New" pitchFamily="34" charset="0"/>
+                <a:ea typeface="Courier New" pitchFamily="34" charset="-122"/>
+                <a:cs typeface="Courier New" pitchFamily="34" charset="-120"/>
+              </a:rPr>
+              <a:t>:</a:t>
+            </a:r>
+            <a:pPr indent="0" marL="0">
+              <a:lnSpc>
+                <a:spcPct val="105000"/>
+              </a:lnSpc>
+              <a:buNone/>
+            </a:pPr>
+            <a:r>
+              <a:rPr lang="en-US" sz="1050" dirty="0">
+                <a:solidFill>
+                  <a:srgbClr val="CCCCCC"/>
+                </a:solidFill>
+                <a:latin typeface="Courier New" pitchFamily="34" charset="0"/>
+                <a:ea typeface="Courier New" pitchFamily="34" charset="-122"/>
+                <a:cs typeface="Courier New" pitchFamily="34" charset="-120"/>
+              </a:rPr>
+              <a:t> </a:t>
+            </a:r>
+            <a:pPr indent="0" marL="0">
+              <a:lnSpc>
+                <a:spcPct val="105000"/>
+              </a:lnSpc>
+              <a:buNone/>
+            </a:pPr>
+            <a:r>
+              <a:rPr lang="en-US" sz="1050" dirty="0">
+                <a:solidFill>
+                  <a:srgbClr val="CCCCCC"/>
+                </a:solidFill>
+                <a:latin typeface="Courier New" pitchFamily="34" charset="0"/>
+                <a:ea typeface="Courier New" pitchFamily="34" charset="-122"/>
+                <a:cs typeface="Courier New" pitchFamily="34" charset="-120"/>
+              </a:rPr>
+              <a:t>{</a:t>
             </a:r>
             <a:endParaRPr lang="en-US" sz="1050" dirty="0"/>
           </a:p>
@@ -12399,7 +13722,24 @@
             <a:r>
               <a:rPr lang="en-US" sz="1050" dirty="0">
                 <a:solidFill>
-                  <a:srgbClr val="E8ECEF"/>
+                  <a:srgbClr val="6E7681"/>
+                </a:solidFill>
+                <a:latin typeface="Courier New" pitchFamily="34" charset="0"/>
+                <a:ea typeface="Courier New" pitchFamily="34" charset="-122"/>
+                <a:cs typeface="Courier New" pitchFamily="34" charset="-120"/>
+              </a:rPr>
+              <a:t>15  </a:t>
+            </a:r>
+            <a:pPr indent="0" marL="0">
+              <a:lnSpc>
+                <a:spcPct val="105000"/>
+              </a:lnSpc>
+              <a:buNone/>
+            </a:pPr>
+            <a:r>
+              <a:rPr lang="en-US" sz="1050" dirty="0">
+                <a:solidFill>
+                  <a:srgbClr val="CCCCCC"/>
                 </a:solidFill>
                 <a:latin typeface="Courier New" pitchFamily="34" charset="0"/>
                 <a:ea typeface="Courier New" pitchFamily="34" charset="-122"/>
@@ -12416,7 +13756,7 @@
             <a:r>
               <a:rPr lang="en-US" sz="1050" dirty="0">
                 <a:solidFill>
-                  <a:srgbClr val="4DB1FF"/>
+                  <a:srgbClr val="9CDCFE"/>
                 </a:solidFill>
                 <a:latin typeface="Courier New" pitchFamily="34" charset="0"/>
                 <a:ea typeface="Courier New" pitchFamily="34" charset="-122"/>
@@ -12433,13 +13773,13 @@
             <a:r>
               <a:rPr lang="en-US" sz="1050" dirty="0">
                 <a:solidFill>
-                  <a:srgbClr val="E8ECEF"/>
-                </a:solidFill>
-                <a:latin typeface="Courier New" pitchFamily="34" charset="0"/>
-                <a:ea typeface="Courier New" pitchFamily="34" charset="-122"/>
-                <a:cs typeface="Courier New" pitchFamily="34" charset="-120"/>
-              </a:rPr>
-              <a:t>: </a:t>
+                  <a:srgbClr val="CCCCCC"/>
+                </a:solidFill>
+                <a:latin typeface="Courier New" pitchFamily="34" charset="0"/>
+                <a:ea typeface="Courier New" pitchFamily="34" charset="-122"/>
+                <a:cs typeface="Courier New" pitchFamily="34" charset="-120"/>
+              </a:rPr>
+              <a:t>:</a:t>
             </a:r>
             <a:pPr indent="0" marL="0">
               <a:lnSpc>
@@ -12450,7 +13790,24 @@
             <a:r>
               <a:rPr lang="en-US" sz="1050" dirty="0">
                 <a:solidFill>
-                  <a:srgbClr val="8FD694"/>
+                  <a:srgbClr val="CCCCCC"/>
+                </a:solidFill>
+                <a:latin typeface="Courier New" pitchFamily="34" charset="0"/>
+                <a:ea typeface="Courier New" pitchFamily="34" charset="-122"/>
+                <a:cs typeface="Courier New" pitchFamily="34" charset="-120"/>
+              </a:rPr>
+              <a:t> </a:t>
+            </a:r>
+            <a:pPr indent="0" marL="0">
+              <a:lnSpc>
+                <a:spcPct val="105000"/>
+              </a:lnSpc>
+              <a:buNone/>
+            </a:pPr>
+            <a:r>
+              <a:rPr lang="en-US" sz="1050" dirty="0">
+                <a:solidFill>
+                  <a:srgbClr val="CE9178"/>
                 </a:solidFill>
                 <a:latin typeface="Courier New" pitchFamily="34" charset="0"/>
                 <a:ea typeface="Courier New" pitchFamily="34" charset="-122"/>
@@ -12467,13 +13824,47 @@
             <a:r>
               <a:rPr lang="en-US" sz="1050" dirty="0">
                 <a:solidFill>
-                  <a:srgbClr val="E8ECEF"/>
-                </a:solidFill>
-                <a:latin typeface="Courier New" pitchFamily="34" charset="0"/>
-                <a:ea typeface="Courier New" pitchFamily="34" charset="-122"/>
-                <a:cs typeface="Courier New" pitchFamily="34" charset="-120"/>
-              </a:rPr>
-              <a:t>, ...</a:t>
+                  <a:srgbClr val="CCCCCC"/>
+                </a:solidFill>
+                <a:latin typeface="Courier New" pitchFamily="34" charset="0"/>
+                <a:ea typeface="Courier New" pitchFamily="34" charset="-122"/>
+                <a:cs typeface="Courier New" pitchFamily="34" charset="-120"/>
+              </a:rPr>
+              <a:t>,</a:t>
+            </a:r>
+            <a:pPr indent="0" marL="0">
+              <a:lnSpc>
+                <a:spcPct val="105000"/>
+              </a:lnSpc>
+              <a:buNone/>
+            </a:pPr>
+            <a:r>
+              <a:rPr lang="en-US" sz="1050" dirty="0">
+                <a:solidFill>
+                  <a:srgbClr val="CCCCCC"/>
+                </a:solidFill>
+                <a:latin typeface="Courier New" pitchFamily="34" charset="0"/>
+                <a:ea typeface="Courier New" pitchFamily="34" charset="-122"/>
+                <a:cs typeface="Courier New" pitchFamily="34" charset="-120"/>
+              </a:rPr>
+              <a:t> </a:t>
+            </a:r>
+            <a:pPr indent="0" marL="0">
+              <a:lnSpc>
+                <a:spcPct val="105000"/>
+              </a:lnSpc>
+              <a:buNone/>
+            </a:pPr>
+            <a:r>
+              <a:rPr lang="en-US" sz="1050" dirty="0">
+                <a:solidFill>
+                  <a:srgbClr val="CCCCCC"/>
+                </a:solidFill>
+                <a:latin typeface="Courier New" pitchFamily="34" charset="0"/>
+                <a:ea typeface="Courier New" pitchFamily="34" charset="-122"/>
+                <a:cs typeface="Courier New" pitchFamily="34" charset="-120"/>
+              </a:rPr>
+              <a:t>...</a:t>
             </a:r>
             <a:endParaRPr lang="en-US" sz="1050" dirty="0"/>
           </a:p>
@@ -15445,7 +16836,7 @@
       </p:pic>
       <p:sp>
         <p:nvSpPr>
-          <p:cNvPr id="7" name="Código"/>
+          <p:cNvPr id="7" name="Editor"/>
           <p:cNvSpPr/>
           <p:nvPr/>
         </p:nvSpPr>
@@ -15460,9 +16851,14 @@
             </a:avLst>
           </a:prstGeom>
           <a:solidFill>
-            <a:srgbClr val="12171C"/>
+            <a:srgbClr val="1F1F1F"/>
           </a:solidFill>
-          <a:ln/>
+          <a:ln w="9525">
+            <a:solidFill>
+              <a:srgbClr val="2B2B2B"/>
+            </a:solidFill>
+            <a:prstDash val="solid"/>
+          </a:ln>
           <a:effectLst>
             <a:outerShdw sx="100000" sy="100000" kx="0" ky="0" algn="bl" rotWithShape="0" blurRad="101600" dist="25400" dir="5400000">
               <a:srgbClr val="223548">
@@ -15480,8 +16876,8 @@
         </p:nvSpPr>
         <p:spPr>
           <a:xfrm>
-            <a:off x="777240" y="5586984"/>
-            <a:ext cx="5449824" cy="475488"/>
+            <a:off x="731520" y="5586984"/>
+            <a:ext cx="5586984" cy="493776"/>
           </a:xfrm>
           <a:prstGeom prst="rect">
             <a:avLst/>
@@ -15500,9 +16896,26 @@
               <a:buNone/>
             </a:pPr>
             <a:r>
-              <a:rPr lang="en-US" sz="1100" dirty="0">
-                <a:solidFill>
-                  <a:srgbClr val="E8ECEF"/>
+              <a:rPr lang="en-US" sz="1000" dirty="0">
+                <a:solidFill>
+                  <a:srgbClr val="6E7681"/>
+                </a:solidFill>
+                <a:latin typeface="Courier New" pitchFamily="34" charset="0"/>
+                <a:ea typeface="Courier New" pitchFamily="34" charset="-122"/>
+                <a:cs typeface="Courier New" pitchFamily="34" charset="-120"/>
+              </a:rPr>
+              <a:t> 1  </a:t>
+            </a:r>
+            <a:pPr indent="0" marL="0">
+              <a:lnSpc>
+                <a:spcPct val="105000"/>
+              </a:lnSpc>
+              <a:buNone/>
+            </a:pPr>
+            <a:r>
+              <a:rPr lang="en-US" sz="1000" dirty="0">
+                <a:solidFill>
+                  <a:srgbClr val="DCDCAA"/>
                 </a:solidFill>
                 <a:latin typeface="Courier New" pitchFamily="34" charset="0"/>
                 <a:ea typeface="Courier New" pitchFamily="34" charset="-122"/>
@@ -15517,253 +16930,117 @@
               <a:buNone/>
             </a:pPr>
             <a:r>
-              <a:rPr lang="en-US" sz="1100" dirty="0">
-                <a:solidFill>
-                  <a:srgbClr val="E8ECEF"/>
-                </a:solidFill>
-                <a:latin typeface="Courier New" pitchFamily="34" charset="0"/>
-                <a:ea typeface="Courier New" pitchFamily="34" charset="-122"/>
-                <a:cs typeface="Courier New" pitchFamily="34" charset="-120"/>
-              </a:rPr>
-              <a:t> ...</a:t>
-            </a:r>
-            <a:pPr indent="0" marL="0">
-              <a:lnSpc>
-                <a:spcPct val="105000"/>
-              </a:lnSpc>
-              <a:buNone/>
-            </a:pPr>
-            <a:r>
-              <a:rPr lang="en-US" sz="1100" dirty="0">
-                <a:solidFill>
-                  <a:srgbClr val="E8ECEF"/>
-                </a:solidFill>
-                <a:latin typeface="Courier New" pitchFamily="34" charset="0"/>
-                <a:ea typeface="Courier New" pitchFamily="34" charset="-122"/>
-                <a:cs typeface="Courier New" pitchFamily="34" charset="-120"/>
-              </a:rPr>
-              <a:t>/</a:t>
-            </a:r>
-            <a:pPr indent="0" marL="0">
-              <a:lnSpc>
-                <a:spcPct val="105000"/>
-              </a:lnSpc>
-              <a:buNone/>
-            </a:pPr>
-            <a:r>
-              <a:rPr lang="en-US" sz="1100" dirty="0">
-                <a:solidFill>
-                  <a:srgbClr val="E8ECEF"/>
-                </a:solidFill>
-                <a:latin typeface="Courier New" pitchFamily="34" charset="0"/>
-                <a:ea typeface="Courier New" pitchFamily="34" charset="-122"/>
-                <a:cs typeface="Courier New" pitchFamily="34" charset="-120"/>
-              </a:rPr>
-              <a:t>zui_pc_analitico</a:t>
-            </a:r>
-            <a:pPr indent="0" marL="0">
-              <a:lnSpc>
-                <a:spcPct val="105000"/>
-              </a:lnSpc>
-              <a:buNone/>
-            </a:pPr>
-            <a:r>
-              <a:rPr lang="en-US" sz="1100" dirty="0">
-                <a:solidFill>
-                  <a:srgbClr val="E8ECEF"/>
-                </a:solidFill>
-                <a:latin typeface="Courier New" pitchFamily="34" charset="0"/>
-                <a:ea typeface="Courier New" pitchFamily="34" charset="-122"/>
-                <a:cs typeface="Courier New" pitchFamily="34" charset="-120"/>
-              </a:rPr>
-              <a:t>/</a:t>
-            </a:r>
-            <a:pPr indent="0" marL="0">
-              <a:lnSpc>
-                <a:spcPct val="105000"/>
-              </a:lnSpc>
-              <a:buNone/>
-            </a:pPr>
-            <a:r>
-              <a:rPr lang="en-US" sz="1100" dirty="0">
-                <a:solidFill>
-                  <a:srgbClr val="FF9F80"/>
-                </a:solidFill>
-                <a:latin typeface="Courier New" pitchFamily="34" charset="0"/>
-                <a:ea typeface="Courier New" pitchFamily="34" charset="-122"/>
-                <a:cs typeface="Courier New" pitchFamily="34" charset="-120"/>
-              </a:rPr>
-              <a:t>0001</a:t>
-            </a:r>
-            <a:pPr indent="0" marL="0">
-              <a:lnSpc>
-                <a:spcPct val="105000"/>
-              </a:lnSpc>
-              <a:buNone/>
-            </a:pPr>
-            <a:r>
-              <a:rPr lang="en-US" sz="1100" dirty="0">
-                <a:solidFill>
-                  <a:srgbClr val="E8ECEF"/>
-                </a:solidFill>
-                <a:latin typeface="Courier New" pitchFamily="34" charset="0"/>
-                <a:ea typeface="Courier New" pitchFamily="34" charset="-122"/>
-                <a:cs typeface="Courier New" pitchFamily="34" charset="-120"/>
-              </a:rPr>
-              <a:t>/</a:t>
-            </a:r>
-            <a:pPr indent="0" marL="0">
-              <a:lnSpc>
-                <a:spcPct val="105000"/>
-              </a:lnSpc>
-              <a:buNone/>
-            </a:pPr>
-            <a:r>
-              <a:rPr lang="en-US" sz="1100" dirty="0">
-                <a:solidFill>
-                  <a:srgbClr val="E8ECEF"/>
-                </a:solidFill>
-                <a:latin typeface="Courier New" pitchFamily="34" charset="0"/>
-                <a:ea typeface="Courier New" pitchFamily="34" charset="-122"/>
-                <a:cs typeface="Courier New" pitchFamily="34" charset="-120"/>
-              </a:rPr>
-              <a:t>ClienteAnalise</a:t>
-            </a:r>
-            <a:endParaRPr lang="en-US" sz="1100" dirty="0"/>
-          </a:p>
-          <a:p>
-            <a:pPr indent="0" marL="0">
-              <a:lnSpc>
-                <a:spcPct val="105000"/>
-              </a:lnSpc>
-              <a:buNone/>
-            </a:pPr>
-            <a:r>
-              <a:rPr lang="en-US" sz="1100" dirty="0">
-                <a:solidFill>
-                  <a:srgbClr val="E8ECEF"/>
-                </a:solidFill>
-                <a:latin typeface="Courier New" pitchFamily="34" charset="0"/>
-                <a:ea typeface="Courier New" pitchFamily="34" charset="-122"/>
-                <a:cs typeface="Courier New" pitchFamily="34" charset="-120"/>
-              </a:rPr>
-              <a:t>    ?$</a:t>
-            </a:r>
-            <a:pPr indent="0" marL="0">
-              <a:lnSpc>
-                <a:spcPct val="105000"/>
-              </a:lnSpc>
-              <a:buNone/>
-            </a:pPr>
-            <a:r>
-              <a:rPr lang="en-US" sz="1100" dirty="0">
-                <a:solidFill>
-                  <a:srgbClr val="E8ECEF"/>
-                </a:solidFill>
-                <a:latin typeface="Courier New" pitchFamily="34" charset="0"/>
-                <a:ea typeface="Courier New" pitchFamily="34" charset="-122"/>
-                <a:cs typeface="Courier New" pitchFamily="34" charset="-120"/>
-              </a:rPr>
-              <a:t>apply</a:t>
-            </a:r>
-            <a:pPr indent="0" marL="0">
-              <a:lnSpc>
-                <a:spcPct val="105000"/>
-              </a:lnSpc>
-              <a:buNone/>
-            </a:pPr>
-            <a:r>
-              <a:rPr lang="en-US" sz="1100" dirty="0">
-                <a:solidFill>
-                  <a:srgbClr val="E8ECEF"/>
-                </a:solidFill>
-                <a:latin typeface="Courier New" pitchFamily="34" charset="0"/>
-                <a:ea typeface="Courier New" pitchFamily="34" charset="-122"/>
-                <a:cs typeface="Courier New" pitchFamily="34" charset="-120"/>
-              </a:rPr>
-              <a:t>=</a:t>
-            </a:r>
-            <a:pPr indent="0" marL="0">
-              <a:lnSpc>
-                <a:spcPct val="105000"/>
-              </a:lnSpc>
-              <a:buNone/>
-            </a:pPr>
-            <a:r>
-              <a:rPr lang="en-US" sz="1100" dirty="0">
-                <a:solidFill>
-                  <a:srgbClr val="E8ECEF"/>
-                </a:solidFill>
-                <a:latin typeface="Courier New" pitchFamily="34" charset="0"/>
-                <a:ea typeface="Courier New" pitchFamily="34" charset="-122"/>
-                <a:cs typeface="Courier New" pitchFamily="34" charset="-120"/>
-              </a:rPr>
-              <a:t>groupby</a:t>
-            </a:r>
-            <a:pPr indent="0" marL="0">
-              <a:lnSpc>
-                <a:spcPct val="105000"/>
-              </a:lnSpc>
-              <a:buNone/>
-            </a:pPr>
-            <a:r>
-              <a:rPr lang="en-US" sz="1100" dirty="0">
-                <a:solidFill>
-                  <a:srgbClr val="E8ECEF"/>
-                </a:solidFill>
-                <a:latin typeface="Courier New" pitchFamily="34" charset="0"/>
-                <a:ea typeface="Courier New" pitchFamily="34" charset="-122"/>
-                <a:cs typeface="Courier New" pitchFamily="34" charset="-120"/>
-              </a:rPr>
-              <a:t>((</a:t>
-            </a:r>
-            <a:pPr indent="0" marL="0">
-              <a:lnSpc>
-                <a:spcPct val="105000"/>
-              </a:lnSpc>
-              <a:buNone/>
-            </a:pPr>
-            <a:r>
-              <a:rPr lang="en-US" sz="1100" dirty="0">
-                <a:solidFill>
-                  <a:srgbClr val="E8ECEF"/>
-                </a:solidFill>
-                <a:latin typeface="Courier New" pitchFamily="34" charset="0"/>
-                <a:ea typeface="Courier New" pitchFamily="34" charset="-122"/>
-                <a:cs typeface="Courier New" pitchFamily="34" charset="-120"/>
-              </a:rPr>
-              <a:t>Genero</a:t>
-            </a:r>
-            <a:pPr indent="0" marL="0">
-              <a:lnSpc>
-                <a:spcPct val="105000"/>
-              </a:lnSpc>
-              <a:buNone/>
-            </a:pPr>
-            <a:r>
-              <a:rPr lang="en-US" sz="1100" dirty="0">
-                <a:solidFill>
-                  <a:srgbClr val="E8ECEF"/>
-                </a:solidFill>
-                <a:latin typeface="Courier New" pitchFamily="34" charset="0"/>
-                <a:ea typeface="Courier New" pitchFamily="34" charset="-122"/>
-                <a:cs typeface="Courier New" pitchFamily="34" charset="-120"/>
-              </a:rPr>
-              <a:t>),</a:t>
-            </a:r>
-            <a:endParaRPr lang="en-US" sz="1100" dirty="0"/>
-          </a:p>
-          <a:p>
-            <a:pPr indent="0" marL="0">
-              <a:lnSpc>
-                <a:spcPct val="105000"/>
-              </a:lnSpc>
-              <a:buNone/>
-            </a:pPr>
-            <a:r>
-              <a:rPr lang="en-US" sz="1100" dirty="0">
-                <a:solidFill>
-                  <a:srgbClr val="E8ECEF"/>
+              <a:rPr lang="en-US" sz="1000" dirty="0">
+                <a:solidFill>
+                  <a:srgbClr val="CCCCCC"/>
+                </a:solidFill>
+                <a:latin typeface="Courier New" pitchFamily="34" charset="0"/>
+                <a:ea typeface="Courier New" pitchFamily="34" charset="-122"/>
+                <a:cs typeface="Courier New" pitchFamily="34" charset="-120"/>
+              </a:rPr>
+              <a:t> </a:t>
+            </a:r>
+            <a:pPr indent="0" marL="0">
+              <a:lnSpc>
+                <a:spcPct val="105000"/>
+              </a:lnSpc>
+              <a:buNone/>
+            </a:pPr>
+            <a:r>
+              <a:rPr lang="en-US" sz="1000" dirty="0">
+                <a:solidFill>
+                  <a:srgbClr val="CCCCCC"/>
+                </a:solidFill>
+                <a:latin typeface="Courier New" pitchFamily="34" charset="0"/>
+                <a:ea typeface="Courier New" pitchFamily="34" charset="-122"/>
+                <a:cs typeface="Courier New" pitchFamily="34" charset="-120"/>
+              </a:rPr>
+              <a:t>.../zui_pc_analitico/0001/ClienteAnalise</a:t>
+            </a:r>
+            <a:endParaRPr lang="en-US" sz="1000" dirty="0"/>
+          </a:p>
+          <a:p>
+            <a:pPr indent="0" marL="0">
+              <a:lnSpc>
+                <a:spcPct val="105000"/>
+              </a:lnSpc>
+              <a:buNone/>
+            </a:pPr>
+            <a:r>
+              <a:rPr lang="en-US" sz="1000" dirty="0">
+                <a:solidFill>
+                  <a:srgbClr val="6E7681"/>
+                </a:solidFill>
+                <a:latin typeface="Courier New" pitchFamily="34" charset="0"/>
+                <a:ea typeface="Courier New" pitchFamily="34" charset="-122"/>
+                <a:cs typeface="Courier New" pitchFamily="34" charset="-120"/>
+              </a:rPr>
+              <a:t> 2  </a:t>
+            </a:r>
+            <a:pPr indent="0" marL="0">
+              <a:lnSpc>
+                <a:spcPct val="105000"/>
+              </a:lnSpc>
+              <a:buNone/>
+            </a:pPr>
+            <a:r>
+              <a:rPr lang="en-US" sz="1000" dirty="0">
+                <a:solidFill>
+                  <a:srgbClr val="CCCCCC"/>
+                </a:solidFill>
+                <a:latin typeface="Courier New" pitchFamily="34" charset="0"/>
+                <a:ea typeface="Courier New" pitchFamily="34" charset="-122"/>
+                <a:cs typeface="Courier New" pitchFamily="34" charset="-120"/>
+              </a:rPr>
+              <a:t>    </a:t>
+            </a:r>
+            <a:pPr indent="0" marL="0">
+              <a:lnSpc>
+                <a:spcPct val="105000"/>
+              </a:lnSpc>
+              <a:buNone/>
+            </a:pPr>
+            <a:r>
+              <a:rPr lang="en-US" sz="1000" dirty="0">
+                <a:solidFill>
+                  <a:srgbClr val="DCDCAA"/>
+                </a:solidFill>
+                <a:latin typeface="Courier New" pitchFamily="34" charset="0"/>
+                <a:ea typeface="Courier New" pitchFamily="34" charset="-122"/>
+                <a:cs typeface="Courier New" pitchFamily="34" charset="-120"/>
+              </a:rPr>
+              <a:t>?$apply=groupby((Genero),</a:t>
+            </a:r>
+            <a:endParaRPr lang="en-US" sz="1000" dirty="0"/>
+          </a:p>
+          <a:p>
+            <a:pPr indent="0" marL="0">
+              <a:lnSpc>
+                <a:spcPct val="105000"/>
+              </a:lnSpc>
+              <a:buNone/>
+            </a:pPr>
+            <a:r>
+              <a:rPr lang="en-US" sz="1000" dirty="0">
+                <a:solidFill>
+                  <a:srgbClr val="6E7681"/>
+                </a:solidFill>
+                <a:latin typeface="Courier New" pitchFamily="34" charset="0"/>
+                <a:ea typeface="Courier New" pitchFamily="34" charset="-122"/>
+                <a:cs typeface="Courier New" pitchFamily="34" charset="-120"/>
+              </a:rPr>
+              <a:t> 3  </a:t>
+            </a:r>
+            <a:pPr indent="0" marL="0">
+              <a:lnSpc>
+                <a:spcPct val="105000"/>
+              </a:lnSpc>
+              <a:buNone/>
+            </a:pPr>
+            <a:r>
+              <a:rPr lang="en-US" sz="1000" dirty="0">
+                <a:solidFill>
+                  <a:srgbClr val="CCCCCC"/>
                 </a:solidFill>
                 <a:latin typeface="Courier New" pitchFamily="34" charset="0"/>
                 <a:ea typeface="Courier New" pitchFamily="34" charset="-122"/>
@@ -15778,68 +17055,17 @@
               <a:buNone/>
             </a:pPr>
             <a:r>
-              <a:rPr lang="en-US" sz="1100" dirty="0">
-                <a:solidFill>
-                  <a:srgbClr val="E8ECEF"/>
-                </a:solidFill>
-                <a:latin typeface="Courier New" pitchFamily="34" charset="0"/>
-                <a:ea typeface="Courier New" pitchFamily="34" charset="-122"/>
-                <a:cs typeface="Courier New" pitchFamily="34" charset="-120"/>
-              </a:rPr>
-              <a:t>aggregate</a:t>
-            </a:r>
-            <a:pPr indent="0" marL="0">
-              <a:lnSpc>
-                <a:spcPct val="105000"/>
-              </a:lnSpc>
-              <a:buNone/>
-            </a:pPr>
-            <a:r>
-              <a:rPr lang="en-US" sz="1100" dirty="0">
-                <a:solidFill>
-                  <a:srgbClr val="E8ECEF"/>
-                </a:solidFill>
-                <a:latin typeface="Courier New" pitchFamily="34" charset="0"/>
-                <a:ea typeface="Courier New" pitchFamily="34" charset="-122"/>
-                <a:cs typeface="Courier New" pitchFamily="34" charset="-120"/>
-              </a:rPr>
-              <a:t>(</a:t>
-            </a:r>
-            <a:pPr indent="0" marL="0">
-              <a:lnSpc>
-                <a:spcPct val="105000"/>
-              </a:lnSpc>
-              <a:buNone/>
-            </a:pPr>
-            <a:r>
-              <a:rPr lang="en-US" sz="1100" dirty="0">
-                <a:solidFill>
-                  <a:srgbClr val="E8ECEF"/>
-                </a:solidFill>
-                <a:latin typeface="Courier New" pitchFamily="34" charset="0"/>
-                <a:ea typeface="Courier New" pitchFamily="34" charset="-122"/>
-                <a:cs typeface="Courier New" pitchFamily="34" charset="-120"/>
-              </a:rPr>
-              <a:t>QtdeClientes</a:t>
-            </a:r>
-            <a:pPr indent="0" marL="0">
-              <a:lnSpc>
-                <a:spcPct val="105000"/>
-              </a:lnSpc>
-              <a:buNone/>
-            </a:pPr>
-            <a:r>
-              <a:rPr lang="en-US" sz="1100" dirty="0">
-                <a:solidFill>
-                  <a:srgbClr val="E8ECEF"/>
-                </a:solidFill>
-                <a:latin typeface="Courier New" pitchFamily="34" charset="0"/>
-                <a:ea typeface="Courier New" pitchFamily="34" charset="-122"/>
-                <a:cs typeface="Courier New" pitchFamily="34" charset="-120"/>
-              </a:rPr>
-              <a:t>))</a:t>
-            </a:r>
-            <a:endParaRPr lang="en-US" sz="1100" dirty="0"/>
+              <a:rPr lang="en-US" sz="1000" dirty="0">
+                <a:solidFill>
+                  <a:srgbClr val="DCDCAA"/>
+                </a:solidFill>
+                <a:latin typeface="Courier New" pitchFamily="34" charset="0"/>
+                <a:ea typeface="Courier New" pitchFamily="34" charset="-122"/>
+                <a:cs typeface="Courier New" pitchFamily="34" charset="-120"/>
+              </a:rPr>
+              <a:t>aggregate(QtdeClientes))</a:t>
+            </a:r>
+            <a:endParaRPr lang="en-US" sz="1000" dirty="0"/>
           </a:p>
         </p:txBody>
       </p:sp>
@@ -17666,7 +18892,7 @@
       </p:pic>
       <p:sp>
         <p:nvSpPr>
-          <p:cNvPr id="7" name="Código"/>
+          <p:cNvPr id="7" name="Editor"/>
           <p:cNvSpPr/>
           <p:nvPr/>
         </p:nvSpPr>
@@ -17681,9 +18907,14 @@
             </a:avLst>
           </a:prstGeom>
           <a:solidFill>
-            <a:srgbClr val="12171C"/>
+            <a:srgbClr val="1F1F1F"/>
           </a:solidFill>
-          <a:ln/>
+          <a:ln w="9525">
+            <a:solidFill>
+              <a:srgbClr val="2B2B2B"/>
+            </a:solidFill>
+            <a:prstDash val="solid"/>
+          </a:ln>
           <a:effectLst>
             <a:outerShdw sx="100000" sy="100000" kx="0" ky="0" algn="bl" rotWithShape="0" blurRad="101600" dist="25400" dir="5400000">
               <a:srgbClr val="223548">
@@ -17701,8 +18932,8 @@
         </p:nvSpPr>
         <p:spPr>
           <a:xfrm>
-            <a:off x="8138160" y="1792224"/>
-            <a:ext cx="3276295" cy="2487168"/>
+            <a:off x="8092440" y="1792224"/>
+            <a:ext cx="3413455" cy="2505456"/>
           </a:xfrm>
           <a:prstGeom prst="rect">
             <a:avLst/>
@@ -17723,7 +18954,24 @@
             <a:r>
               <a:rPr lang="en-US" sz="1150" dirty="0">
                 <a:solidFill>
-                  <a:srgbClr val="E8ECEF"/>
+                  <a:srgbClr val="6E7681"/>
+                </a:solidFill>
+                <a:latin typeface="Courier New" pitchFamily="34" charset="0"/>
+                <a:ea typeface="Courier New" pitchFamily="34" charset="-122"/>
+                <a:cs typeface="Courier New" pitchFamily="34" charset="-120"/>
+              </a:rPr>
+              <a:t> 1  </a:t>
+            </a:r>
+            <a:pPr indent="0" marL="0">
+              <a:lnSpc>
+                <a:spcPct val="105000"/>
+              </a:lnSpc>
+              <a:buNone/>
+            </a:pPr>
+            <a:r>
+              <a:rPr lang="en-US" sz="1150" dirty="0">
+                <a:solidFill>
+                  <a:srgbClr val="DCDCAA"/>
                 </a:solidFill>
                 <a:latin typeface="Courier New" pitchFamily="34" charset="0"/>
                 <a:ea typeface="Courier New" pitchFamily="34" charset="-122"/>
@@ -17740,7 +18988,7 @@
             <a:r>
               <a:rPr lang="en-US" sz="1150" dirty="0">
                 <a:solidFill>
-                  <a:srgbClr val="E8ECEF"/>
+                  <a:srgbClr val="CCCCCC"/>
                 </a:solidFill>
                 <a:latin typeface="Courier New" pitchFamily="34" charset="0"/>
                 <a:ea typeface="Courier New" pitchFamily="34" charset="-122"/>
@@ -17757,14 +19005,17 @@
             <a:r>
               <a:rPr lang="en-US" sz="1150" dirty="0">
                 <a:solidFill>
-                  <a:srgbClr val="E8ECEF"/>
-                </a:solidFill>
-                <a:latin typeface="Courier New" pitchFamily="34" charset="0"/>
-                <a:ea typeface="Courier New" pitchFamily="34" charset="-122"/>
-                <a:cs typeface="Courier New" pitchFamily="34" charset="-120"/>
-              </a:rPr>
-              <a:t>ui5</a:t>
-            </a:r>
+                  <a:srgbClr val="CCCCCC"/>
+                </a:solidFill>
+                <a:latin typeface="Courier New" pitchFamily="34" charset="0"/>
+                <a:ea typeface="Courier New" pitchFamily="34" charset="-122"/>
+                <a:cs typeface="Courier New" pitchFamily="34" charset="-120"/>
+              </a:rPr>
+              <a:t>ui5/launchpad</a:t>
+            </a:r>
+            <a:endParaRPr lang="en-US" sz="1150" dirty="0"/>
+          </a:p>
+          <a:p>
             <a:pPr indent="0" marL="0">
               <a:lnSpc>
                 <a:spcPct val="105000"/>
@@ -17774,13 +19025,13 @@
             <a:r>
               <a:rPr lang="en-US" sz="1150" dirty="0">
                 <a:solidFill>
-                  <a:srgbClr val="E8ECEF"/>
-                </a:solidFill>
-                <a:latin typeface="Courier New" pitchFamily="34" charset="0"/>
-                <a:ea typeface="Courier New" pitchFamily="34" charset="-122"/>
-                <a:cs typeface="Courier New" pitchFamily="34" charset="-120"/>
-              </a:rPr>
-              <a:t>/</a:t>
+                  <a:srgbClr val="6E7681"/>
+                </a:solidFill>
+                <a:latin typeface="Courier New" pitchFamily="34" charset="0"/>
+                <a:ea typeface="Courier New" pitchFamily="34" charset="-122"/>
+                <a:cs typeface="Courier New" pitchFamily="34" charset="-120"/>
+              </a:rPr>
+              <a:t> 2  </a:t>
             </a:r>
             <a:pPr indent="0" marL="0">
               <a:lnSpc>
@@ -17791,13 +19042,47 @@
             <a:r>
               <a:rPr lang="en-US" sz="1150" dirty="0">
                 <a:solidFill>
-                  <a:srgbClr val="E8ECEF"/>
-                </a:solidFill>
-                <a:latin typeface="Courier New" pitchFamily="34" charset="0"/>
-                <a:ea typeface="Courier New" pitchFamily="34" charset="-122"/>
-                <a:cs typeface="Courier New" pitchFamily="34" charset="-120"/>
-              </a:rPr>
-              <a:t>launchpad</a:t>
+                  <a:srgbClr val="DCDCAA"/>
+                </a:solidFill>
+                <a:latin typeface="Courier New" pitchFamily="34" charset="0"/>
+                <a:ea typeface="Courier New" pitchFamily="34" charset="-122"/>
+                <a:cs typeface="Courier New" pitchFamily="34" charset="-120"/>
+              </a:rPr>
+              <a:t>npm</a:t>
+            </a:r>
+            <a:pPr indent="0" marL="0">
+              <a:lnSpc>
+                <a:spcPct val="105000"/>
+              </a:lnSpc>
+              <a:buNone/>
+            </a:pPr>
+            <a:r>
+              <a:rPr lang="en-US" sz="1150" dirty="0">
+                <a:solidFill>
+                  <a:srgbClr val="CCCCCC"/>
+                </a:solidFill>
+                <a:latin typeface="Courier New" pitchFamily="34" charset="0"/>
+                <a:ea typeface="Courier New" pitchFamily="34" charset="-122"/>
+                <a:cs typeface="Courier New" pitchFamily="34" charset="-120"/>
+              </a:rPr>
+              <a:t> </a:t>
+            </a:r>
+            <a:pPr indent="0" marL="0">
+              <a:lnSpc>
+                <a:spcPct val="105000"/>
+              </a:lnSpc>
+              <a:buNone/>
+            </a:pPr>
+            <a:r>
+              <a:rPr lang="en-US" sz="1150" dirty="0">
+                <a:solidFill>
+                  <a:srgbClr val="CCCCCC"/>
+                </a:solidFill>
+                <a:latin typeface="Courier New" pitchFamily="34" charset="0"/>
+                <a:ea typeface="Courier New" pitchFamily="34" charset="-122"/>
+                <a:cs typeface="Courier New" pitchFamily="34" charset="-120"/>
+              </a:rPr>
+              <a:t>install</a:t>
             </a:r>
             <a:endParaRPr lang="en-US" sz="1150" dirty="0"/>
           </a:p>
@@ -17811,7 +19096,118 @@
             <a:r>
               <a:rPr lang="en-US" sz="1150" dirty="0">
                 <a:solidFill>
-                  <a:srgbClr val="E8ECEF"/>
+                  <a:srgbClr val="6E7681"/>
+                </a:solidFill>
+                <a:latin typeface="Courier New" pitchFamily="34" charset="0"/>
+                <a:ea typeface="Courier New" pitchFamily="34" charset="-122"/>
+                <a:cs typeface="Courier New" pitchFamily="34" charset="-120"/>
+              </a:rPr>
+              <a:t> 3  </a:t>
+            </a:r>
+            <a:endParaRPr lang="en-US" sz="1150" dirty="0"/>
+          </a:p>
+          <a:p>
+            <a:pPr indent="0" marL="0">
+              <a:lnSpc>
+                <a:spcPct val="105000"/>
+              </a:lnSpc>
+              <a:buNone/>
+            </a:pPr>
+            <a:r>
+              <a:rPr lang="en-US" sz="1150" dirty="0">
+                <a:solidFill>
+                  <a:srgbClr val="6E7681"/>
+                </a:solidFill>
+                <a:latin typeface="Courier New" pitchFamily="34" charset="0"/>
+                <a:ea typeface="Courier New" pitchFamily="34" charset="-122"/>
+                <a:cs typeface="Courier New" pitchFamily="34" charset="-120"/>
+              </a:rPr>
+              <a:t> 4  </a:t>
+            </a:r>
+            <a:pPr indent="0" marL="0">
+              <a:lnSpc>
+                <a:spcPct val="105000"/>
+              </a:lnSpc>
+              <a:buNone/>
+            </a:pPr>
+            <a:r>
+              <a:rPr lang="en-US" sz="1150" dirty="0">
+                <a:solidFill>
+                  <a:srgbClr val="6A9955"/>
+                </a:solidFill>
+                <a:latin typeface="Courier New" pitchFamily="34" charset="0"/>
+                <a:ea typeface="Courier New" pitchFamily="34" charset="-122"/>
+                <a:cs typeface="Courier New" pitchFamily="34" charset="-120"/>
+              </a:rPr>
+              <a:t># dados reais do BTP ABAP</a:t>
+            </a:r>
+            <a:endParaRPr lang="en-US" sz="1150" dirty="0"/>
+          </a:p>
+          <a:p>
+            <a:pPr indent="0" marL="0">
+              <a:lnSpc>
+                <a:spcPct val="105000"/>
+              </a:lnSpc>
+              <a:buNone/>
+            </a:pPr>
+            <a:r>
+              <a:rPr lang="en-US" sz="1150" dirty="0">
+                <a:solidFill>
+                  <a:srgbClr val="6E7681"/>
+                </a:solidFill>
+                <a:latin typeface="Courier New" pitchFamily="34" charset="0"/>
+                <a:ea typeface="Courier New" pitchFamily="34" charset="-122"/>
+                <a:cs typeface="Courier New" pitchFamily="34" charset="-120"/>
+              </a:rPr>
+              <a:t> 5  </a:t>
+            </a:r>
+            <a:pPr indent="0" marL="0">
+              <a:lnSpc>
+                <a:spcPct val="105000"/>
+              </a:lnSpc>
+              <a:buNone/>
+            </a:pPr>
+            <a:r>
+              <a:rPr lang="en-US" sz="1150" dirty="0">
+                <a:solidFill>
+                  <a:srgbClr val="6A9955"/>
+                </a:solidFill>
+                <a:latin typeface="Courier New" pitchFamily="34" charset="0"/>
+                <a:ea typeface="Courier New" pitchFamily="34" charset="-122"/>
+                <a:cs typeface="Courier New" pitchFamily="34" charset="-120"/>
+              </a:rPr>
+              <a:t># (login no navegador)</a:t>
+            </a:r>
+            <a:endParaRPr lang="en-US" sz="1150" dirty="0"/>
+          </a:p>
+          <a:p>
+            <a:pPr indent="0" marL="0">
+              <a:lnSpc>
+                <a:spcPct val="105000"/>
+              </a:lnSpc>
+              <a:buNone/>
+            </a:pPr>
+            <a:r>
+              <a:rPr lang="en-US" sz="1150" dirty="0">
+                <a:solidFill>
+                  <a:srgbClr val="6E7681"/>
+                </a:solidFill>
+                <a:latin typeface="Courier New" pitchFamily="34" charset="0"/>
+                <a:ea typeface="Courier New" pitchFamily="34" charset="-122"/>
+                <a:cs typeface="Courier New" pitchFamily="34" charset="-120"/>
+              </a:rPr>
+              <a:t> 6  </a:t>
+            </a:r>
+            <a:pPr indent="0" marL="0">
+              <a:lnSpc>
+                <a:spcPct val="105000"/>
+              </a:lnSpc>
+              <a:buNone/>
+            </a:pPr>
+            <a:r>
+              <a:rPr lang="en-US" sz="1150" dirty="0">
+                <a:solidFill>
+                  <a:srgbClr val="DCDCAA"/>
                 </a:solidFill>
                 <a:latin typeface="Courier New" pitchFamily="34" charset="0"/>
                 <a:ea typeface="Courier New" pitchFamily="34" charset="-122"/>
@@ -17828,7 +19224,7 @@
             <a:r>
               <a:rPr lang="en-US" sz="1150" dirty="0">
                 <a:solidFill>
-                  <a:srgbClr val="E8ECEF"/>
+                  <a:srgbClr val="CCCCCC"/>
                 </a:solidFill>
                 <a:latin typeface="Courier New" pitchFamily="34" charset="0"/>
                 <a:ea typeface="Courier New" pitchFamily="34" charset="-122"/>
@@ -17845,13 +19241,13 @@
             <a:r>
               <a:rPr lang="en-US" sz="1150" dirty="0">
                 <a:solidFill>
-                  <a:srgbClr val="E8ECEF"/>
-                </a:solidFill>
-                <a:latin typeface="Courier New" pitchFamily="34" charset="0"/>
-                <a:ea typeface="Courier New" pitchFamily="34" charset="-122"/>
-                <a:cs typeface="Courier New" pitchFamily="34" charset="-120"/>
-              </a:rPr>
-              <a:t>install</a:t>
+                  <a:srgbClr val="CCCCCC"/>
+                </a:solidFill>
+                <a:latin typeface="Courier New" pitchFamily="34" charset="0"/>
+                <a:ea typeface="Courier New" pitchFamily="34" charset="-122"/>
+                <a:cs typeface="Courier New" pitchFamily="34" charset="-120"/>
+              </a:rPr>
+              <a:t>start</a:t>
             </a:r>
             <a:endParaRPr lang="en-US" sz="1150" dirty="0"/>
           </a:p>
@@ -17865,7 +19261,98 @@
             <a:r>
               <a:rPr lang="en-US" sz="1150" dirty="0">
                 <a:solidFill>
-                  <a:srgbClr val="E8ECEF"/>
+                  <a:srgbClr val="6E7681"/>
+                </a:solidFill>
+                <a:latin typeface="Courier New" pitchFamily="34" charset="0"/>
+                <a:ea typeface="Courier New" pitchFamily="34" charset="-122"/>
+                <a:cs typeface="Courier New" pitchFamily="34" charset="-120"/>
+              </a:rPr>
+              <a:t> 7  </a:t>
+            </a:r>
+            <a:endParaRPr lang="en-US" sz="1150" dirty="0"/>
+          </a:p>
+          <a:p>
+            <a:pPr indent="0" marL="0">
+              <a:lnSpc>
+                <a:spcPct val="105000"/>
+              </a:lnSpc>
+              <a:buNone/>
+            </a:pPr>
+            <a:r>
+              <a:rPr lang="en-US" sz="1150" dirty="0">
+                <a:solidFill>
+                  <a:srgbClr val="6E7681"/>
+                </a:solidFill>
+                <a:latin typeface="Courier New" pitchFamily="34" charset="0"/>
+                <a:ea typeface="Courier New" pitchFamily="34" charset="-122"/>
+                <a:cs typeface="Courier New" pitchFamily="34" charset="-120"/>
+              </a:rPr>
+              <a:t> 8  </a:t>
+            </a:r>
+            <a:pPr indent="0" marL="0">
+              <a:lnSpc>
+                <a:spcPct val="105000"/>
+              </a:lnSpc>
+              <a:buNone/>
+            </a:pPr>
+            <a:r>
+              <a:rPr lang="en-US" sz="1150" dirty="0">
+                <a:solidFill>
+                  <a:srgbClr val="6A9955"/>
+                </a:solidFill>
+                <a:latin typeface="Courier New" pitchFamily="34" charset="0"/>
+                <a:ea typeface="Courier New" pitchFamily="34" charset="-122"/>
+                <a:cs typeface="Courier New" pitchFamily="34" charset="-120"/>
+              </a:rPr>
+              <a:t># sem backend: mock server</a:t>
+            </a:r>
+            <a:endParaRPr lang="en-US" sz="1150" dirty="0"/>
+          </a:p>
+          <a:p>
+            <a:pPr indent="0" marL="0">
+              <a:lnSpc>
+                <a:spcPct val="105000"/>
+              </a:lnSpc>
+              <a:buNone/>
+            </a:pPr>
+            <a:r>
+              <a:rPr lang="en-US" sz="1150" dirty="0">
+                <a:solidFill>
+                  <a:srgbClr val="6E7681"/>
+                </a:solidFill>
+                <a:latin typeface="Courier New" pitchFamily="34" charset="0"/>
+                <a:ea typeface="Courier New" pitchFamily="34" charset="-122"/>
+                <a:cs typeface="Courier New" pitchFamily="34" charset="-120"/>
+              </a:rPr>
+              <a:t> 9  </a:t>
+            </a:r>
+            <a:pPr indent="0" marL="0">
+              <a:lnSpc>
+                <a:spcPct val="105000"/>
+              </a:lnSpc>
+              <a:buNone/>
+            </a:pPr>
+            <a:r>
+              <a:rPr lang="en-US" sz="1150" dirty="0">
+                <a:solidFill>
+                  <a:srgbClr val="DCDCAA"/>
+                </a:solidFill>
+                <a:latin typeface="Courier New" pitchFamily="34" charset="0"/>
+                <a:ea typeface="Courier New" pitchFamily="34" charset="-122"/>
+                <a:cs typeface="Courier New" pitchFamily="34" charset="-120"/>
+              </a:rPr>
+              <a:t>npm</a:t>
+            </a:r>
+            <a:pPr indent="0" marL="0">
+              <a:lnSpc>
+                <a:spcPct val="105000"/>
+              </a:lnSpc>
+              <a:buNone/>
+            </a:pPr>
+            <a:r>
+              <a:rPr lang="en-US" sz="1150" dirty="0">
+                <a:solidFill>
+                  <a:srgbClr val="CCCCCC"/>
                 </a:solidFill>
                 <a:latin typeface="Courier New" pitchFamily="34" charset="0"/>
                 <a:ea typeface="Courier New" pitchFamily="34" charset="-122"/>
@@ -17873,49 +19360,6 @@
               </a:rPr>
               <a:t> </a:t>
             </a:r>
-            <a:endParaRPr lang="en-US" sz="1150" dirty="0"/>
-          </a:p>
-          <a:p>
-            <a:pPr indent="0" marL="0">
-              <a:lnSpc>
-                <a:spcPct val="105000"/>
-              </a:lnSpc>
-              <a:buNone/>
-            </a:pPr>
-            <a:r>
-              <a:rPr lang="en-US" sz="1150" i="1" dirty="0">
-                <a:solidFill>
-                  <a:srgbClr val="8396A8"/>
-                </a:solidFill>
-                <a:latin typeface="Courier New" pitchFamily="34" charset="0"/>
-                <a:ea typeface="Courier New" pitchFamily="34" charset="-122"/>
-                <a:cs typeface="Courier New" pitchFamily="34" charset="-120"/>
-              </a:rPr>
-              <a:t># dados reais do BTP ABAP</a:t>
-            </a:r>
-            <a:endParaRPr lang="en-US" sz="1150" dirty="0"/>
-          </a:p>
-          <a:p>
-            <a:pPr indent="0" marL="0">
-              <a:lnSpc>
-                <a:spcPct val="105000"/>
-              </a:lnSpc>
-              <a:buNone/>
-            </a:pPr>
-            <a:r>
-              <a:rPr lang="en-US" sz="1150" i="1" dirty="0">
-                <a:solidFill>
-                  <a:srgbClr val="8396A8"/>
-                </a:solidFill>
-                <a:latin typeface="Courier New" pitchFamily="34" charset="0"/>
-                <a:ea typeface="Courier New" pitchFamily="34" charset="-122"/>
-                <a:cs typeface="Courier New" pitchFamily="34" charset="-120"/>
-              </a:rPr>
-              <a:t># (login no navegador)</a:t>
-            </a:r>
-            <a:endParaRPr lang="en-US" sz="1150" dirty="0"/>
-          </a:p>
-          <a:p>
             <a:pPr indent="0" marL="0">
               <a:lnSpc>
                 <a:spcPct val="105000"/>
@@ -17925,13 +19369,13 @@
             <a:r>
               <a:rPr lang="en-US" sz="1150" dirty="0">
                 <a:solidFill>
-                  <a:srgbClr val="E8ECEF"/>
-                </a:solidFill>
-                <a:latin typeface="Courier New" pitchFamily="34" charset="0"/>
-                <a:ea typeface="Courier New" pitchFamily="34" charset="-122"/>
-                <a:cs typeface="Courier New" pitchFamily="34" charset="-120"/>
-              </a:rPr>
-              <a:t>npm</a:t>
+                  <a:srgbClr val="CCCCCC"/>
+                </a:solidFill>
+                <a:latin typeface="Courier New" pitchFamily="34" charset="0"/>
+                <a:ea typeface="Courier New" pitchFamily="34" charset="-122"/>
+                <a:cs typeface="Courier New" pitchFamily="34" charset="-120"/>
+              </a:rPr>
+              <a:t>run</a:t>
             </a:r>
             <a:pPr indent="0" marL="0">
               <a:lnSpc>
@@ -17942,7 +19386,7 @@
             <a:r>
               <a:rPr lang="en-US" sz="1150" dirty="0">
                 <a:solidFill>
-                  <a:srgbClr val="E8ECEF"/>
+                  <a:srgbClr val="CCCCCC"/>
                 </a:solidFill>
                 <a:latin typeface="Courier New" pitchFamily="34" charset="0"/>
                 <a:ea typeface="Courier New" pitchFamily="34" charset="-122"/>
@@ -17959,135 +19403,7 @@
             <a:r>
               <a:rPr lang="en-US" sz="1150" dirty="0">
                 <a:solidFill>
-                  <a:srgbClr val="E8ECEF"/>
-                </a:solidFill>
-                <a:latin typeface="Courier New" pitchFamily="34" charset="0"/>
-                <a:ea typeface="Courier New" pitchFamily="34" charset="-122"/>
-                <a:cs typeface="Courier New" pitchFamily="34" charset="-120"/>
-              </a:rPr>
-              <a:t>start</a:t>
-            </a:r>
-            <a:endParaRPr lang="en-US" sz="1150" dirty="0"/>
-          </a:p>
-          <a:p>
-            <a:pPr indent="0" marL="0">
-              <a:lnSpc>
-                <a:spcPct val="105000"/>
-              </a:lnSpc>
-              <a:buNone/>
-            </a:pPr>
-            <a:r>
-              <a:rPr lang="en-US" sz="1150" dirty="0">
-                <a:solidFill>
-                  <a:srgbClr val="E8ECEF"/>
-                </a:solidFill>
-                <a:latin typeface="Courier New" pitchFamily="34" charset="0"/>
-                <a:ea typeface="Courier New" pitchFamily="34" charset="-122"/>
-                <a:cs typeface="Courier New" pitchFamily="34" charset="-120"/>
-              </a:rPr>
-              <a:t> </a:t>
-            </a:r>
-            <a:endParaRPr lang="en-US" sz="1150" dirty="0"/>
-          </a:p>
-          <a:p>
-            <a:pPr indent="0" marL="0">
-              <a:lnSpc>
-                <a:spcPct val="105000"/>
-              </a:lnSpc>
-              <a:buNone/>
-            </a:pPr>
-            <a:r>
-              <a:rPr lang="en-US" sz="1150" i="1" dirty="0">
-                <a:solidFill>
-                  <a:srgbClr val="8396A8"/>
-                </a:solidFill>
-                <a:latin typeface="Courier New" pitchFamily="34" charset="0"/>
-                <a:ea typeface="Courier New" pitchFamily="34" charset="-122"/>
-                <a:cs typeface="Courier New" pitchFamily="34" charset="-120"/>
-              </a:rPr>
-              <a:t># sem backend: mock server</a:t>
-            </a:r>
-            <a:endParaRPr lang="en-US" sz="1150" dirty="0"/>
-          </a:p>
-          <a:p>
-            <a:pPr indent="0" marL="0">
-              <a:lnSpc>
-                <a:spcPct val="105000"/>
-              </a:lnSpc>
-              <a:buNone/>
-            </a:pPr>
-            <a:r>
-              <a:rPr lang="en-US" sz="1150" dirty="0">
-                <a:solidFill>
-                  <a:srgbClr val="E8ECEF"/>
-                </a:solidFill>
-                <a:latin typeface="Courier New" pitchFamily="34" charset="0"/>
-                <a:ea typeface="Courier New" pitchFamily="34" charset="-122"/>
-                <a:cs typeface="Courier New" pitchFamily="34" charset="-120"/>
-              </a:rPr>
-              <a:t>npm</a:t>
-            </a:r>
-            <a:pPr indent="0" marL="0">
-              <a:lnSpc>
-                <a:spcPct val="105000"/>
-              </a:lnSpc>
-              <a:buNone/>
-            </a:pPr>
-            <a:r>
-              <a:rPr lang="en-US" sz="1150" dirty="0">
-                <a:solidFill>
-                  <a:srgbClr val="E8ECEF"/>
-                </a:solidFill>
-                <a:latin typeface="Courier New" pitchFamily="34" charset="0"/>
-                <a:ea typeface="Courier New" pitchFamily="34" charset="-122"/>
-                <a:cs typeface="Courier New" pitchFamily="34" charset="-120"/>
-              </a:rPr>
-              <a:t> </a:t>
-            </a:r>
-            <a:pPr indent="0" marL="0">
-              <a:lnSpc>
-                <a:spcPct val="105000"/>
-              </a:lnSpc>
-              <a:buNone/>
-            </a:pPr>
-            <a:r>
-              <a:rPr lang="en-US" sz="1150" dirty="0">
-                <a:solidFill>
-                  <a:srgbClr val="E8ECEF"/>
-                </a:solidFill>
-                <a:latin typeface="Courier New" pitchFamily="34" charset="0"/>
-                <a:ea typeface="Courier New" pitchFamily="34" charset="-122"/>
-                <a:cs typeface="Courier New" pitchFamily="34" charset="-120"/>
-              </a:rPr>
-              <a:t>run</a:t>
-            </a:r>
-            <a:pPr indent="0" marL="0">
-              <a:lnSpc>
-                <a:spcPct val="105000"/>
-              </a:lnSpc>
-              <a:buNone/>
-            </a:pPr>
-            <a:r>
-              <a:rPr lang="en-US" sz="1150" dirty="0">
-                <a:solidFill>
-                  <a:srgbClr val="E8ECEF"/>
-                </a:solidFill>
-                <a:latin typeface="Courier New" pitchFamily="34" charset="0"/>
-                <a:ea typeface="Courier New" pitchFamily="34" charset="-122"/>
-                <a:cs typeface="Courier New" pitchFamily="34" charset="-120"/>
-              </a:rPr>
-              <a:t> </a:t>
-            </a:r>
-            <a:pPr indent="0" marL="0">
-              <a:lnSpc>
-                <a:spcPct val="105000"/>
-              </a:lnSpc>
-              <a:buNone/>
-            </a:pPr>
-            <a:r>
-              <a:rPr lang="en-US" sz="1150" dirty="0">
-                <a:solidFill>
-                  <a:srgbClr val="E8ECEF"/>
+                  <a:srgbClr val="CCCCCC"/>
                 </a:solidFill>
                 <a:latin typeface="Courier New" pitchFamily="34" charset="0"/>
                 <a:ea typeface="Courier New" pitchFamily="34" charset="-122"/>

</xml_diff>

<commit_message>
docs(apresentacoes): prefixo ZAVBS opcional e sugestão ZPK nos slides
- Etapa 1: novo slide "Prefixos" depois de "Organização", com a tabela
  ZAVBS -> ZPK; a nota do slide "Organização" deixa de dizer que o
  prefixo vem do sistema.
- Etapa 2: quadro no slide "Convenções" sobre prefixos livres.
- Etapas 4 e 5: coluna "Pacote (prefixo opcional)" e, no ui5-deploy.yaml
  do slide de deploy, o comentário "# ou ZPK_PC_PEDIDOS".

Co-Authored-By: Claude Opus 5.5 <noreply@anthropic.com>
</commit_message>
<xml_diff>
--- a/docs/apresentacoes/05-apps-fiori.pptx
+++ b/docs/apresentacoes/05-apps-fiori.pptx
@@ -27457,6 +27457,17 @@
               </a:rPr>
               <a:t>ZAVBS_PC_PEDIDOS</a:t>
             </a:r>
+            <a:r>
+              <a:rPr lang="en-US" sz="1100" dirty="0">
+                <a:solidFill>
+                  <a:srgbClr val="6A9955"/>
+                </a:solidFill>
+                <a:latin typeface="Courier New" pitchFamily="34" charset="0"/>
+                <a:ea typeface="Courier New" pitchFamily="34" charset="-122"/>
+                <a:cs typeface="Courier New" pitchFamily="34" charset="-120"/>
+              </a:rPr>
+              <a:t>  # ou ZPK_PC_PEDIDOS</a:t>
+            </a:r>
             <a:endParaRPr lang="en-US" sz="1100" dirty="0"/>
           </a:p>
           <a:p>
@@ -27723,7 +27734,7 @@
                             <a:srgbClr val="1D2D3E"/>
                           </a:solidFill>
                         </a:rPr>
-                        <a:t>Pacote</a:t>
+                        <a:t>Pacote (prefixo opcional)</a:t>
                       </a:r>
                       <a:endParaRPr lang="en-US" sz="1050" dirty="0"/>
                     </a:p>

</xml_diff>

<commit_message>
docs: atualiza as referências às pastas das apps UI5
README principal e ui5/README.md com a nova estrutura (apps-list-reports e
apps-analiticos), links das tabelas de apps e comando cd; slides da etapa 5
com os novos caminhos nos breadcrumbs, nas fichas das apps e nas notas.

Co-Authored-By: Claude Opus 5.5 <noreply@anthropic.com>
</commit_message>
<xml_diff>
--- a/docs/apresentacoes/05-apps-fiori.pptx
+++ b/docs/apresentacoes/05-apps-fiori.pptx
@@ -2888,7 +2888,7 @@
           <a:p>
             <a:r>
               <a:rPr lang="en-US" dirty="0"/>
-              <a:t>Cada pasta em ui5/ tem package.json, node_modules e configuração próprios. O ui5.yaml sobe o servidor local com proxy para o sistema ABAP (no BTP, login por reentranceTicket); o ui5-mock.yaml usa o metadata salvo em localService para rodar sem backend.</a:t>
+              <a:t>Cada app em ui5/apps-list-reports/ e ui5/apps-analiticos/ tem package.json, node_modules e configuração próprios. O ui5.yaml sobe o servidor local com proxy para o sistema ABAP (no BTP, login por reentranceTicket); o ui5-mock.yaml usa o metadata salvo em localService para rodar sem backend.</a:t>
             </a:r>
             <a:endParaRPr lang="en-US" dirty="0"/>
           </a:p>
@@ -4910,7 +4910,28 @@
                 <a:ea typeface="Courier New" pitchFamily="34" charset="-122"/>
                 <a:cs typeface="Courier New" pitchFamily="34" charset="-120"/>
               </a:rPr>
-              <a:t>ui5/gestao-clientes</a:t>
+              <a:t>ui5/apps-list-reports/</a:t>
+            </a:r>
+            <a:br>
+              <a:rPr lang="en-US" sz="1000" dirty="0">
+                <a:solidFill>
+                  <a:srgbClr val="0064D9"/>
+                </a:solidFill>
+                <a:latin typeface="Courier New" pitchFamily="34" charset="0"/>
+                <a:ea typeface="Courier New" pitchFamily="34" charset="-122"/>
+                <a:cs typeface="Courier New" pitchFamily="34" charset="-120"/>
+              </a:rPr>
+            </a:br>
+            <a:r>
+              <a:rPr lang="en-US" sz="1000" dirty="0">
+                <a:solidFill>
+                  <a:srgbClr val="0064D9"/>
+                </a:solidFill>
+                <a:latin typeface="Courier New" pitchFamily="34" charset="0"/>
+                <a:ea typeface="Courier New" pitchFamily="34" charset="-122"/>
+                <a:cs typeface="Courier New" pitchFamily="34" charset="-120"/>
+              </a:rPr>
+              <a:t>gestao-clientes</a:t>
             </a:r>
             <a:endParaRPr lang="en-US" sz="1000" dirty="0"/>
           </a:p>
@@ -8103,7 +8124,7 @@
                 <a:ea typeface="Courier New" pitchFamily="34" charset="-122"/>
                 <a:cs typeface="Courier New" pitchFamily="34" charset="-120"/>
               </a:rPr>
-              <a:t>ui5/gestao-estoque</a:t>
+              <a:t>ui5/apps-list-reports/gestao-estoque</a:t>
             </a:r>
             <a:pPr indent="0" marL="0">
               <a:buNone/>
@@ -8203,7 +8224,7 @@
                 <a:ea typeface="Courier New" pitchFamily="34" charset="-122"/>
                 <a:cs typeface="Courier New" pitchFamily="34" charset="-120"/>
               </a:rPr>
-              <a:t>ui5/analise-estoque</a:t>
+              <a:t>ui5/apps-analiticos/analise-estoque</a:t>
             </a:r>
             <a:pPr indent="0" marL="0">
               <a:buNone/>
@@ -8522,7 +8543,28 @@
                 <a:ea typeface="Courier New" pitchFamily="34" charset="-122"/>
                 <a:cs typeface="Courier New" pitchFamily="34" charset="-120"/>
               </a:rPr>
-              <a:t>ui5/gestao-estoque</a:t>
+              <a:t>ui5/apps-list-reports/</a:t>
+            </a:r>
+            <a:br>
+              <a:rPr lang="en-US" sz="1000" dirty="0">
+                <a:solidFill>
+                  <a:srgbClr val="0064D9"/>
+                </a:solidFill>
+                <a:latin typeface="Courier New" pitchFamily="34" charset="0"/>
+                <a:ea typeface="Courier New" pitchFamily="34" charset="-122"/>
+                <a:cs typeface="Courier New" pitchFamily="34" charset="-120"/>
+              </a:rPr>
+            </a:br>
+            <a:r>
+              <a:rPr lang="en-US" sz="1000" dirty="0">
+                <a:solidFill>
+                  <a:srgbClr val="0064D9"/>
+                </a:solidFill>
+                <a:latin typeface="Courier New" pitchFamily="34" charset="0"/>
+                <a:ea typeface="Courier New" pitchFamily="34" charset="-122"/>
+                <a:cs typeface="Courier New" pitchFamily="34" charset="-120"/>
+              </a:rPr>
+              <a:t>gestao-estoque</a:t>
             </a:r>
             <a:endParaRPr lang="en-US" sz="1000" dirty="0"/>
           </a:p>
@@ -11518,7 +11560,7 @@
                 <a:ea typeface="Courier New" pitchFamily="34" charset="-122"/>
                 <a:cs typeface="Courier New" pitchFamily="34" charset="-120"/>
               </a:rPr>
-              <a:t>ui5/pedidos-compras</a:t>
+              <a:t>ui5/apps-list-reports/pedidos-compras</a:t>
             </a:r>
             <a:pPr indent="0" marL="0">
               <a:buNone/>
@@ -11668,7 +11710,7 @@
                 <a:ea typeface="Courier New" pitchFamily="34" charset="-122"/>
                 <a:cs typeface="Courier New" pitchFamily="34" charset="-120"/>
               </a:rPr>
-              <a:t>ui5/analise-pedidos</a:t>
+              <a:t>ui5/apps-analiticos/analise-pedidos</a:t>
             </a:r>
             <a:pPr indent="0" marL="0">
               <a:buNone/>
@@ -21962,7 +22004,28 @@
                 <a:ea typeface="Courier New" pitchFamily="34" charset="-122"/>
                 <a:cs typeface="Courier New" pitchFamily="34" charset="-120"/>
               </a:rPr>
-              <a:t>ui5/gestao-reembolsos</a:t>
+              <a:t>ui5/apps-list-reports/</a:t>
+            </a:r>
+            <a:br>
+              <a:rPr lang="en-US" sz="1100" b="1" dirty="0">
+                <a:solidFill>
+                  <a:srgbClr val="FFFFFF"/>
+                </a:solidFill>
+                <a:latin typeface="Courier New" pitchFamily="34" charset="0"/>
+                <a:ea typeface="Courier New" pitchFamily="34" charset="-122"/>
+                <a:cs typeface="Courier New" pitchFamily="34" charset="-120"/>
+              </a:rPr>
+            </a:br>
+            <a:r>
+              <a:rPr lang="en-US" sz="1100" b="1" dirty="0">
+                <a:solidFill>
+                  <a:srgbClr val="FFFFFF"/>
+                </a:solidFill>
+                <a:latin typeface="Courier New" pitchFamily="34" charset="0"/>
+                <a:ea typeface="Courier New" pitchFamily="34" charset="-122"/>
+                <a:cs typeface="Courier New" pitchFamily="34" charset="-120"/>
+              </a:rPr>
+              <a:t>gestao-reembolsos</a:t>
             </a:r>
             <a:pPr indent="0" marL="0">
               <a:buNone/>
@@ -22062,7 +22125,28 @@
                 <a:ea typeface="Courier New" pitchFamily="34" charset="-122"/>
                 <a:cs typeface="Courier New" pitchFamily="34" charset="-120"/>
               </a:rPr>
-              <a:t>ui5/analise-reembolsos</a:t>
+              <a:t>ui5/apps-analiticos/</a:t>
+            </a:r>
+            <a:br>
+              <a:rPr lang="en-US" sz="1100" b="1" dirty="0">
+                <a:solidFill>
+                  <a:srgbClr val="FFFFFF"/>
+                </a:solidFill>
+                <a:latin typeface="Courier New" pitchFamily="34" charset="0"/>
+                <a:ea typeface="Courier New" pitchFamily="34" charset="-122"/>
+                <a:cs typeface="Courier New" pitchFamily="34" charset="-120"/>
+              </a:rPr>
+            </a:br>
+            <a:r>
+              <a:rPr lang="en-US" sz="1100" b="1" dirty="0">
+                <a:solidFill>
+                  <a:srgbClr val="FFFFFF"/>
+                </a:solidFill>
+                <a:latin typeface="Courier New" pitchFamily="34" charset="0"/>
+                <a:ea typeface="Courier New" pitchFamily="34" charset="-122"/>
+                <a:cs typeface="Courier New" pitchFamily="34" charset="-120"/>
+              </a:rPr>
+              <a:t>analise-reembolsos</a:t>
             </a:r>
             <a:pPr indent="0" marL="0">
               <a:buNone/>
@@ -22381,7 +22465,28 @@
                 <a:ea typeface="Courier New" pitchFamily="34" charset="-122"/>
                 <a:cs typeface="Courier New" pitchFamily="34" charset="-120"/>
               </a:rPr>
-              <a:t>ui5/gestao-reembolsos</a:t>
+              <a:t>ui5/apps-list-reports/</a:t>
+            </a:r>
+            <a:br>
+              <a:rPr lang="en-US" sz="1000" dirty="0">
+                <a:solidFill>
+                  <a:srgbClr val="0064D9"/>
+                </a:solidFill>
+                <a:latin typeface="Courier New" pitchFamily="34" charset="0"/>
+                <a:ea typeface="Courier New" pitchFamily="34" charset="-122"/>
+                <a:cs typeface="Courier New" pitchFamily="34" charset="-120"/>
+              </a:rPr>
+            </a:br>
+            <a:r>
+              <a:rPr lang="en-US" sz="1000" dirty="0">
+                <a:solidFill>
+                  <a:srgbClr val="0064D9"/>
+                </a:solidFill>
+                <a:latin typeface="Courier New" pitchFamily="34" charset="0"/>
+                <a:ea typeface="Courier New" pitchFamily="34" charset="-122"/>
+                <a:cs typeface="Courier New" pitchFamily="34" charset="-120"/>
+              </a:rPr>
+              <a:t>gestao-reembolsos</a:t>
             </a:r>
             <a:endParaRPr lang="en-US" sz="1000" dirty="0"/>
           </a:p>
@@ -26270,6 +26375,28 @@
                   <a:srgbClr val="A9A9A9"/>
                 </a:solidFill>
               </a:rPr>
+              <a:t>apps-list-reports</a:t>
+            </a:r>
+            <a:pPr indent="0" marL="0">
+              <a:buNone/>
+            </a:pPr>
+            <a:r>
+              <a:rPr lang="en-US" sz="900" dirty="0">
+                <a:solidFill>
+                  <a:srgbClr val="6E7681"/>
+                </a:solidFill>
+              </a:rPr>
+              <a:t>  ›  </a:t>
+            </a:r>
+            <a:pPr indent="0" marL="0">
+              <a:buNone/>
+            </a:pPr>
+            <a:r>
+              <a:rPr lang="en-US" sz="900" dirty="0">
+                <a:solidFill>
+                  <a:srgbClr val="A9A9A9"/>
+                </a:solidFill>
+              </a:rPr>
               <a:t>pedidos-compras</a:t>
             </a:r>
             <a:pPr indent="0" marL="0">
@@ -32473,6 +32600,28 @@
                   <a:srgbClr val="A9A9A9"/>
                 </a:solidFill>
               </a:rPr>
+              <a:t>apps-list-reports</a:t>
+            </a:r>
+            <a:pPr indent="0" marL="0">
+              <a:buNone/>
+            </a:pPr>
+            <a:r>
+              <a:rPr lang="en-US" sz="900" dirty="0">
+                <a:solidFill>
+                  <a:srgbClr val="6E7681"/>
+                </a:solidFill>
+              </a:rPr>
+              <a:t>  ›  </a:t>
+            </a:r>
+            <a:pPr indent="0" marL="0">
+              <a:buNone/>
+            </a:pPr>
+            <a:r>
+              <a:rPr lang="en-US" sz="900" dirty="0">
+                <a:solidFill>
+                  <a:srgbClr val="A9A9A9"/>
+                </a:solidFill>
+              </a:rPr>
               <a:t>pedidos-compras</a:t>
             </a:r>
             <a:pPr indent="0" marL="0">
@@ -35423,7 +35572,7 @@
                 <a:ea typeface="Courier New" pitchFamily="34" charset="-122"/>
                 <a:cs typeface="Courier New" pitchFamily="34" charset="-120"/>
               </a:rPr>
-              <a:t>ui5/&lt;app&gt;/</a:t>
+              <a:t>ui5/apps-*/&lt;app&gt;/</a:t>
             </a:r>
             <a:pPr indent="0" marL="0">
               <a:buNone/>
@@ -39607,7 +39756,7 @@
                   <a:srgbClr val="556B82"/>
                 </a:solidFill>
               </a:rPr>
-              <a:t>Nome, namespace, pasta ui5/pedidos-compras</a:t>
+              <a:t>Nome, namespace, pasta ui5/apps-list-reports/pedidos-compras</a:t>
             </a:r>
             <a:endParaRPr lang="en-US" sz="1150" dirty="0"/>
           </a:p>
@@ -39914,6 +40063,28 @@
                 </a:solidFill>
               </a:rPr>
               <a:t>ui5</a:t>
+            </a:r>
+            <a:pPr indent="0" marL="0">
+              <a:buNone/>
+            </a:pPr>
+            <a:r>
+              <a:rPr lang="en-US" sz="900" dirty="0">
+                <a:solidFill>
+                  <a:srgbClr val="6E7681"/>
+                </a:solidFill>
+              </a:rPr>
+              <a:t>  ›  </a:t>
+            </a:r>
+            <a:pPr indent="0" marL="0">
+              <a:buNone/>
+            </a:pPr>
+            <a:r>
+              <a:rPr lang="en-US" sz="900" dirty="0">
+                <a:solidFill>
+                  <a:srgbClr val="A9A9A9"/>
+                </a:solidFill>
+              </a:rPr>
+              <a:t>apps-list-reports</a:t>
             </a:r>
             <a:pPr indent="0" marL="0">
               <a:buNone/>
@@ -42331,6 +42502,28 @@
                   <a:srgbClr val="A9A9A9"/>
                 </a:solidFill>
               </a:rPr>
+              <a:t>apps-list-reports</a:t>
+            </a:r>
+            <a:pPr indent="0" marL="0">
+              <a:buNone/>
+            </a:pPr>
+            <a:r>
+              <a:rPr lang="en-US" sz="900" dirty="0">
+                <a:solidFill>
+                  <a:srgbClr val="6E7681"/>
+                </a:solidFill>
+              </a:rPr>
+              <a:t>  ›  </a:t>
+            </a:r>
+            <a:pPr indent="0" marL="0">
+              <a:buNone/>
+            </a:pPr>
+            <a:r>
+              <a:rPr lang="en-US" sz="900" dirty="0">
+                <a:solidFill>
+                  <a:srgbClr val="A9A9A9"/>
+                </a:solidFill>
+              </a:rPr>
               <a:t>gestao-clientes</a:t>
             </a:r>
             <a:endParaRPr lang="en-US" sz="900" dirty="0"/>
@@ -45210,6 +45403,28 @@
                 </a:solidFill>
               </a:rPr>
               <a:t>ui5</a:t>
+            </a:r>
+            <a:pPr indent="0" marL="0">
+              <a:buNone/>
+            </a:pPr>
+            <a:r>
+              <a:rPr lang="en-US" sz="900" dirty="0">
+                <a:solidFill>
+                  <a:srgbClr val="6E7681"/>
+                </a:solidFill>
+              </a:rPr>
+              <a:t>  ›  </a:t>
+            </a:r>
+            <a:pPr indent="0" marL="0">
+              <a:buNone/>
+            </a:pPr>
+            <a:r>
+              <a:rPr lang="en-US" sz="900" dirty="0">
+                <a:solidFill>
+                  <a:srgbClr val="A9A9A9"/>
+                </a:solidFill>
+              </a:rPr>
+              <a:t>apps-list-reports</a:t>
             </a:r>
             <a:pPr indent="0" marL="0">
               <a:buNone/>
@@ -47876,6 +48091,28 @@
                   <a:srgbClr val="A9A9A9"/>
                 </a:solidFill>
               </a:rPr>
+              <a:t>apps-analiticos</a:t>
+            </a:r>
+            <a:pPr indent="0" marL="0">
+              <a:buNone/>
+            </a:pPr>
+            <a:r>
+              <a:rPr lang="en-US" sz="900" dirty="0">
+                <a:solidFill>
+                  <a:srgbClr val="6E7681"/>
+                </a:solidFill>
+              </a:rPr>
+              <a:t>  ›  </a:t>
+            </a:r>
+            <a:pPr indent="0" marL="0">
+              <a:buNone/>
+            </a:pPr>
+            <a:r>
+              <a:rPr lang="en-US" sz="900" dirty="0">
+                <a:solidFill>
+                  <a:srgbClr val="A9A9A9"/>
+                </a:solidFill>
+              </a:rPr>
               <a:t>analise-clientes</a:t>
             </a:r>
             <a:pPr indent="0" marL="0">
@@ -54289,7 +54526,7 @@
                 <a:ea typeface="Courier New" pitchFamily="34" charset="-122"/>
                 <a:cs typeface="Courier New" pitchFamily="34" charset="-120"/>
               </a:rPr>
-              <a:t>ui5/gestao-clientes</a:t>
+              <a:t>ui5/apps-list-reports/gestao-clientes</a:t>
             </a:r>
             <a:pPr indent="0" marL="0">
               <a:buNone/>
@@ -54389,7 +54626,7 @@
                 <a:ea typeface="Courier New" pitchFamily="34" charset="-122"/>
                 <a:cs typeface="Courier New" pitchFamily="34" charset="-120"/>
               </a:rPr>
-              <a:t>ui5/analise-clientes</a:t>
+              <a:t>ui5/apps-analiticos/analise-clientes</a:t>
             </a:r>
             <a:pPr indent="0" marL="0">
               <a:buNone/>

</xml_diff>

<commit_message>
docs(apresentacoes): seção Antes do deploy na etapa 05
Abre a seção de qualidade e testes, renomeia o slide de comandos para
"Rode os comandos de lint, build e testes" e explica a importância e a
responsabilidade de rodar lint, build, testes, UI5 linter e deploy-test
antes do npm run deploy.

Co-Authored-By: Claude Opus 5.5 <noreply@anthropic.com>
</commit_message>
<xml_diff>
--- a/docs/apresentacoes/05-apps-fiori.pptx
+++ b/docs/apresentacoes/05-apps-fiori.pptx
@@ -27,7 +27,10 @@
     <p:sldId id="275" r:id="rId21"/>
     <p:sldId id="276" r:id="rId22"/>
     <p:sldId id="277" r:id="rId23"/>
+    <p:sldId id="287" r:id="rId38"/>
     <p:sldId id="278" r:id="rId24"/>
+    <p:sldId id="288" r:id="rId39"/>
+    <p:sldId id="289" r:id="rId40"/>
     <p:sldId id="279" r:id="rId25"/>
     <p:sldId id="280" r:id="rId26"/>
     <p:sldId id="283" r:id="rId34"/>
@@ -2745,6 +2748,270 @@
     <p:extLst>
       <p:ext uri="{BB962C8B-B14F-4D97-AF65-F5344CB8AC3E}">
         <p14:creationId xmlns:p14="http://schemas.microsoft.com/office/powerpoint/2010/main" val="1024086991"/>
+      </p:ext>
+    </p:extLst>
+  </p:cSld>
+  <p:clrMapOvr>
+    <a:masterClrMapping/>
+  </p:clrMapOvr>
+</p:notes>
+</file>
+
+<file path=ppt/notesSlides/notesSlide32.xml><?xml version="1.0" encoding="utf-8"?>
+<p:notes xmlns:a="http://schemas.openxmlformats.org/drawingml/2006/main" xmlns:r="http://schemas.openxmlformats.org/officeDocument/2006/relationships" xmlns:p="http://schemas.openxmlformats.org/presentationml/2006/main">
+  <p:cSld>
+    <p:spTree>
+      <p:nvGrpSpPr>
+        <p:cNvPr id="1" name=""/>
+        <p:cNvGrpSpPr/>
+        <p:nvPr/>
+      </p:nvGrpSpPr>
+      <p:grpSpPr>
+        <a:xfrm>
+          <a:off x="0" y="0"/>
+          <a:ext cx="0" cy="0"/>
+          <a:chOff x="0" y="0"/>
+          <a:chExt cx="0" cy="0"/>
+        </a:xfrm>
+      </p:grpSpPr>
+      <p:sp>
+        <p:nvSpPr>
+          <p:cNvPr id="2" name="Slide Image Placeholder 1"/>
+          <p:cNvSpPr>
+            <a:spLocks noGrp="1" noRot="1" noChangeAspect="1"/>
+          </p:cNvSpPr>
+          <p:nvPr>
+            <p:ph type="sldImg"/>
+          </p:nvPr>
+        </p:nvSpPr>
+        <p:spPr/>
+      </p:sp>
+      <p:sp>
+        <p:nvSpPr>
+          <p:cNvPr id="3" name="Notes Placeholder 2"/>
+          <p:cNvSpPr>
+            <a:spLocks noGrp="1"/>
+          </p:cNvSpPr>
+          <p:nvPr>
+            <p:ph type="body" idx="1"/>
+          </p:nvPr>
+        </p:nvSpPr>
+        <p:spPr/>
+        <p:txBody>
+          <a:bodyPr/>
+          <a:lstStyle/>
+          <a:p>
+            <a:r>
+              <a:rPr lang="en-US" dirty="0"/>
+              <a:t>Antes de publicar, cada app passa por lint, build e testes na máquina de quem vai fazer o deploy. Esta seção mostra os comandos, o que cada um evita e de quem é a responsabilidade.</a:t>
+            </a:r>
+            <a:endParaRPr lang="en-US" dirty="0"/>
+          </a:p>
+        </p:txBody>
+      </p:sp>
+      <p:sp>
+        <p:nvSpPr>
+          <p:cNvPr id="4" name="Slide Number Placeholder 3"/>
+          <p:cNvSpPr>
+            <a:spLocks noGrp="1"/>
+          </p:cNvSpPr>
+          <p:nvPr>
+            <p:ph type="sldNum" sz="quarter" idx="10"/>
+          </p:nvPr>
+        </p:nvSpPr>
+        <p:spPr/>
+        <p:txBody>
+          <a:bodyPr/>
+          <a:lstStyle/>
+          <a:p>
+            <a:fld id="{F7021451-1387-4CA6-816F-3879F97B5CBC}" type="slidenum">
+              <a:rPr lang="en-US"/>
+              <a:t>23</a:t>
+            </a:fld>
+            <a:endParaRPr lang="en-US"/>
+          </a:p>
+        </p:txBody>
+      </p:sp>
+    </p:spTree>
+    <p:extLst>
+      <p:ext uri="{BB962C8B-B14F-4D97-AF65-F5344CB8AC3E}">
+        <p14:creationId xmlns:p14="http://schemas.microsoft.com/office/powerpoint/2010/main" val="1024087023"/>
+      </p:ext>
+    </p:extLst>
+  </p:cSld>
+  <p:clrMapOvr>
+    <a:masterClrMapping/>
+  </p:clrMapOvr>
+</p:notes>
+</file>
+
+<file path=ppt/notesSlides/notesSlide33.xml><?xml version="1.0" encoding="utf-8"?>
+<p:notes xmlns:a="http://schemas.openxmlformats.org/drawingml/2006/main" xmlns:r="http://schemas.openxmlformats.org/officeDocument/2006/relationships" xmlns:p="http://schemas.openxmlformats.org/presentationml/2006/main">
+  <p:cSld>
+    <p:spTree>
+      <p:nvGrpSpPr>
+        <p:cNvPr id="1" name=""/>
+        <p:cNvGrpSpPr/>
+        <p:nvPr/>
+      </p:nvGrpSpPr>
+      <p:grpSpPr>
+        <a:xfrm>
+          <a:off x="0" y="0"/>
+          <a:ext cx="0" cy="0"/>
+          <a:chOff x="0" y="0"/>
+          <a:chExt cx="0" cy="0"/>
+        </a:xfrm>
+      </p:grpSpPr>
+      <p:sp>
+        <p:nvSpPr>
+          <p:cNvPr id="2" name="Slide Image Placeholder 1"/>
+          <p:cNvSpPr>
+            <a:spLocks noGrp="1" noRot="1" noChangeAspect="1"/>
+          </p:cNvSpPr>
+          <p:nvPr>
+            <p:ph type="sldImg"/>
+          </p:nvPr>
+        </p:nvSpPr>
+        <p:spPr/>
+      </p:sp>
+      <p:sp>
+        <p:nvSpPr>
+          <p:cNvPr id="3" name="Notes Placeholder 2"/>
+          <p:cNvSpPr>
+            <a:spLocks noGrp="1"/>
+          </p:cNvSpPr>
+          <p:nvPr>
+            <p:ph type="body" idx="1"/>
+          </p:nvPr>
+        </p:nvSpPr>
+        <p:spPr/>
+        <p:txBody>
+          <a:bodyPr/>
+          <a:lstStyle/>
+          <a:p>
+            <a:r>
+              <a:rPr lang="en-US" dirty="0"/>
+              <a:t>Cada comando pega uma classe de erro mais cedo e mais barato do que no sistema. O npm run deploy já roda o build, mas um erro de build no meio do deploy se mistura com erros de conexão, pacote e transporte; rodando antes, cada problema aparece sozinho.</a:t>
+            </a:r>
+            <a:endParaRPr lang="en-US" dirty="0"/>
+          </a:p>
+        </p:txBody>
+      </p:sp>
+      <p:sp>
+        <p:nvSpPr>
+          <p:cNvPr id="4" name="Slide Number Placeholder 3"/>
+          <p:cNvSpPr>
+            <a:spLocks noGrp="1"/>
+          </p:cNvSpPr>
+          <p:nvPr>
+            <p:ph type="sldNum" sz="quarter" idx="10"/>
+          </p:nvPr>
+        </p:nvSpPr>
+        <p:spPr/>
+        <p:txBody>
+          <a:bodyPr/>
+          <a:lstStyle/>
+          <a:p>
+            <a:fld id="{F7021451-1387-4CA6-816F-3879F97B5CBC}" type="slidenum">
+              <a:rPr lang="en-US"/>
+              <a:t>23</a:t>
+            </a:fld>
+            <a:endParaRPr lang="en-US"/>
+          </a:p>
+        </p:txBody>
+      </p:sp>
+    </p:spTree>
+    <p:extLst>
+      <p:ext uri="{BB962C8B-B14F-4D97-AF65-F5344CB8AC3E}">
+        <p14:creationId xmlns:p14="http://schemas.microsoft.com/office/powerpoint/2010/main" val="1024087024"/>
+      </p:ext>
+    </p:extLst>
+  </p:cSld>
+  <p:clrMapOvr>
+    <a:masterClrMapping/>
+  </p:clrMapOvr>
+</p:notes>
+</file>
+
+<file path=ppt/notesSlides/notesSlide34.xml><?xml version="1.0" encoding="utf-8"?>
+<p:notes xmlns:a="http://schemas.openxmlformats.org/drawingml/2006/main" xmlns:r="http://schemas.openxmlformats.org/officeDocument/2006/relationships" xmlns:p="http://schemas.openxmlformats.org/presentationml/2006/main">
+  <p:cSld>
+    <p:spTree>
+      <p:nvGrpSpPr>
+        <p:cNvPr id="1" name=""/>
+        <p:cNvGrpSpPr/>
+        <p:nvPr/>
+      </p:nvGrpSpPr>
+      <p:grpSpPr>
+        <a:xfrm>
+          <a:off x="0" y="0"/>
+          <a:ext cx="0" cy="0"/>
+          <a:chOff x="0" y="0"/>
+          <a:chExt cx="0" cy="0"/>
+        </a:xfrm>
+      </p:grpSpPr>
+      <p:sp>
+        <p:nvSpPr>
+          <p:cNvPr id="2" name="Slide Image Placeholder 1"/>
+          <p:cNvSpPr>
+            <a:spLocks noGrp="1" noRot="1" noChangeAspect="1"/>
+          </p:cNvSpPr>
+          <p:nvPr>
+            <p:ph type="sldImg"/>
+          </p:nvPr>
+        </p:nvSpPr>
+        <p:spPr/>
+      </p:sp>
+      <p:sp>
+        <p:nvSpPr>
+          <p:cNvPr id="3" name="Notes Placeholder 2"/>
+          <p:cNvSpPr>
+            <a:spLocks noGrp="1"/>
+          </p:cNvSpPr>
+          <p:nvPr>
+            <p:ph type="body" idx="1"/>
+          </p:nvPr>
+        </p:nvSpPr>
+        <p:spPr/>
+        <p:txBody>
+          <a:bodyPr/>
+          <a:lstStyle/>
+          <a:p>
+            <a:r>
+              <a:rPr lang="en-US" dirty="0"/>
+              <a:t>Não há pipeline de CI no repositório: a sequência é manual e é responsabilidade de quem publica. Qualquer falha interrompe a sequência; corrija e recomece pelo lint. No BTP trial a versão publicada vale na hora para todos; no On-Premise a ordem de transporte leva o mesmo código para QAS e PRD.</a:t>
+            </a:r>
+            <a:endParaRPr lang="en-US" dirty="0"/>
+          </a:p>
+        </p:txBody>
+      </p:sp>
+      <p:sp>
+        <p:nvSpPr>
+          <p:cNvPr id="4" name="Slide Number Placeholder 3"/>
+          <p:cNvSpPr>
+            <a:spLocks noGrp="1"/>
+          </p:cNvSpPr>
+          <p:nvPr>
+            <p:ph type="sldNum" sz="quarter" idx="10"/>
+          </p:nvPr>
+        </p:nvSpPr>
+        <p:spPr/>
+        <p:txBody>
+          <a:bodyPr/>
+          <a:lstStyle/>
+          <a:p>
+            <a:fld id="{F7021451-1387-4CA6-816F-3879F97B5CBC}" type="slidenum">
+              <a:rPr lang="en-US"/>
+              <a:t>23</a:t>
+            </a:fld>
+            <a:endParaRPr lang="en-US"/>
+          </a:p>
+        </p:txBody>
+      </p:sp>
+    </p:spTree>
+    <p:extLst>
+      <p:ext uri="{BB962C8B-B14F-4D97-AF65-F5344CB8AC3E}">
+        <p14:creationId xmlns:p14="http://schemas.microsoft.com/office/powerpoint/2010/main" val="1024087025"/>
       </p:ext>
     </p:extLst>
   </p:cSld>
@@ -25073,7 +25340,7 @@
                   <a:schemeClr val="accent1"/>
                 </a:solidFill>
               </a:rPr>
-              <a:t>QUALIDADE</a:t>
+              <a:t>ANTES DO DEPLOY</a:t>
             </a:r>
             <a:endParaRPr lang="en-US" sz="1100" dirty="0"/>
           </a:p>
@@ -25111,7 +25378,7 @@
                   <a:schemeClr val="tx1"/>
                 </a:solidFill>
               </a:rPr>
-              <a:t>Lint, build e testes antes de cada deploy</a:t>
+              <a:t>Rode os comandos de lint, build e testes</a:t>
             </a:r>
             <a:endParaRPr lang="en-US" sz="3000" dirty="0"/>
           </a:p>
@@ -39108,6 +39375,3816 @@
 </p:sld>
 </file>
 
+<file path=ppt/slides/slide32.xml><?xml version="1.0" encoding="utf-8"?>
+<p:sld xmlns:a="http://schemas.openxmlformats.org/drawingml/2006/main" xmlns:r="http://schemas.openxmlformats.org/officeDocument/2006/relationships" xmlns:p="http://schemas.openxmlformats.org/presentationml/2006/main">
+  <p:cSld>
+    <p:spTree>
+      <p:nvGrpSpPr>
+        <p:cNvPr id="1" name=""/>
+        <p:cNvGrpSpPr/>
+        <p:nvPr/>
+      </p:nvGrpSpPr>
+      <p:grpSpPr>
+        <a:xfrm>
+          <a:off x="0" y="0"/>
+          <a:ext cx="0" cy="0"/>
+          <a:chOff x="0" y="0"/>
+          <a:chExt cx="0" cy="0"/>
+        </a:xfrm>
+      </p:grpSpPr>
+      <p:sp>
+        <p:nvSpPr>
+          <p:cNvPr id="3" name="Texto"/>
+          <p:cNvSpPr/>
+          <p:nvPr>
+            <p:ph idx="100" type="body" hasCustomPrompt="1"/>
+          </p:nvPr>
+        </p:nvSpPr>
+        <p:spPr>
+          <a:xfrm>
+            <a:off x="731520" y="1325880"/>
+            <a:ext cx="6949440" cy="365760"/>
+          </a:xfrm>
+          <a:prstGeom prst="rect">
+            <a:avLst/>
+          </a:prstGeom>
+          <a:noFill/>
+          <a:ln/>
+        </p:spPr>
+        <p:txBody>
+          <a:bodyPr wrap="square" lIns="0" tIns="0" rIns="0" bIns="0" rtlCol="0" anchor="ctr"/>
+          <a:lstStyle/>
+          <a:p>
+            <a:pPr algn="l" indent="0" marL="0">
+              <a:buNone/>
+            </a:pPr>
+            <a:r>
+              <a:rPr lang="pt-BR" sz="1400" b="1" spc="200" kern="0" dirty="0">
+                <a:solidFill>
+                  <a:srgbClr val="89D1FF"/>
+                </a:solidFill>
+              </a:rPr>
+              <a:t>ETAPA 5 · ANTES DO DEPLOY</a:t>
+            </a:r>
+            <a:endParaRPr lang="pt-BR" sz="1400" dirty="0"/>
+          </a:p>
+        </p:txBody>
+      </p:sp>
+      <p:sp>
+        <p:nvSpPr>
+          <p:cNvPr id="4" name="Texto"/>
+          <p:cNvSpPr/>
+          <p:nvPr>
+            <p:ph idx="101" type="title" hasCustomPrompt="1"/>
+          </p:nvPr>
+        </p:nvSpPr>
+        <p:spPr>
+          <a:xfrm>
+            <a:off x="731520" y="1737360"/>
+            <a:ext cx="6949440" cy="1600200"/>
+          </a:xfrm>
+          <a:prstGeom prst="rect">
+            <a:avLst/>
+          </a:prstGeom>
+          <a:noFill/>
+          <a:ln/>
+        </p:spPr>
+        <p:txBody>
+          <a:bodyPr wrap="square" lIns="0" tIns="0" rIns="0" bIns="0" rtlCol="0" anchor="t"/>
+          <a:lstStyle/>
+          <a:p>
+            <a:pPr algn="l" indent="0" marL="0">
+              <a:buNone/>
+            </a:pPr>
+            <a:r>
+              <a:rPr lang="pt-BR" sz="4400" b="1" dirty="0">
+                <a:solidFill>
+                  <a:schemeClr val="bg1"/>
+                </a:solidFill>
+              </a:rPr>
+              <a:t>Qualidade e testes antes de publicar</a:t>
+            </a:r>
+            <a:endParaRPr lang="pt-BR" sz="4400" dirty="0"/>
+          </a:p>
+        </p:txBody>
+      </p:sp>
+      <p:sp>
+        <p:nvSpPr>
+          <p:cNvPr id="5" name="Texto"/>
+          <p:cNvSpPr/>
+          <p:nvPr>
+            <p:ph idx="102" type="body" hasCustomPrompt="1"/>
+          </p:nvPr>
+        </p:nvSpPr>
+        <p:spPr>
+          <a:xfrm>
+            <a:off x="731520" y="3383280"/>
+            <a:ext cx="6949440" cy="914400"/>
+          </a:xfrm>
+          <a:prstGeom prst="rect">
+            <a:avLst/>
+          </a:prstGeom>
+          <a:noFill/>
+          <a:ln/>
+        </p:spPr>
+        <p:txBody>
+          <a:bodyPr wrap="square" lIns="0" tIns="0" rIns="0" bIns="0" rtlCol="0" anchor="t"/>
+          <a:lstStyle/>
+          <a:p>
+            <a:pPr algn="l" indent="0" marL="0">
+              <a:buNone/>
+            </a:pPr>
+            <a:r>
+              <a:rPr lang="pt-BR" sz="1800" dirty="0">
+                <a:solidFill>
+                  <a:schemeClr val="bg2"/>
+                </a:solidFill>
+              </a:rPr>
+              <a:t>Os comandos que quem publica roda na própria máquina, em cada app alterada, antes do npm run deploy.</a:t>
+            </a:r>
+            <a:endParaRPr lang="pt-BR" sz="1800" dirty="0"/>
+          </a:p>
+        </p:txBody>
+      </p:sp>
+      <p:sp>
+        <p:nvSpPr>
+          <p:cNvPr id="6" name="Ícone inspection"/>
+          <p:cNvSpPr/>
+          <p:nvPr/>
+        </p:nvSpPr>
+        <p:spPr>
+          <a:xfrm>
+            <a:off x="731520" y="411480"/>
+            <a:ext cx="731520" cy="731520"/>
+          </a:xfrm>
+          <a:prstGeom prst="roundRect">
+            <a:avLst>
+              <a:gd name="adj" fmla="val 22000"/>
+            </a:avLst>
+          </a:prstGeom>
+          <a:solidFill>
+            <a:srgbClr val="1B3A7A"/>
+          </a:solidFill>
+          <a:ln>
+            <a:noFill/>
+          </a:ln>
+        </p:spPr>
+      </p:sp>
+      <p:pic>
+        <p:nvPicPr>
+          <p:cNvPr id="7" name="Imagem" descr="inspection"/>
+          <p:cNvPicPr>
+            <a:picLocks noChangeAspect="1"/>
+          </p:cNvPicPr>
+          <p:nvPr/>
+        </p:nvPicPr>
+        <p:blipFill>
+          <a:blip r:embed="rId1"/>
+          <a:stretch>
+            <a:fillRect/>
+          </a:stretch>
+        </p:blipFill>
+        <p:spPr>
+          <a:xfrm>
+            <a:off x="905256" y="585216"/>
+            <a:ext cx="384048" cy="384048"/>
+          </a:xfrm>
+          <a:prstGeom prst="rect">
+            <a:avLst/>
+          </a:prstGeom>
+        </p:spPr>
+      </p:pic>
+      <p:sp>
+        <p:nvSpPr>
+          <p:cNvPr id="8" name="Objetos da seção"/>
+          <p:cNvSpPr/>
+          <p:nvPr/>
+        </p:nvSpPr>
+        <p:spPr>
+          <a:xfrm>
+            <a:off x="8001000" y="1325880"/>
+            <a:ext cx="3639312" cy="2980944"/>
+          </a:xfrm>
+          <a:prstGeom prst="roundRect">
+            <a:avLst>
+              <a:gd name="adj" fmla="val 3670"/>
+            </a:avLst>
+          </a:prstGeom>
+          <a:solidFill>
+            <a:srgbClr val="1B3A7A"/>
+          </a:solidFill>
+          <a:ln>
+            <a:noFill/>
+          </a:ln>
+        </p:spPr>
+      </p:sp>
+      <p:sp>
+        <p:nvSpPr>
+          <p:cNvPr id="9" name="Texto"/>
+          <p:cNvSpPr txBox="1"/>
+          <p:nvPr/>
+        </p:nvSpPr>
+        <p:spPr>
+          <a:xfrm>
+            <a:off x="8275320" y="1481328"/>
+            <a:ext cx="3090672" cy="274320"/>
+          </a:xfrm>
+          <a:prstGeom prst="roundRect">
+            <a:avLst/>
+          </a:prstGeom>
+          <a:noFill/>
+          <a:ln>
+            <a:noFill/>
+          </a:ln>
+        </p:spPr>
+        <p:txBody>
+          <a:bodyPr wrap="square" lIns="0" tIns="0" rIns="0" bIns="0" rtlCol="0" anchor="ctr"/>
+          <a:lstStyle/>
+          <a:p>
+            <a:pPr algn="l" indent="0" marL="0">
+              <a:buNone/>
+            </a:pPr>
+            <a:r>
+              <a:rPr lang="pt-BR" sz="1100" b="1" spc="150" kern="0" dirty="0">
+                <a:solidFill>
+                  <a:srgbClr val="89D1FF"/>
+                </a:solidFill>
+              </a:rPr>
+              <a:t>OBJETOS NESTA SEÇÃO</a:t>
+            </a:r>
+            <a:endParaRPr lang="pt-BR" sz="1100" dirty="0"/>
+          </a:p>
+        </p:txBody>
+      </p:sp>
+      <p:sp>
+        <p:nvSpPr>
+          <p:cNvPr id="10" name="Texto"/>
+          <p:cNvSpPr txBox="1"/>
+          <p:nvPr/>
+        </p:nvSpPr>
+        <p:spPr>
+          <a:xfrm>
+            <a:off x="8275320" y="1874520"/>
+            <a:ext cx="3246120" cy="384048"/>
+          </a:xfrm>
+          <a:prstGeom prst="roundRect">
+            <a:avLst/>
+          </a:prstGeom>
+          <a:noFill/>
+          <a:ln>
+            <a:noFill/>
+          </a:ln>
+        </p:spPr>
+        <p:txBody>
+          <a:bodyPr wrap="square" lIns="0" tIns="0" rIns="0" bIns="0" rtlCol="0" anchor="ctr"/>
+          <a:lstStyle/>
+          <a:p>
+            <a:pPr algn="l" indent="0" marL="0">
+              <a:buNone/>
+            </a:pPr>
+            <a:r>
+              <a:rPr lang="pt-BR" sz="1100" b="1" dirty="0">
+                <a:solidFill>
+                  <a:srgbClr val="FFFFFF"/>
+                </a:solidFill>
+                <a:latin typeface="Courier New" pitchFamily="34" charset="0"/>
+                <a:ea typeface="Courier New" pitchFamily="34" charset="-122"/>
+                <a:cs typeface="Courier New" pitchFamily="34" charset="-120"/>
+              </a:rPr>
+              <a:t>npm run lint</a:t>
+            </a:r>
+            <a:r>
+              <a:rPr lang="pt-BR" sz="1100" dirty="0">
+                <a:solidFill>
+                  <a:srgbClr val="D1EFFF"/>
+                </a:solidFill>
+              </a:rPr>
+              <a:t xml:space="preserve">  ESLint do Fiori tools</a:t>
+            </a:r>
+            <a:endParaRPr lang="pt-BR" sz="1100" dirty="0"/>
+          </a:p>
+        </p:txBody>
+      </p:sp>
+      <p:sp>
+        <p:nvSpPr>
+          <p:cNvPr id="11" name="Texto"/>
+          <p:cNvSpPr txBox="1"/>
+          <p:nvPr/>
+        </p:nvSpPr>
+        <p:spPr>
+          <a:xfrm>
+            <a:off x="8275320" y="2258568"/>
+            <a:ext cx="3246120" cy="384048"/>
+          </a:xfrm>
+          <a:prstGeom prst="roundRect">
+            <a:avLst/>
+          </a:prstGeom>
+          <a:noFill/>
+          <a:ln>
+            <a:noFill/>
+          </a:ln>
+        </p:spPr>
+        <p:txBody>
+          <a:bodyPr wrap="square" lIns="0" tIns="0" rIns="0" bIns="0" rtlCol="0" anchor="ctr"/>
+          <a:lstStyle/>
+          <a:p>
+            <a:pPr algn="l" indent="0" marL="0">
+              <a:buNone/>
+            </a:pPr>
+            <a:r>
+              <a:rPr lang="pt-BR" sz="1100" b="1" dirty="0">
+                <a:solidFill>
+                  <a:srgbClr val="FFFFFF"/>
+                </a:solidFill>
+                <a:latin typeface="Courier New" pitchFamily="34" charset="0"/>
+                <a:ea typeface="Courier New" pitchFamily="34" charset="-122"/>
+                <a:cs typeface="Courier New" pitchFamily="34" charset="-120"/>
+              </a:rPr>
+              <a:t>npm run build</a:t>
+            </a:r>
+            <a:r>
+              <a:rPr lang="pt-BR" sz="1100" dirty="0">
+                <a:solidFill>
+                  <a:srgbClr val="D1EFFF"/>
+                </a:solidFill>
+              </a:rPr>
+              <a:t xml:space="preserve">  dist/ do ui5 build</a:t>
+            </a:r>
+            <a:endParaRPr lang="pt-BR" sz="1100" dirty="0"/>
+          </a:p>
+        </p:txBody>
+      </p:sp>
+      <p:sp>
+        <p:nvSpPr>
+          <p:cNvPr id="12" name="Texto"/>
+          <p:cNvSpPr txBox="1"/>
+          <p:nvPr/>
+        </p:nvSpPr>
+        <p:spPr>
+          <a:xfrm>
+            <a:off x="8275320" y="2642616"/>
+            <a:ext cx="3246120" cy="384048"/>
+          </a:xfrm>
+          <a:prstGeom prst="roundRect">
+            <a:avLst/>
+          </a:prstGeom>
+          <a:noFill/>
+          <a:ln>
+            <a:noFill/>
+          </a:ln>
+        </p:spPr>
+        <p:txBody>
+          <a:bodyPr wrap="square" lIns="0" tIns="0" rIns="0" bIns="0" rtlCol="0" anchor="ctr"/>
+          <a:lstStyle/>
+          <a:p>
+            <a:pPr algn="l" indent="0" marL="0">
+              <a:buNone/>
+            </a:pPr>
+            <a:r>
+              <a:rPr lang="pt-BR" sz="1100" b="1" dirty="0">
+                <a:solidFill>
+                  <a:srgbClr val="FFFFFF"/>
+                </a:solidFill>
+                <a:latin typeface="Courier New" pitchFamily="34" charset="0"/>
+                <a:ea typeface="Courier New" pitchFamily="34" charset="-122"/>
+                <a:cs typeface="Courier New" pitchFamily="34" charset="-120"/>
+              </a:rPr>
+              <a:t>npm run int-test</a:t>
+            </a:r>
+            <a:r>
+              <a:rPr lang="pt-BR" sz="1100" dirty="0">
+                <a:solidFill>
+                  <a:srgbClr val="D1EFFF"/>
+                </a:solidFill>
+              </a:rPr>
+              <a:t xml:space="preserve">  OPA5, apps de gestão</a:t>
+            </a:r>
+            <a:endParaRPr lang="pt-BR" sz="1100" dirty="0"/>
+          </a:p>
+        </p:txBody>
+      </p:sp>
+      <p:sp>
+        <p:nvSpPr>
+          <p:cNvPr id="13" name="Texto"/>
+          <p:cNvSpPr txBox="1"/>
+          <p:nvPr/>
+        </p:nvSpPr>
+        <p:spPr>
+          <a:xfrm>
+            <a:off x="8275320" y="3026664"/>
+            <a:ext cx="3246120" cy="384048"/>
+          </a:xfrm>
+          <a:prstGeom prst="roundRect">
+            <a:avLst/>
+          </a:prstGeom>
+          <a:noFill/>
+          <a:ln>
+            <a:noFill/>
+          </a:ln>
+        </p:spPr>
+        <p:txBody>
+          <a:bodyPr wrap="square" lIns="0" tIns="0" rIns="0" bIns="0" rtlCol="0" anchor="ctr"/>
+          <a:lstStyle/>
+          <a:p>
+            <a:pPr algn="l" indent="0" marL="0">
+              <a:buNone/>
+            </a:pPr>
+            <a:r>
+              <a:rPr lang="pt-BR" sz="1100" b="1" dirty="0">
+                <a:solidFill>
+                  <a:srgbClr val="FFFFFF"/>
+                </a:solidFill>
+                <a:latin typeface="Courier New" pitchFamily="34" charset="0"/>
+                <a:ea typeface="Courier New" pitchFamily="34" charset="-122"/>
+                <a:cs typeface="Courier New" pitchFamily="34" charset="-120"/>
+              </a:rPr>
+              <a:t>npm run unit-test</a:t>
+            </a:r>
+            <a:r>
+              <a:rPr lang="pt-BR" sz="1100" dirty="0">
+                <a:solidFill>
+                  <a:srgbClr val="D1EFFF"/>
+                </a:solidFill>
+              </a:rPr>
+              <a:t xml:space="preserve">  QUnit, análises</a:t>
+            </a:r>
+            <a:endParaRPr lang="pt-BR" sz="1100" dirty="0"/>
+          </a:p>
+        </p:txBody>
+      </p:sp>
+      <p:sp>
+        <p:nvSpPr>
+          <p:cNvPr id="14" name="Texto"/>
+          <p:cNvSpPr txBox="1"/>
+          <p:nvPr/>
+        </p:nvSpPr>
+        <p:spPr>
+          <a:xfrm>
+            <a:off x="8275320" y="3410712"/>
+            <a:ext cx="3246120" cy="384048"/>
+          </a:xfrm>
+          <a:prstGeom prst="roundRect">
+            <a:avLst/>
+          </a:prstGeom>
+          <a:noFill/>
+          <a:ln>
+            <a:noFill/>
+          </a:ln>
+        </p:spPr>
+        <p:txBody>
+          <a:bodyPr wrap="square" lIns="0" tIns="0" rIns="0" bIns="0" rtlCol="0" anchor="ctr"/>
+          <a:lstStyle/>
+          <a:p>
+            <a:pPr algn="l" indent="0" marL="0">
+              <a:buNone/>
+            </a:pPr>
+            <a:r>
+              <a:rPr lang="pt-BR" sz="1100" b="1" dirty="0">
+                <a:solidFill>
+                  <a:srgbClr val="FFFFFF"/>
+                </a:solidFill>
+                <a:latin typeface="Courier New" pitchFamily="34" charset="0"/>
+                <a:ea typeface="Courier New" pitchFamily="34" charset="-122"/>
+                <a:cs typeface="Courier New" pitchFamily="34" charset="-120"/>
+              </a:rPr>
+              <a:t>npx @ui5/linter</a:t>
+            </a:r>
+            <a:r>
+              <a:rPr lang="pt-BR" sz="1100" dirty="0">
+                <a:solidFill>
+                  <a:srgbClr val="D1EFFF"/>
+                </a:solidFill>
+              </a:rPr>
+              <a:t xml:space="preserve">  UI5 linter</a:t>
+            </a:r>
+            <a:endParaRPr lang="pt-BR" sz="1100" dirty="0"/>
+          </a:p>
+        </p:txBody>
+      </p:sp>
+      <p:sp>
+        <p:nvSpPr>
+          <p:cNvPr id="15" name="Texto"/>
+          <p:cNvSpPr txBox="1"/>
+          <p:nvPr/>
+        </p:nvSpPr>
+        <p:spPr>
+          <a:xfrm>
+            <a:off x="8275320" y="3794760"/>
+            <a:ext cx="3246120" cy="384048"/>
+          </a:xfrm>
+          <a:prstGeom prst="roundRect">
+            <a:avLst/>
+          </a:prstGeom>
+          <a:noFill/>
+          <a:ln>
+            <a:noFill/>
+          </a:ln>
+        </p:spPr>
+        <p:txBody>
+          <a:bodyPr wrap="square" lIns="0" tIns="0" rIns="0" bIns="0" rtlCol="0" anchor="ctr"/>
+          <a:lstStyle/>
+          <a:p>
+            <a:pPr algn="l" indent="0" marL="0">
+              <a:buNone/>
+            </a:pPr>
+            <a:r>
+              <a:rPr lang="pt-BR" sz="1100" b="1" dirty="0">
+                <a:solidFill>
+                  <a:srgbClr val="FFFFFF"/>
+                </a:solidFill>
+                <a:latin typeface="Courier New" pitchFamily="34" charset="0"/>
+                <a:ea typeface="Courier New" pitchFamily="34" charset="-122"/>
+                <a:cs typeface="Courier New" pitchFamily="34" charset="-120"/>
+              </a:rPr>
+              <a:t>npm run deploy-test</a:t>
+            </a:r>
+            <a:r>
+              <a:rPr lang="pt-BR" sz="1100" dirty="0">
+                <a:solidFill>
+                  <a:srgbClr val="D1EFFF"/>
+                </a:solidFill>
+              </a:rPr>
+              <a:t xml:space="preserve">  deploy simulado</a:t>
+            </a:r>
+            <a:endParaRPr lang="pt-BR" sz="1100" dirty="0"/>
+          </a:p>
+        </p:txBody>
+      </p:sp>
+    </p:spTree>
+  </p:cSld>
+  <p:clrMapOvr>
+    <a:masterClrMapping/>
+  </p:clrMapOvr>
+</p:sld>
+</file>
+
+<file path=ppt/slides/slide33.xml><?xml version="1.0" encoding="utf-8"?>
+<p:sld xmlns:a="http://schemas.openxmlformats.org/drawingml/2006/main" xmlns:r="http://schemas.openxmlformats.org/officeDocument/2006/relationships" xmlns:p="http://schemas.openxmlformats.org/presentationml/2006/main">
+  <p:cSld>
+    <p:spTree>
+      <p:nvGrpSpPr>
+        <p:cNvPr id="1" name=""/>
+        <p:cNvGrpSpPr/>
+        <p:nvPr/>
+      </p:nvGrpSpPr>
+      <p:grpSpPr>
+        <a:xfrm>
+          <a:off x="0" y="0"/>
+          <a:ext cx="0" cy="0"/>
+          <a:chOff x="0" y="0"/>
+          <a:chExt cx="0" cy="0"/>
+        </a:xfrm>
+      </p:grpSpPr>
+      <p:sp>
+        <p:nvSpPr>
+          <p:cNvPr id="3" name="Rótulo"/>
+          <p:cNvSpPr/>
+          <p:nvPr>
+            <p:ph idx="100" type="body" hasCustomPrompt="1"/>
+          </p:nvPr>
+        </p:nvSpPr>
+        <p:spPr>
+          <a:xfrm>
+            <a:off x="548640" y="384048"/>
+            <a:ext cx="9144000" cy="274320"/>
+          </a:xfrm>
+          <a:prstGeom prst="rect">
+            <a:avLst/>
+          </a:prstGeom>
+          <a:noFill/>
+          <a:ln/>
+        </p:spPr>
+        <p:txBody>
+          <a:bodyPr wrap="square" lIns="0" tIns="0" rIns="0" bIns="0" rtlCol="0" anchor="ctr"/>
+          <a:lstStyle/>
+          <a:p>
+            <a:pPr algn="l" indent="0" marL="0">
+              <a:buNone/>
+            </a:pPr>
+            <a:r>
+              <a:rPr lang="pt-BR" sz="1100" b="1" spc="150" kern="0" dirty="0">
+                <a:solidFill>
+                  <a:schemeClr val="accent1"/>
+                </a:solidFill>
+              </a:rPr>
+              <a:t>ANTES DO DEPLOY · IMPORTÂNCIA</a:t>
+            </a:r>
+            <a:endParaRPr lang="pt-BR" sz="1100" dirty="0"/>
+          </a:p>
+        </p:txBody>
+      </p:sp>
+      <p:sp>
+        <p:nvSpPr>
+          <p:cNvPr id="4" name="Título"/>
+          <p:cNvSpPr/>
+          <p:nvPr>
+            <p:ph idx="101" type="title" hasCustomPrompt="1"/>
+          </p:nvPr>
+        </p:nvSpPr>
+        <p:spPr>
+          <a:xfrm>
+            <a:off x="548640" y="676656"/>
+            <a:ext cx="11094415" cy="658368"/>
+          </a:xfrm>
+          <a:prstGeom prst="rect">
+            <a:avLst/>
+          </a:prstGeom>
+          <a:noFill/>
+          <a:ln/>
+        </p:spPr>
+        <p:txBody>
+          <a:bodyPr wrap="square" lIns="0" tIns="0" rIns="0" bIns="0" rtlCol="0" anchor="ctr"/>
+          <a:lstStyle/>
+          <a:p>
+            <a:pPr algn="l" indent="0" marL="0">
+              <a:buNone/>
+            </a:pPr>
+            <a:r>
+              <a:rPr lang="pt-BR" sz="3000" b="1" dirty="0">
+                <a:solidFill>
+                  <a:schemeClr val="tx1"/>
+                </a:solidFill>
+              </a:rPr>
+              <a:t>O que cada comando impede de chegar ao sistema</a:t>
+            </a:r>
+            <a:endParaRPr lang="pt-BR" sz="3000" dirty="0"/>
+          </a:p>
+        </p:txBody>
+      </p:sp>
+      <p:sp>
+        <p:nvSpPr>
+          <p:cNvPr id="5" name="Texto"/>
+          <p:cNvSpPr txBox="1"/>
+          <p:nvPr/>
+        </p:nvSpPr>
+        <p:spPr>
+          <a:xfrm>
+            <a:off x="3108960" y="1463040"/>
+            <a:ext cx="3840480" cy="256032"/>
+          </a:xfrm>
+          <a:prstGeom prst="roundRect">
+            <a:avLst/>
+          </a:prstGeom>
+          <a:noFill/>
+          <a:ln>
+            <a:noFill/>
+          </a:ln>
+        </p:spPr>
+        <p:txBody>
+          <a:bodyPr wrap="square" lIns="0" tIns="0" rIns="0" bIns="0" rtlCol="0" anchor="ctr"/>
+          <a:lstStyle/>
+          <a:p>
+            <a:pPr algn="l" indent="0" marL="0">
+              <a:buNone/>
+            </a:pPr>
+            <a:r>
+              <a:rPr lang="pt-BR" sz="1000" b="1" spc="120" kern="0" dirty="0">
+                <a:solidFill>
+                  <a:srgbClr val="556B82"/>
+                </a:solidFill>
+              </a:rPr>
+              <a:t>O QUE VERIFICA</a:t>
+            </a:r>
+            <a:endParaRPr lang="pt-BR" sz="1000" dirty="0"/>
+          </a:p>
+        </p:txBody>
+      </p:sp>
+      <p:sp>
+        <p:nvSpPr>
+          <p:cNvPr id="6" name="Texto"/>
+          <p:cNvSpPr txBox="1"/>
+          <p:nvPr/>
+        </p:nvSpPr>
+        <p:spPr>
+          <a:xfrm>
+            <a:off x="7315200" y="1463040"/>
+            <a:ext cx="4206240" cy="256032"/>
+          </a:xfrm>
+          <a:prstGeom prst="roundRect">
+            <a:avLst/>
+          </a:prstGeom>
+          <a:noFill/>
+          <a:ln>
+            <a:noFill/>
+          </a:ln>
+        </p:spPr>
+        <p:txBody>
+          <a:bodyPr wrap="square" lIns="0" tIns="0" rIns="0" bIns="0" rtlCol="0" anchor="ctr"/>
+          <a:lstStyle/>
+          <a:p>
+            <a:pPr algn="l" indent="0" marL="0">
+              <a:buNone/>
+            </a:pPr>
+            <a:r>
+              <a:rPr lang="pt-BR" sz="1000" b="1" spc="120" kern="0" dirty="0">
+                <a:solidFill>
+                  <a:srgbClr val="AA0808"/>
+                </a:solidFill>
+              </a:rPr>
+              <a:t>SE PULAR, APARECE…</a:t>
+            </a:r>
+            <a:endParaRPr lang="pt-BR" sz="1000" dirty="0"/>
+          </a:p>
+        </p:txBody>
+      </p:sp>
+      <p:sp>
+        <p:nvSpPr>
+          <p:cNvPr id="7" name="Cartão"/>
+          <p:cNvSpPr/>
+          <p:nvPr/>
+        </p:nvSpPr>
+        <p:spPr>
+          <a:xfrm>
+            <a:off x="548640" y="1783080"/>
+            <a:ext cx="11091672" cy="630936"/>
+          </a:xfrm>
+          <a:prstGeom prst="roundRect">
+            <a:avLst>
+              <a:gd name="adj" fmla="val 5217"/>
+            </a:avLst>
+          </a:prstGeom>
+          <a:solidFill>
+            <a:srgbClr val="FFFFFF"/>
+          </a:solidFill>
+          <a:ln>
+            <a:noFill/>
+          </a:ln>
+          <a:effectLst>
+            <a:outerShdw sx="100000" sy="100000" kx="0" ky="0" algn="bl" rotWithShape="0" blurRad="101600" dist="25400" dir="5400000">
+              <a:srgbClr val="223548">
+                <a:alpha val="16000"/>
+              </a:srgbClr>
+            </a:outerShdw>
+          </a:effectLst>
+        </p:spPr>
+      </p:sp>
+      <p:sp>
+        <p:nvSpPr>
+          <p:cNvPr id="8" name="Ícone inspection"/>
+          <p:cNvSpPr/>
+          <p:nvPr/>
+        </p:nvSpPr>
+        <p:spPr>
+          <a:xfrm>
+            <a:off x="713232" y="1892808"/>
+            <a:ext cx="411480" cy="411480"/>
+          </a:xfrm>
+          <a:prstGeom prst="roundRect">
+            <a:avLst>
+              <a:gd name="adj" fmla="val 22000"/>
+            </a:avLst>
+          </a:prstGeom>
+          <a:solidFill>
+            <a:srgbClr val="E1F4FF"/>
+          </a:solidFill>
+          <a:ln>
+            <a:noFill/>
+          </a:ln>
+        </p:spPr>
+      </p:sp>
+      <p:pic>
+        <p:nvPicPr>
+          <p:cNvPr id="9" name="Imagem" descr="inspection"/>
+          <p:cNvPicPr>
+            <a:picLocks noChangeAspect="1"/>
+          </p:cNvPicPr>
+          <p:nvPr/>
+        </p:nvPicPr>
+        <p:blipFill>
+          <a:blip r:embed="rId1"/>
+          <a:stretch>
+            <a:fillRect/>
+          </a:stretch>
+        </p:blipFill>
+        <p:spPr>
+          <a:xfrm>
+            <a:off x="811987" y="1991563"/>
+            <a:ext cx="213970" cy="213970"/>
+          </a:xfrm>
+          <a:prstGeom prst="rect">
+            <a:avLst/>
+          </a:prstGeom>
+        </p:spPr>
+      </p:pic>
+      <p:sp>
+        <p:nvSpPr>
+          <p:cNvPr id="10" name="Texto"/>
+          <p:cNvSpPr txBox="1"/>
+          <p:nvPr/>
+        </p:nvSpPr>
+        <p:spPr>
+          <a:xfrm>
+            <a:off x="1261872" y="1783080"/>
+            <a:ext cx="1783080" cy="630936"/>
+          </a:xfrm>
+          <a:prstGeom prst="roundRect">
+            <a:avLst/>
+          </a:prstGeom>
+          <a:noFill/>
+          <a:ln>
+            <a:noFill/>
+          </a:ln>
+        </p:spPr>
+        <p:txBody>
+          <a:bodyPr wrap="square" lIns="0" tIns="0" rIns="0" bIns="0" rtlCol="0" anchor="ctr"/>
+          <a:lstStyle/>
+          <a:p>
+            <a:pPr algn="l" indent="0" marL="0">
+              <a:buNone/>
+            </a:pPr>
+            <a:r>
+              <a:rPr lang="pt-BR" sz="1100" b="1" dirty="0">
+                <a:solidFill>
+                  <a:srgbClr val="1D2D3E"/>
+                </a:solidFill>
+                <a:latin typeface="Courier New" pitchFamily="34" charset="0"/>
+                <a:ea typeface="Courier New" pitchFamily="34" charset="-122"/>
+                <a:cs typeface="Courier New" pitchFamily="34" charset="-120"/>
+              </a:rPr>
+              <a:t>npm run lint</a:t>
+            </a:r>
+            <a:endParaRPr lang="pt-BR" sz="1100" dirty="0"/>
+          </a:p>
+        </p:txBody>
+      </p:sp>
+      <p:sp>
+        <p:nvSpPr>
+          <p:cNvPr id="11" name="Texto"/>
+          <p:cNvSpPr txBox="1"/>
+          <p:nvPr/>
+        </p:nvSpPr>
+        <p:spPr>
+          <a:xfrm>
+            <a:off x="3108960" y="1783080"/>
+            <a:ext cx="3840480" cy="630936"/>
+          </a:xfrm>
+          <a:prstGeom prst="roundRect">
+            <a:avLst/>
+          </a:prstGeom>
+          <a:noFill/>
+          <a:ln>
+            <a:noFill/>
+          </a:ln>
+        </p:spPr>
+        <p:txBody>
+          <a:bodyPr wrap="square" lIns="0" tIns="0" rIns="0" bIns="0" rtlCol="0" anchor="ctr"/>
+          <a:lstStyle/>
+          <a:p>
+            <a:pPr algn="l" indent="0" marL="0">
+              <a:buNone/>
+            </a:pPr>
+            <a:r>
+              <a:rPr lang="pt-BR" sz="1150" dirty="0">
+                <a:solidFill>
+                  <a:srgbClr val="1D2D3E"/>
+                </a:solidFill>
+              </a:rPr>
+              <a:t>Erros de JavaScript e as regras do plugin Fiori tools do ESLint</a:t>
+            </a:r>
+            <a:endParaRPr lang="pt-BR" sz="1150" dirty="0"/>
+          </a:p>
+        </p:txBody>
+      </p:sp>
+      <p:cxnSp>
+        <p:nvCxnSpPr>
+          <p:cNvPr id="12" name="Conector"/>
+          <p:cNvCxnSpPr/>
+          <p:nvPr/>
+        </p:nvCxnSpPr>
+        <p:spPr>
+          <a:xfrm>
+            <a:off x="7178040" y="1920240"/>
+            <a:ext cx="0" cy="356616"/>
+          </a:xfrm>
+          <a:prstGeom prst="line">
+            <a:avLst/>
+          </a:prstGeom>
+          <a:noFill/>
+          <a:ln w="12700">
+            <a:solidFill>
+              <a:srgbClr val="E5E5E5"/>
+            </a:solidFill>
+            <a:prstDash val="solid"/>
+            <a:round/>
+          </a:ln>
+        </p:spPr>
+      </p:cxnSp>
+      <p:sp>
+        <p:nvSpPr>
+          <p:cNvPr id="13" name="Texto"/>
+          <p:cNvSpPr txBox="1"/>
+          <p:nvPr/>
+        </p:nvSpPr>
+        <p:spPr>
+          <a:xfrm>
+            <a:off x="7315200" y="1783080"/>
+            <a:ext cx="4206240" cy="630936"/>
+          </a:xfrm>
+          <a:prstGeom prst="roundRect">
+            <a:avLst/>
+          </a:prstGeom>
+          <a:noFill/>
+          <a:ln>
+            <a:noFill/>
+          </a:ln>
+        </p:spPr>
+        <p:txBody>
+          <a:bodyPr wrap="square" lIns="0" tIns="0" rIns="0" bIns="0" rtlCol="0" anchor="ctr"/>
+          <a:lstStyle/>
+          <a:p>
+            <a:pPr algn="l" indent="0" marL="0">
+              <a:buNone/>
+            </a:pPr>
+            <a:r>
+              <a:rPr lang="pt-BR" sz="1150" dirty="0">
+                <a:solidFill>
+                  <a:srgbClr val="556B82"/>
+                </a:solidFill>
+              </a:rPr>
+              <a:t>…no navegador de quem abre a app publicada</a:t>
+            </a:r>
+            <a:endParaRPr lang="pt-BR" sz="1150" dirty="0"/>
+          </a:p>
+        </p:txBody>
+      </p:sp>
+      <p:sp>
+        <p:nvSpPr>
+          <p:cNvPr id="14" name="Cartão"/>
+          <p:cNvSpPr/>
+          <p:nvPr/>
+        </p:nvSpPr>
+        <p:spPr>
+          <a:xfrm>
+            <a:off x="548640" y="2505456"/>
+            <a:ext cx="11091672" cy="630936"/>
+          </a:xfrm>
+          <a:prstGeom prst="roundRect">
+            <a:avLst>
+              <a:gd name="adj" fmla="val 5217"/>
+            </a:avLst>
+          </a:prstGeom>
+          <a:solidFill>
+            <a:srgbClr val="FFFFFF"/>
+          </a:solidFill>
+          <a:ln>
+            <a:noFill/>
+          </a:ln>
+          <a:effectLst>
+            <a:outerShdw sx="100000" sy="100000" kx="0" ky="0" algn="bl" rotWithShape="0" blurRad="101600" dist="25400" dir="5400000">
+              <a:srgbClr val="223548">
+                <a:alpha val="16000"/>
+              </a:srgbClr>
+            </a:outerShdw>
+          </a:effectLst>
+        </p:spPr>
+      </p:sp>
+      <p:sp>
+        <p:nvSpPr>
+          <p:cNvPr id="15" name="Ícone sap-box"/>
+          <p:cNvSpPr/>
+          <p:nvPr/>
+        </p:nvSpPr>
+        <p:spPr>
+          <a:xfrm>
+            <a:off x="713232" y="2615184"/>
+            <a:ext cx="411480" cy="411480"/>
+          </a:xfrm>
+          <a:prstGeom prst="roundRect">
+            <a:avLst>
+              <a:gd name="adj" fmla="val 22000"/>
+            </a:avLst>
+          </a:prstGeom>
+          <a:solidFill>
+            <a:srgbClr val="E3F7F6"/>
+          </a:solidFill>
+          <a:ln>
+            <a:noFill/>
+          </a:ln>
+        </p:spPr>
+      </p:sp>
+      <p:pic>
+        <p:nvPicPr>
+          <p:cNvPr id="16" name="Imagem" descr="sap-box"/>
+          <p:cNvPicPr>
+            <a:picLocks noChangeAspect="1"/>
+          </p:cNvPicPr>
+          <p:nvPr/>
+        </p:nvPicPr>
+        <p:blipFill>
+          <a:blip r:embed="rId2"/>
+          <a:stretch>
+            <a:fillRect/>
+          </a:stretch>
+        </p:blipFill>
+        <p:spPr>
+          <a:xfrm>
+            <a:off x="811987" y="2713939"/>
+            <a:ext cx="213970" cy="213970"/>
+          </a:xfrm>
+          <a:prstGeom prst="rect">
+            <a:avLst/>
+          </a:prstGeom>
+        </p:spPr>
+      </p:pic>
+      <p:sp>
+        <p:nvSpPr>
+          <p:cNvPr id="17" name="Texto"/>
+          <p:cNvSpPr txBox="1"/>
+          <p:nvPr/>
+        </p:nvSpPr>
+        <p:spPr>
+          <a:xfrm>
+            <a:off x="1261872" y="2505456"/>
+            <a:ext cx="1783080" cy="630936"/>
+          </a:xfrm>
+          <a:prstGeom prst="roundRect">
+            <a:avLst/>
+          </a:prstGeom>
+          <a:noFill/>
+          <a:ln>
+            <a:noFill/>
+          </a:ln>
+        </p:spPr>
+        <p:txBody>
+          <a:bodyPr wrap="square" lIns="0" tIns="0" rIns="0" bIns="0" rtlCol="0" anchor="ctr"/>
+          <a:lstStyle/>
+          <a:p>
+            <a:pPr algn="l" indent="0" marL="0">
+              <a:buNone/>
+            </a:pPr>
+            <a:r>
+              <a:rPr lang="pt-BR" sz="1100" b="1" dirty="0">
+                <a:solidFill>
+                  <a:srgbClr val="1D2D3E"/>
+                </a:solidFill>
+                <a:latin typeface="Courier New" pitchFamily="34" charset="0"/>
+                <a:ea typeface="Courier New" pitchFamily="34" charset="-122"/>
+                <a:cs typeface="Courier New" pitchFamily="34" charset="-120"/>
+              </a:rPr>
+              <a:t>npm run build</a:t>
+            </a:r>
+            <a:endParaRPr lang="pt-BR" sz="1100" dirty="0"/>
+          </a:p>
+        </p:txBody>
+      </p:sp>
+      <p:sp>
+        <p:nvSpPr>
+          <p:cNvPr id="18" name="Texto"/>
+          <p:cNvSpPr txBox="1"/>
+          <p:nvPr/>
+        </p:nvSpPr>
+        <p:spPr>
+          <a:xfrm>
+            <a:off x="3108960" y="2505456"/>
+            <a:ext cx="3840480" cy="630936"/>
+          </a:xfrm>
+          <a:prstGeom prst="roundRect">
+            <a:avLst/>
+          </a:prstGeom>
+          <a:noFill/>
+          <a:ln>
+            <a:noFill/>
+          </a:ln>
+        </p:spPr>
+        <p:txBody>
+          <a:bodyPr wrap="square" lIns="0" tIns="0" rIns="0" bIns="0" rtlCol="0" anchor="ctr"/>
+          <a:lstStyle/>
+          <a:p>
+            <a:pPr algn="l" indent="0" marL="0">
+              <a:buNone/>
+            </a:pPr>
+            <a:r>
+              <a:rPr lang="pt-BR" sz="1150" dirty="0">
+                <a:solidFill>
+                  <a:srgbClr val="1D2D3E"/>
+                </a:solidFill>
+              </a:rPr>
+              <a:t>Que o projeto gera o dist/ com preload e cachebuster</a:t>
+            </a:r>
+            <a:endParaRPr lang="pt-BR" sz="1150" dirty="0"/>
+          </a:p>
+        </p:txBody>
+      </p:sp>
+      <p:cxnSp>
+        <p:nvCxnSpPr>
+          <p:cNvPr id="19" name="Conector"/>
+          <p:cNvCxnSpPr/>
+          <p:nvPr/>
+        </p:nvCxnSpPr>
+        <p:spPr>
+          <a:xfrm>
+            <a:off x="7178040" y="2642616"/>
+            <a:ext cx="0" cy="356616"/>
+          </a:xfrm>
+          <a:prstGeom prst="line">
+            <a:avLst/>
+          </a:prstGeom>
+          <a:noFill/>
+          <a:ln w="12700">
+            <a:solidFill>
+              <a:srgbClr val="E5E5E5"/>
+            </a:solidFill>
+            <a:prstDash val="solid"/>
+            <a:round/>
+          </a:ln>
+        </p:spPr>
+      </p:cxnSp>
+      <p:sp>
+        <p:nvSpPr>
+          <p:cNvPr id="20" name="Texto"/>
+          <p:cNvSpPr txBox="1"/>
+          <p:nvPr/>
+        </p:nvSpPr>
+        <p:spPr>
+          <a:xfrm>
+            <a:off x="7315200" y="2505456"/>
+            <a:ext cx="4206240" cy="630936"/>
+          </a:xfrm>
+          <a:prstGeom prst="roundRect">
+            <a:avLst/>
+          </a:prstGeom>
+          <a:noFill/>
+          <a:ln>
+            <a:noFill/>
+          </a:ln>
+        </p:spPr>
+        <p:txBody>
+          <a:bodyPr wrap="square" lIns="0" tIns="0" rIns="0" bIns="0" rtlCol="0" anchor="ctr"/>
+          <a:lstStyle/>
+          <a:p>
+            <a:pPr algn="l" indent="0" marL="0">
+              <a:buNone/>
+            </a:pPr>
+            <a:r>
+              <a:rPr lang="pt-BR" sz="1150" dirty="0">
+                <a:solidFill>
+                  <a:srgbClr val="556B82"/>
+                </a:solidFill>
+              </a:rPr>
+              <a:t>…no meio do deploy, junto com erros de conexão e pacote</a:t>
+            </a:r>
+            <a:endParaRPr lang="pt-BR" sz="1150" dirty="0"/>
+          </a:p>
+        </p:txBody>
+      </p:sp>
+      <p:sp>
+        <p:nvSpPr>
+          <p:cNvPr id="21" name="Cartão"/>
+          <p:cNvSpPr/>
+          <p:nvPr/>
+        </p:nvSpPr>
+        <p:spPr>
+          <a:xfrm>
+            <a:off x="548640" y="3227832"/>
+            <a:ext cx="11091672" cy="630936"/>
+          </a:xfrm>
+          <a:prstGeom prst="roundRect">
+            <a:avLst>
+              <a:gd name="adj" fmla="val 5217"/>
+            </a:avLst>
+          </a:prstGeom>
+          <a:solidFill>
+            <a:srgbClr val="FFFFFF"/>
+          </a:solidFill>
+          <a:ln>
+            <a:noFill/>
+          </a:ln>
+          <a:effectLst>
+            <a:outerShdw sx="100000" sy="100000" kx="0" ky="0" algn="bl" rotWithShape="0" blurRad="101600" dist="25400" dir="5400000">
+              <a:srgbClr val="223548">
+                <a:alpha val="16000"/>
+              </a:srgbClr>
+            </a:outerShdw>
+          </a:effectLst>
+        </p:spPr>
+      </p:sp>
+      <p:sp>
+        <p:nvSpPr>
+          <p:cNvPr id="22" name="Ícone validate"/>
+          <p:cNvSpPr/>
+          <p:nvPr/>
+        </p:nvSpPr>
+        <p:spPr>
+          <a:xfrm>
+            <a:off x="713232" y="3337560"/>
+            <a:ext cx="411480" cy="411480"/>
+          </a:xfrm>
+          <a:prstGeom prst="roundRect">
+            <a:avLst>
+              <a:gd name="adj" fmla="val 22000"/>
+            </a:avLst>
+          </a:prstGeom>
+          <a:solidFill>
+            <a:srgbClr val="F5FAE5"/>
+          </a:solidFill>
+          <a:ln>
+            <a:noFill/>
+          </a:ln>
+        </p:spPr>
+      </p:sp>
+      <p:pic>
+        <p:nvPicPr>
+          <p:cNvPr id="23" name="Imagem" descr="validate"/>
+          <p:cNvPicPr>
+            <a:picLocks noChangeAspect="1"/>
+          </p:cNvPicPr>
+          <p:nvPr/>
+        </p:nvPicPr>
+        <p:blipFill>
+          <a:blip r:embed="rId3"/>
+          <a:stretch>
+            <a:fillRect/>
+          </a:stretch>
+        </p:blipFill>
+        <p:spPr>
+          <a:xfrm>
+            <a:off x="811987" y="3436315"/>
+            <a:ext cx="213970" cy="213970"/>
+          </a:xfrm>
+          <a:prstGeom prst="rect">
+            <a:avLst/>
+          </a:prstGeom>
+        </p:spPr>
+      </p:pic>
+      <p:sp>
+        <p:nvSpPr>
+          <p:cNvPr id="24" name="Texto"/>
+          <p:cNvSpPr txBox="1"/>
+          <p:nvPr/>
+        </p:nvSpPr>
+        <p:spPr>
+          <a:xfrm>
+            <a:off x="1261872" y="3227832"/>
+            <a:ext cx="1783080" cy="630936"/>
+          </a:xfrm>
+          <a:prstGeom prst="roundRect">
+            <a:avLst/>
+          </a:prstGeom>
+          <a:noFill/>
+          <a:ln>
+            <a:noFill/>
+          </a:ln>
+        </p:spPr>
+        <p:txBody>
+          <a:bodyPr wrap="square" lIns="0" tIns="0" rIns="0" bIns="0" rtlCol="0" anchor="ctr"/>
+          <a:lstStyle/>
+          <a:p>
+            <a:pPr algn="l" indent="0" marL="0">
+              <a:buNone/>
+            </a:pPr>
+            <a:r>
+              <a:rPr lang="pt-BR" sz="1100" b="1" dirty="0">
+                <a:solidFill>
+                  <a:srgbClr val="1D2D3E"/>
+                </a:solidFill>
+                <a:latin typeface="Courier New" pitchFamily="34" charset="0"/>
+                <a:ea typeface="Courier New" pitchFamily="34" charset="-122"/>
+                <a:cs typeface="Courier New" pitchFamily="34" charset="-120"/>
+              </a:rPr>
+              <a:t>npm run int-test</a:t>
+            </a:r>
+            <a:endParaRPr lang="pt-BR" sz="1100" dirty="0"/>
+          </a:p>
+        </p:txBody>
+      </p:sp>
+      <p:sp>
+        <p:nvSpPr>
+          <p:cNvPr id="25" name="Texto"/>
+          <p:cNvSpPr txBox="1"/>
+          <p:nvPr/>
+        </p:nvSpPr>
+        <p:spPr>
+          <a:xfrm>
+            <a:off x="3108960" y="3227832"/>
+            <a:ext cx="3840480" cy="630936"/>
+          </a:xfrm>
+          <a:prstGeom prst="roundRect">
+            <a:avLst/>
+          </a:prstGeom>
+          <a:noFill/>
+          <a:ln>
+            <a:noFill/>
+          </a:ln>
+        </p:spPr>
+        <p:txBody>
+          <a:bodyPr wrap="square" lIns="0" tIns="0" rIns="0" bIns="0" rtlCol="0" anchor="ctr"/>
+          <a:lstStyle/>
+          <a:p>
+            <a:pPr algn="l" indent="0" marL="0">
+              <a:buNone/>
+            </a:pPr>
+            <a:r>
+              <a:rPr lang="pt-BR" sz="1150" dirty="0">
+                <a:solidFill>
+                  <a:srgbClr val="1D2D3E"/>
+                </a:solidFill>
+              </a:rPr>
+              <a:t>List Report e Object Page abrem e navegam com o mock</a:t>
+            </a:r>
+            <a:endParaRPr lang="pt-BR" sz="1150" dirty="0"/>
+          </a:p>
+        </p:txBody>
+      </p:sp>
+      <p:cxnSp>
+        <p:nvCxnSpPr>
+          <p:cNvPr id="26" name="Conector"/>
+          <p:cNvCxnSpPr/>
+          <p:nvPr/>
+        </p:nvCxnSpPr>
+        <p:spPr>
+          <a:xfrm>
+            <a:off x="7178040" y="3364992"/>
+            <a:ext cx="0" cy="356616"/>
+          </a:xfrm>
+          <a:prstGeom prst="line">
+            <a:avLst/>
+          </a:prstGeom>
+          <a:noFill/>
+          <a:ln w="12700">
+            <a:solidFill>
+              <a:srgbClr val="E5E5E5"/>
+            </a:solidFill>
+            <a:prstDash val="solid"/>
+            <a:round/>
+          </a:ln>
+        </p:spPr>
+      </p:cxnSp>
+      <p:sp>
+        <p:nvSpPr>
+          <p:cNvPr id="27" name="Texto"/>
+          <p:cNvSpPr txBox="1"/>
+          <p:nvPr/>
+        </p:nvSpPr>
+        <p:spPr>
+          <a:xfrm>
+            <a:off x="7315200" y="3227832"/>
+            <a:ext cx="4206240" cy="630936"/>
+          </a:xfrm>
+          <a:prstGeom prst="roundRect">
+            <a:avLst/>
+          </a:prstGeom>
+          <a:noFill/>
+          <a:ln>
+            <a:noFill/>
+          </a:ln>
+        </p:spPr>
+        <p:txBody>
+          <a:bodyPr wrap="square" lIns="0" tIns="0" rIns="0" bIns="0" rtlCol="0" anchor="ctr"/>
+          <a:lstStyle/>
+          <a:p>
+            <a:pPr algn="l" indent="0" marL="0">
+              <a:buNone/>
+            </a:pPr>
+            <a:r>
+              <a:rPr lang="pt-BR" sz="1150" dirty="0">
+                <a:solidFill>
+                  <a:srgbClr val="556B82"/>
+                </a:solidFill>
+              </a:rPr>
+              <a:t>…como tela quebrada após mudar manifest ou anotações</a:t>
+            </a:r>
+            <a:endParaRPr lang="pt-BR" sz="1150" dirty="0"/>
+          </a:p>
+        </p:txBody>
+      </p:sp>
+      <p:sp>
+        <p:nvSpPr>
+          <p:cNvPr id="28" name="Cartão"/>
+          <p:cNvSpPr/>
+          <p:nvPr/>
+        </p:nvSpPr>
+        <p:spPr>
+          <a:xfrm>
+            <a:off x="548640" y="3950208"/>
+            <a:ext cx="11091672" cy="630936"/>
+          </a:xfrm>
+          <a:prstGeom prst="roundRect">
+            <a:avLst>
+              <a:gd name="adj" fmla="val 5217"/>
+            </a:avLst>
+          </a:prstGeom>
+          <a:solidFill>
+            <a:srgbClr val="FFFFFF"/>
+          </a:solidFill>
+          <a:ln>
+            <a:noFill/>
+          </a:ln>
+          <a:effectLst>
+            <a:outerShdw sx="100000" sy="100000" kx="0" ky="0" algn="bl" rotWithShape="0" blurRad="101600" dist="25400" dir="5400000">
+              <a:srgbClr val="223548">
+                <a:alpha val="16000"/>
+              </a:srgbClr>
+            </a:outerShdw>
+          </a:effectLst>
+        </p:spPr>
+      </p:sp>
+      <p:sp>
+        <p:nvSpPr>
+          <p:cNvPr id="29" name="Ícone e-learning"/>
+          <p:cNvSpPr/>
+          <p:nvPr/>
+        </p:nvSpPr>
+        <p:spPr>
+          <a:xfrm>
+            <a:off x="713232" y="4059936"/>
+            <a:ext cx="411480" cy="411480"/>
+          </a:xfrm>
+          <a:prstGeom prst="roundRect">
+            <a:avLst>
+              <a:gd name="adj" fmla="val 22000"/>
+            </a:avLst>
+          </a:prstGeom>
+          <a:solidFill>
+            <a:srgbClr val="F3ECFB"/>
+          </a:solidFill>
+          <a:ln>
+            <a:noFill/>
+          </a:ln>
+        </p:spPr>
+      </p:sp>
+      <p:pic>
+        <p:nvPicPr>
+          <p:cNvPr id="30" name="Imagem" descr="e-learning"/>
+          <p:cNvPicPr>
+            <a:picLocks noChangeAspect="1"/>
+          </p:cNvPicPr>
+          <p:nvPr/>
+        </p:nvPicPr>
+        <p:blipFill>
+          <a:blip r:embed="rId4"/>
+          <a:stretch>
+            <a:fillRect/>
+          </a:stretch>
+        </p:blipFill>
+        <p:spPr>
+          <a:xfrm>
+            <a:off x="811987" y="4158691"/>
+            <a:ext cx="213970" cy="213970"/>
+          </a:xfrm>
+          <a:prstGeom prst="rect">
+            <a:avLst/>
+          </a:prstGeom>
+        </p:spPr>
+      </p:pic>
+      <p:sp>
+        <p:nvSpPr>
+          <p:cNvPr id="31" name="Texto"/>
+          <p:cNvSpPr txBox="1"/>
+          <p:nvPr/>
+        </p:nvSpPr>
+        <p:spPr>
+          <a:xfrm>
+            <a:off x="1261872" y="3950208"/>
+            <a:ext cx="1783080" cy="630936"/>
+          </a:xfrm>
+          <a:prstGeom prst="roundRect">
+            <a:avLst/>
+          </a:prstGeom>
+          <a:noFill/>
+          <a:ln>
+            <a:noFill/>
+          </a:ln>
+        </p:spPr>
+        <p:txBody>
+          <a:bodyPr wrap="square" lIns="0" tIns="0" rIns="0" bIns="0" rtlCol="0" anchor="ctr"/>
+          <a:lstStyle/>
+          <a:p>
+            <a:pPr algn="l" indent="0" marL="0">
+              <a:buNone/>
+            </a:pPr>
+            <a:r>
+              <a:rPr lang="pt-BR" sz="1100" b="1" dirty="0">
+                <a:solidFill>
+                  <a:srgbClr val="1D2D3E"/>
+                </a:solidFill>
+                <a:latin typeface="Courier New" pitchFamily="34" charset="0"/>
+                <a:ea typeface="Courier New" pitchFamily="34" charset="-122"/>
+                <a:cs typeface="Courier New" pitchFamily="34" charset="-120"/>
+              </a:rPr>
+              <a:t>npm run unit-test</a:t>
+            </a:r>
+            <a:endParaRPr lang="pt-BR" sz="1100" dirty="0"/>
+          </a:p>
+        </p:txBody>
+      </p:sp>
+      <p:sp>
+        <p:nvSpPr>
+          <p:cNvPr id="32" name="Texto"/>
+          <p:cNvSpPr txBox="1"/>
+          <p:nvPr/>
+        </p:nvSpPr>
+        <p:spPr>
+          <a:xfrm>
+            <a:off x="3108960" y="3950208"/>
+            <a:ext cx="3840480" cy="630936"/>
+          </a:xfrm>
+          <a:prstGeom prst="roundRect">
+            <a:avLst/>
+          </a:prstGeom>
+          <a:noFill/>
+          <a:ln>
+            <a:noFill/>
+          </a:ln>
+        </p:spPr>
+        <p:txBody>
+          <a:bodyPr wrap="square" lIns="0" tIns="0" rIns="0" bIns="0" rtlCol="0" anchor="ctr"/>
+          <a:lstStyle/>
+          <a:p>
+            <a:pPr algn="l" indent="0" marL="0">
+              <a:buNone/>
+            </a:pPr>
+            <a:r>
+              <a:rPr lang="pt-BR" sz="1150" dirty="0">
+                <a:solidFill>
+                  <a:srgbClr val="1D2D3E"/>
+                </a:solidFill>
+              </a:rPr>
+              <a:t>Catálogo de cenários, textos i18n e o $apply das consultas</a:t>
+            </a:r>
+            <a:endParaRPr lang="pt-BR" sz="1150" dirty="0"/>
+          </a:p>
+        </p:txBody>
+      </p:sp>
+      <p:cxnSp>
+        <p:nvCxnSpPr>
+          <p:cNvPr id="33" name="Conector"/>
+          <p:cNvCxnSpPr/>
+          <p:nvPr/>
+        </p:nvCxnSpPr>
+        <p:spPr>
+          <a:xfrm>
+            <a:off x="7178040" y="4087368"/>
+            <a:ext cx="0" cy="356616"/>
+          </a:xfrm>
+          <a:prstGeom prst="line">
+            <a:avLst/>
+          </a:prstGeom>
+          <a:noFill/>
+          <a:ln w="12700">
+            <a:solidFill>
+              <a:srgbClr val="E5E5E5"/>
+            </a:solidFill>
+            <a:prstDash val="solid"/>
+            <a:round/>
+          </a:ln>
+        </p:spPr>
+      </p:cxnSp>
+      <p:sp>
+        <p:nvSpPr>
+          <p:cNvPr id="34" name="Texto"/>
+          <p:cNvSpPr txBox="1"/>
+          <p:nvPr/>
+        </p:nvSpPr>
+        <p:spPr>
+          <a:xfrm>
+            <a:off x="7315200" y="3950208"/>
+            <a:ext cx="4206240" cy="630936"/>
+          </a:xfrm>
+          <a:prstGeom prst="roundRect">
+            <a:avLst/>
+          </a:prstGeom>
+          <a:noFill/>
+          <a:ln>
+            <a:noFill/>
+          </a:ln>
+        </p:spPr>
+        <p:txBody>
+          <a:bodyPr wrap="square" lIns="0" tIns="0" rIns="0" bIns="0" rtlCol="0" anchor="ctr"/>
+          <a:lstStyle/>
+          <a:p>
+            <a:pPr algn="l" indent="0" marL="0">
+              <a:buNone/>
+            </a:pPr>
+            <a:r>
+              <a:rPr lang="pt-BR" sz="1150" dirty="0">
+                <a:solidFill>
+                  <a:srgbClr val="556B82"/>
+                </a:solidFill>
+              </a:rPr>
+              <a:t>…como gráfico vazio ou erro de groupby na análise</a:t>
+            </a:r>
+            <a:endParaRPr lang="pt-BR" sz="1150" dirty="0"/>
+          </a:p>
+        </p:txBody>
+      </p:sp>
+      <p:sp>
+        <p:nvSpPr>
+          <p:cNvPr id="35" name="Cartão"/>
+          <p:cNvSpPr/>
+          <p:nvPr/>
+        </p:nvSpPr>
+        <p:spPr>
+          <a:xfrm>
+            <a:off x="548640" y="4672584"/>
+            <a:ext cx="11091672" cy="630936"/>
+          </a:xfrm>
+          <a:prstGeom prst="roundRect">
+            <a:avLst>
+              <a:gd name="adj" fmla="val 5217"/>
+            </a:avLst>
+          </a:prstGeom>
+          <a:solidFill>
+            <a:srgbClr val="FFFFFF"/>
+          </a:solidFill>
+          <a:ln>
+            <a:noFill/>
+          </a:ln>
+          <a:effectLst>
+            <a:outerShdw sx="100000" sy="100000" kx="0" ky="0" algn="bl" rotWithShape="0" blurRad="101600" dist="25400" dir="5400000">
+              <a:srgbClr val="223548">
+                <a:alpha val="16000"/>
+              </a:srgbClr>
+            </a:outerShdw>
+          </a:effectLst>
+        </p:spPr>
+      </p:sp>
+      <p:sp>
+        <p:nvSpPr>
+          <p:cNvPr id="36" name="Ícone syntax"/>
+          <p:cNvSpPr/>
+          <p:nvPr/>
+        </p:nvSpPr>
+        <p:spPr>
+          <a:xfrm>
+            <a:off x="713232" y="4782312"/>
+            <a:ext cx="411480" cy="411480"/>
+          </a:xfrm>
+          <a:prstGeom prst="roundRect">
+            <a:avLst>
+              <a:gd name="adj" fmla="val 22000"/>
+            </a:avLst>
+          </a:prstGeom>
+          <a:solidFill>
+            <a:srgbClr val="FFF3E0"/>
+          </a:solidFill>
+          <a:ln>
+            <a:noFill/>
+          </a:ln>
+        </p:spPr>
+      </p:sp>
+      <p:pic>
+        <p:nvPicPr>
+          <p:cNvPr id="37" name="Imagem" descr="syntax"/>
+          <p:cNvPicPr>
+            <a:picLocks noChangeAspect="1"/>
+          </p:cNvPicPr>
+          <p:nvPr/>
+        </p:nvPicPr>
+        <p:blipFill>
+          <a:blip r:embed="rId5"/>
+          <a:stretch>
+            <a:fillRect/>
+          </a:stretch>
+        </p:blipFill>
+        <p:spPr>
+          <a:xfrm>
+            <a:off x="811987" y="4881067"/>
+            <a:ext cx="213970" cy="213970"/>
+          </a:xfrm>
+          <a:prstGeom prst="rect">
+            <a:avLst/>
+          </a:prstGeom>
+        </p:spPr>
+      </p:pic>
+      <p:sp>
+        <p:nvSpPr>
+          <p:cNvPr id="38" name="Texto"/>
+          <p:cNvSpPr txBox="1"/>
+          <p:nvPr/>
+        </p:nvSpPr>
+        <p:spPr>
+          <a:xfrm>
+            <a:off x="1261872" y="4672584"/>
+            <a:ext cx="1783080" cy="630936"/>
+          </a:xfrm>
+          <a:prstGeom prst="roundRect">
+            <a:avLst/>
+          </a:prstGeom>
+          <a:noFill/>
+          <a:ln>
+            <a:noFill/>
+          </a:ln>
+        </p:spPr>
+        <p:txBody>
+          <a:bodyPr wrap="square" lIns="0" tIns="0" rIns="0" bIns="0" rtlCol="0" anchor="ctr"/>
+          <a:lstStyle/>
+          <a:p>
+            <a:pPr algn="l" indent="0" marL="0">
+              <a:buNone/>
+            </a:pPr>
+            <a:r>
+              <a:rPr lang="pt-BR" sz="1100" b="1" dirty="0">
+                <a:solidFill>
+                  <a:srgbClr val="1D2D3E"/>
+                </a:solidFill>
+                <a:latin typeface="Courier New" pitchFamily="34" charset="0"/>
+                <a:ea typeface="Courier New" pitchFamily="34" charset="-122"/>
+                <a:cs typeface="Courier New" pitchFamily="34" charset="-120"/>
+              </a:rPr>
+              <a:t>npx @ui5/linter</a:t>
+            </a:r>
+            <a:endParaRPr lang="pt-BR" sz="1100" dirty="0"/>
+          </a:p>
+        </p:txBody>
+      </p:sp>
+      <p:sp>
+        <p:nvSpPr>
+          <p:cNvPr id="39" name="Texto"/>
+          <p:cNvSpPr txBox="1"/>
+          <p:nvPr/>
+        </p:nvSpPr>
+        <p:spPr>
+          <a:xfrm>
+            <a:off x="3108960" y="4672584"/>
+            <a:ext cx="3840480" cy="630936"/>
+          </a:xfrm>
+          <a:prstGeom prst="roundRect">
+            <a:avLst/>
+          </a:prstGeom>
+          <a:noFill/>
+          <a:ln>
+            <a:noFill/>
+          </a:ln>
+        </p:spPr>
+        <p:txBody>
+          <a:bodyPr wrap="square" lIns="0" tIns="0" rIns="0" bIns="0" rtlCol="0" anchor="ctr"/>
+          <a:lstStyle/>
+          <a:p>
+            <a:pPr algn="l" indent="0" marL="0">
+              <a:buNone/>
+            </a:pPr>
+            <a:r>
+              <a:rPr lang="pt-BR" sz="1150" dirty="0">
+                <a:solidFill>
+                  <a:srgbClr val="1D2D3E"/>
+                </a:solidFill>
+              </a:rPr>
+              <a:t>APIs depreciadas e práticas fora do padrão SAPUI5</a:t>
+            </a:r>
+            <a:endParaRPr lang="pt-BR" sz="1150" dirty="0"/>
+          </a:p>
+        </p:txBody>
+      </p:sp>
+      <p:cxnSp>
+        <p:nvCxnSpPr>
+          <p:cNvPr id="40" name="Conector"/>
+          <p:cNvCxnSpPr/>
+          <p:nvPr/>
+        </p:nvCxnSpPr>
+        <p:spPr>
+          <a:xfrm>
+            <a:off x="7178040" y="4809744"/>
+            <a:ext cx="0" cy="356616"/>
+          </a:xfrm>
+          <a:prstGeom prst="line">
+            <a:avLst/>
+          </a:prstGeom>
+          <a:noFill/>
+          <a:ln w="12700">
+            <a:solidFill>
+              <a:srgbClr val="E5E5E5"/>
+            </a:solidFill>
+            <a:prstDash val="solid"/>
+            <a:round/>
+          </a:ln>
+        </p:spPr>
+      </p:cxnSp>
+      <p:sp>
+        <p:nvSpPr>
+          <p:cNvPr id="41" name="Texto"/>
+          <p:cNvSpPr txBox="1"/>
+          <p:nvPr/>
+        </p:nvSpPr>
+        <p:spPr>
+          <a:xfrm>
+            <a:off x="7315200" y="4672584"/>
+            <a:ext cx="4206240" cy="630936"/>
+          </a:xfrm>
+          <a:prstGeom prst="roundRect">
+            <a:avLst/>
+          </a:prstGeom>
+          <a:noFill/>
+          <a:ln>
+            <a:noFill/>
+          </a:ln>
+        </p:spPr>
+        <p:txBody>
+          <a:bodyPr wrap="square" lIns="0" tIns="0" rIns="0" bIns="0" rtlCol="0" anchor="ctr"/>
+          <a:lstStyle/>
+          <a:p>
+            <a:pPr algn="l" indent="0" marL="0">
+              <a:buNone/>
+            </a:pPr>
+            <a:r>
+              <a:rPr lang="pt-BR" sz="1150" dirty="0">
+                <a:solidFill>
+                  <a:srgbClr val="556B82"/>
+                </a:solidFill>
+              </a:rPr>
+              <a:t>…no próximo upgrade do SAPUI5 do BTP ou do FES</a:t>
+            </a:r>
+            <a:endParaRPr lang="pt-BR" sz="1150" dirty="0"/>
+          </a:p>
+        </p:txBody>
+      </p:sp>
+      <p:sp>
+        <p:nvSpPr>
+          <p:cNvPr id="42" name="Cartão"/>
+          <p:cNvSpPr/>
+          <p:nvPr/>
+        </p:nvSpPr>
+        <p:spPr>
+          <a:xfrm>
+            <a:off x="548640" y="5394960"/>
+            <a:ext cx="11091672" cy="630936"/>
+          </a:xfrm>
+          <a:prstGeom prst="roundRect">
+            <a:avLst>
+              <a:gd name="adj" fmla="val 5217"/>
+            </a:avLst>
+          </a:prstGeom>
+          <a:solidFill>
+            <a:srgbClr val="FFFFFF"/>
+          </a:solidFill>
+          <a:ln>
+            <a:noFill/>
+          </a:ln>
+          <a:effectLst>
+            <a:outerShdw sx="100000" sy="100000" kx="0" ky="0" algn="bl" rotWithShape="0" blurRad="101600" dist="25400" dir="5400000">
+              <a:srgbClr val="223548">
+                <a:alpha val="16000"/>
+              </a:srgbClr>
+            </a:outerShdw>
+          </a:effectLst>
+        </p:spPr>
+      </p:sp>
+      <p:sp>
+        <p:nvSpPr>
+          <p:cNvPr id="43" name="Ícone upload-to-cloud"/>
+          <p:cNvSpPr/>
+          <p:nvPr/>
+        </p:nvSpPr>
+        <p:spPr>
+          <a:xfrm>
+            <a:off x="713232" y="5504688"/>
+            <a:ext cx="411480" cy="411480"/>
+          </a:xfrm>
+          <a:prstGeom prst="roundRect">
+            <a:avLst>
+              <a:gd name="adj" fmla="val 22000"/>
+            </a:avLst>
+          </a:prstGeom>
+          <a:solidFill>
+            <a:srgbClr val="FDE8F1"/>
+          </a:solidFill>
+          <a:ln>
+            <a:noFill/>
+          </a:ln>
+        </p:spPr>
+      </p:sp>
+      <p:pic>
+        <p:nvPicPr>
+          <p:cNvPr id="44" name="Imagem" descr="upload-to-cloud"/>
+          <p:cNvPicPr>
+            <a:picLocks noChangeAspect="1"/>
+          </p:cNvPicPr>
+          <p:nvPr/>
+        </p:nvPicPr>
+        <p:blipFill>
+          <a:blip r:embed="rId6"/>
+          <a:stretch>
+            <a:fillRect/>
+          </a:stretch>
+        </p:blipFill>
+        <p:spPr>
+          <a:xfrm>
+            <a:off x="811987" y="5603443"/>
+            <a:ext cx="213970" cy="213970"/>
+          </a:xfrm>
+          <a:prstGeom prst="rect">
+            <a:avLst/>
+          </a:prstGeom>
+        </p:spPr>
+      </p:pic>
+      <p:sp>
+        <p:nvSpPr>
+          <p:cNvPr id="45" name="Texto"/>
+          <p:cNvSpPr txBox="1"/>
+          <p:nvPr/>
+        </p:nvSpPr>
+        <p:spPr>
+          <a:xfrm>
+            <a:off x="1261872" y="5394960"/>
+            <a:ext cx="1783080" cy="630936"/>
+          </a:xfrm>
+          <a:prstGeom prst="roundRect">
+            <a:avLst/>
+          </a:prstGeom>
+          <a:noFill/>
+          <a:ln>
+            <a:noFill/>
+          </a:ln>
+        </p:spPr>
+        <p:txBody>
+          <a:bodyPr wrap="square" lIns="0" tIns="0" rIns="0" bIns="0" rtlCol="0" anchor="ctr"/>
+          <a:lstStyle/>
+          <a:p>
+            <a:pPr algn="l" indent="0" marL="0">
+              <a:buNone/>
+            </a:pPr>
+            <a:r>
+              <a:rPr lang="pt-BR" sz="1100" b="1" dirty="0">
+                <a:solidFill>
+                  <a:srgbClr val="1D2D3E"/>
+                </a:solidFill>
+                <a:latin typeface="Courier New" pitchFamily="34" charset="0"/>
+                <a:ea typeface="Courier New" pitchFamily="34" charset="-122"/>
+                <a:cs typeface="Courier New" pitchFamily="34" charset="-120"/>
+              </a:rPr>
+              <a:t>npm run deploy-test</a:t>
+            </a:r>
+            <a:endParaRPr lang="pt-BR" sz="1100" dirty="0"/>
+          </a:p>
+        </p:txBody>
+      </p:sp>
+      <p:sp>
+        <p:nvSpPr>
+          <p:cNvPr id="46" name="Texto"/>
+          <p:cNvSpPr txBox="1"/>
+          <p:nvPr/>
+        </p:nvSpPr>
+        <p:spPr>
+          <a:xfrm>
+            <a:off x="3108960" y="5394960"/>
+            <a:ext cx="3840480" cy="630936"/>
+          </a:xfrm>
+          <a:prstGeom prst="roundRect">
+            <a:avLst/>
+          </a:prstGeom>
+          <a:noFill/>
+          <a:ln>
+            <a:noFill/>
+          </a:ln>
+        </p:spPr>
+        <p:txBody>
+          <a:bodyPr wrap="square" lIns="0" tIns="0" rIns="0" bIns="0" rtlCol="0" anchor="ctr"/>
+          <a:lstStyle/>
+          <a:p>
+            <a:pPr algn="l" indent="0" marL="0">
+              <a:buNone/>
+            </a:pPr>
+            <a:r>
+              <a:rPr lang="pt-BR" sz="1150" dirty="0">
+                <a:solidFill>
+                  <a:srgbClr val="1D2D3E"/>
+                </a:solidFill>
+              </a:rPr>
+              <a:t>URL, cliente, login, pacote e transporte, sem gravar</a:t>
+            </a:r>
+            <a:endParaRPr lang="pt-BR" sz="1150" dirty="0"/>
+          </a:p>
+        </p:txBody>
+      </p:sp>
+      <p:cxnSp>
+        <p:nvCxnSpPr>
+          <p:cNvPr id="47" name="Conector"/>
+          <p:cNvCxnSpPr/>
+          <p:nvPr/>
+        </p:nvCxnSpPr>
+        <p:spPr>
+          <a:xfrm>
+            <a:off x="7178040" y="5532120"/>
+            <a:ext cx="0" cy="356616"/>
+          </a:xfrm>
+          <a:prstGeom prst="line">
+            <a:avLst/>
+          </a:prstGeom>
+          <a:noFill/>
+          <a:ln w="12700">
+            <a:solidFill>
+              <a:srgbClr val="E5E5E5"/>
+            </a:solidFill>
+            <a:prstDash val="solid"/>
+            <a:round/>
+          </a:ln>
+        </p:spPr>
+      </p:cxnSp>
+      <p:sp>
+        <p:nvSpPr>
+          <p:cNvPr id="48" name="Texto"/>
+          <p:cNvSpPr txBox="1"/>
+          <p:nvPr/>
+        </p:nvSpPr>
+        <p:spPr>
+          <a:xfrm>
+            <a:off x="7315200" y="5394960"/>
+            <a:ext cx="4206240" cy="630936"/>
+          </a:xfrm>
+          <a:prstGeom prst="roundRect">
+            <a:avLst/>
+          </a:prstGeom>
+          <a:noFill/>
+          <a:ln>
+            <a:noFill/>
+          </a:ln>
+        </p:spPr>
+        <p:txBody>
+          <a:bodyPr wrap="square" lIns="0" tIns="0" rIns="0" bIns="0" rtlCol="0" anchor="ctr"/>
+          <a:lstStyle/>
+          <a:p>
+            <a:pPr algn="l" indent="0" marL="0">
+              <a:buNone/>
+            </a:pPr>
+            <a:r>
+              <a:rPr lang="pt-BR" sz="1150" dirty="0">
+                <a:solidFill>
+                  <a:srgbClr val="556B82"/>
+                </a:solidFill>
+              </a:rPr>
+              <a:t>…já gravando no ABAP Repository do sistema</a:t>
+            </a:r>
+            <a:endParaRPr lang="pt-BR" sz="1150" dirty="0"/>
+          </a:p>
+        </p:txBody>
+      </p:sp>
+      <p:sp>
+        <p:nvSpPr>
+          <p:cNvPr id="49" name="Slide Number Placeholder 0"/>
+          <p:cNvSpPr>
+            <a:spLocks noGrp="1"/>
+          </p:cNvSpPr>
+          <p:nvPr>
+            <p:ph type="sldNum" sz="quarter" idx="4294967295"/>
+          </p:nvPr>
+        </p:nvSpPr>
+        <p:spPr>
+          <a:xfrm>
+            <a:off x="11183112" y="6419088"/>
+            <a:ext cx="457200" cy="274320"/>
+          </a:xfrm>
+          <a:prstGeom prst="rect">
+            <a:avLst/>
+          </a:prstGeom>
+        </p:spPr>
+        <p:txBody>
+          <a:bodyPr lIns="0" tIns="0" rIns="0" bIns="0" anchor="ctr"/>
+          <a:lstStyle>
+            <a:lvl1pPr>
+              <a:defRPr sz="900">
+                <a:solidFill>
+                  <a:srgbClr val="556B82"/>
+                </a:solidFill>
+              </a:defRPr>
+            </a:lvl1pPr>
+          </a:lstStyle>
+          <a:p>
+            <a:pPr algn="r"/>
+            <a:fld id="{F7021451-1387-4CA6-816F-3879F97B5CBC}" type="slidenum">
+              <a:rPr b="0" lang="en-US"/>
+              <a:t>1</a:t>
+            </a:fld>
+            <a:endParaRPr lang="en-US"/>
+          </a:p>
+        </p:txBody>
+      </p:sp>
+    </p:spTree>
+  </p:cSld>
+  <p:clrMapOvr>
+    <a:masterClrMapping/>
+  </p:clrMapOvr>
+</p:sld>
+</file>
+
+<file path=ppt/slides/slide34.xml><?xml version="1.0" encoding="utf-8"?>
+<p:sld xmlns:a="http://schemas.openxmlformats.org/drawingml/2006/main" xmlns:r="http://schemas.openxmlformats.org/officeDocument/2006/relationships" xmlns:p="http://schemas.openxmlformats.org/presentationml/2006/main">
+  <p:cSld>
+    <p:spTree>
+      <p:nvGrpSpPr>
+        <p:cNvPr id="1" name=""/>
+        <p:cNvGrpSpPr/>
+        <p:nvPr/>
+      </p:nvGrpSpPr>
+      <p:grpSpPr>
+        <a:xfrm>
+          <a:off x="0" y="0"/>
+          <a:ext cx="0" cy="0"/>
+          <a:chOff x="0" y="0"/>
+          <a:chExt cx="0" cy="0"/>
+        </a:xfrm>
+      </p:grpSpPr>
+      <p:sp>
+        <p:nvSpPr>
+          <p:cNvPr id="3" name="Rótulo"/>
+          <p:cNvSpPr/>
+          <p:nvPr>
+            <p:ph idx="100" type="body" hasCustomPrompt="1"/>
+          </p:nvPr>
+        </p:nvSpPr>
+        <p:spPr>
+          <a:xfrm>
+            <a:off x="548640" y="384048"/>
+            <a:ext cx="9144000" cy="274320"/>
+          </a:xfrm>
+          <a:prstGeom prst="rect">
+            <a:avLst/>
+          </a:prstGeom>
+          <a:noFill/>
+          <a:ln/>
+        </p:spPr>
+        <p:txBody>
+          <a:bodyPr wrap="square" lIns="0" tIns="0" rIns="0" bIns="0" rtlCol="0" anchor="ctr"/>
+          <a:lstStyle/>
+          <a:p>
+            <a:pPr algn="l" indent="0" marL="0">
+              <a:buNone/>
+            </a:pPr>
+            <a:r>
+              <a:rPr lang="pt-BR" sz="1100" b="1" spc="150" kern="0" dirty="0">
+                <a:solidFill>
+                  <a:schemeClr val="accent1"/>
+                </a:solidFill>
+              </a:rPr>
+              <a:t>ANTES DO DEPLOY · RESPONSABILIDADE</a:t>
+            </a:r>
+            <a:endParaRPr lang="pt-BR" sz="1100" dirty="0"/>
+          </a:p>
+        </p:txBody>
+      </p:sp>
+      <p:sp>
+        <p:nvSpPr>
+          <p:cNvPr id="4" name="Título"/>
+          <p:cNvSpPr/>
+          <p:nvPr>
+            <p:ph idx="101" type="title" hasCustomPrompt="1"/>
+          </p:nvPr>
+        </p:nvSpPr>
+        <p:spPr>
+          <a:xfrm>
+            <a:off x="548640" y="676656"/>
+            <a:ext cx="11094415" cy="658368"/>
+          </a:xfrm>
+          <a:prstGeom prst="rect">
+            <a:avLst/>
+          </a:prstGeom>
+          <a:noFill/>
+          <a:ln/>
+        </p:spPr>
+        <p:txBody>
+          <a:bodyPr wrap="square" lIns="0" tIns="0" rIns="0" bIns="0" rtlCol="0" anchor="ctr"/>
+          <a:lstStyle/>
+          <a:p>
+            <a:pPr algn="l" indent="0" marL="0">
+              <a:buNone/>
+            </a:pPr>
+            <a:r>
+              <a:rPr lang="pt-BR" sz="3000" b="1" dirty="0">
+                <a:solidFill>
+                  <a:schemeClr val="tx1"/>
+                </a:solidFill>
+              </a:rPr>
+              <a:t>Quem roda o deploy responde pelo que publica</a:t>
+            </a:r>
+            <a:endParaRPr lang="pt-BR" sz="3000" dirty="0"/>
+          </a:p>
+        </p:txBody>
+      </p:sp>
+      <p:sp>
+        <p:nvSpPr>
+          <p:cNvPr id="5" name="Etapa lint"/>
+          <p:cNvSpPr/>
+          <p:nvPr/>
+        </p:nvSpPr>
+        <p:spPr>
+          <a:xfrm>
+            <a:off x="548640" y="1645920"/>
+            <a:ext cx="1658112" cy="868680"/>
+          </a:xfrm>
+          <a:prstGeom prst="roundRect">
+            <a:avLst>
+              <a:gd name="adj" fmla="val 5217"/>
+            </a:avLst>
+          </a:prstGeom>
+          <a:solidFill>
+            <a:srgbClr val="FFFFFF"/>
+          </a:solidFill>
+          <a:ln>
+            <a:noFill/>
+          </a:ln>
+          <a:effectLst>
+            <a:outerShdw sx="100000" sy="100000" kx="0" ky="0" algn="bl" rotWithShape="0" blurRad="101600" dist="25400" dir="5400000">
+              <a:srgbClr val="223548">
+                <a:alpha val="16000"/>
+              </a:srgbClr>
+            </a:outerShdw>
+          </a:effectLst>
+        </p:spPr>
+      </p:sp>
+      <p:sp>
+        <p:nvSpPr>
+          <p:cNvPr id="6" name="Ícone inspection"/>
+          <p:cNvSpPr/>
+          <p:nvPr/>
+        </p:nvSpPr>
+        <p:spPr>
+          <a:xfrm>
+            <a:off x="685800" y="1865376"/>
+            <a:ext cx="438912" cy="438912"/>
+          </a:xfrm>
+          <a:prstGeom prst="roundRect">
+            <a:avLst>
+              <a:gd name="adj" fmla="val 22000"/>
+            </a:avLst>
+          </a:prstGeom>
+          <a:solidFill>
+            <a:srgbClr val="E1F4FF"/>
+          </a:solidFill>
+          <a:ln>
+            <a:noFill/>
+          </a:ln>
+        </p:spPr>
+      </p:sp>
+      <p:pic>
+        <p:nvPicPr>
+          <p:cNvPr id="7" name="Imagem" descr="inspection"/>
+          <p:cNvPicPr>
+            <a:picLocks noChangeAspect="1"/>
+          </p:cNvPicPr>
+          <p:nvPr/>
+        </p:nvPicPr>
+        <p:blipFill>
+          <a:blip r:embed="rId1"/>
+          <a:stretch>
+            <a:fillRect/>
+          </a:stretch>
+        </p:blipFill>
+        <p:spPr>
+          <a:xfrm>
+            <a:off x="791139" y="1970715"/>
+            <a:ext cx="228234" cy="228234"/>
+          </a:xfrm>
+          <a:prstGeom prst="rect">
+            <a:avLst/>
+          </a:prstGeom>
+        </p:spPr>
+      </p:pic>
+      <p:sp>
+        <p:nvSpPr>
+          <p:cNvPr id="8" name="Texto"/>
+          <p:cNvSpPr txBox="1"/>
+          <p:nvPr/>
+        </p:nvSpPr>
+        <p:spPr>
+          <a:xfrm>
+            <a:off x="1234440" y="1645920"/>
+            <a:ext cx="880872" cy="868680"/>
+          </a:xfrm>
+          <a:prstGeom prst="roundRect">
+            <a:avLst/>
+          </a:prstGeom>
+          <a:noFill/>
+          <a:ln>
+            <a:noFill/>
+          </a:ln>
+        </p:spPr>
+        <p:txBody>
+          <a:bodyPr wrap="square" lIns="0" tIns="0" rIns="0" bIns="0" rtlCol="0" anchor="ctr"/>
+          <a:lstStyle/>
+          <a:p>
+            <a:pPr algn="l" indent="0" marL="0">
+              <a:buNone/>
+            </a:pPr>
+            <a:r>
+              <a:rPr lang="pt-BR" sz="1250" b="1" dirty="0">
+                <a:solidFill>
+                  <a:srgbClr val="1D2D3E"/>
+                </a:solidFill>
+              </a:rPr>
+              <a:t>1. lint</a:t>
+            </a:r>
+            <a:endParaRPr lang="pt-BR" sz="1250" dirty="0"/>
+          </a:p>
+        </p:txBody>
+      </p:sp>
+      <p:cxnSp>
+        <p:nvCxnSpPr>
+          <p:cNvPr id="9" name="Conector"/>
+          <p:cNvCxnSpPr/>
+          <p:nvPr/>
+        </p:nvCxnSpPr>
+        <p:spPr>
+          <a:xfrm>
+            <a:off x="2234184" y="2080260"/>
+            <a:ext cx="173736" cy="0"/>
+          </a:xfrm>
+          <a:prstGeom prst="line">
+            <a:avLst/>
+          </a:prstGeom>
+          <a:noFill/>
+          <a:ln w="19050">
+            <a:solidFill>
+              <a:srgbClr val="556B82"/>
+            </a:solidFill>
+            <a:prstDash val="solid"/>
+            <a:round/>
+            <a:tailEnd type="triangle"/>
+          </a:ln>
+        </p:spPr>
+      </p:cxnSp>
+      <p:sp>
+        <p:nvSpPr>
+          <p:cNvPr id="10" name="Etapa testes"/>
+          <p:cNvSpPr/>
+          <p:nvPr/>
+        </p:nvSpPr>
+        <p:spPr>
+          <a:xfrm>
+            <a:off x="2435352" y="1645920"/>
+            <a:ext cx="1658112" cy="868680"/>
+          </a:xfrm>
+          <a:prstGeom prst="roundRect">
+            <a:avLst>
+              <a:gd name="adj" fmla="val 5217"/>
+            </a:avLst>
+          </a:prstGeom>
+          <a:solidFill>
+            <a:srgbClr val="FFFFFF"/>
+          </a:solidFill>
+          <a:ln>
+            <a:noFill/>
+          </a:ln>
+          <a:effectLst>
+            <a:outerShdw sx="100000" sy="100000" kx="0" ky="0" algn="bl" rotWithShape="0" blurRad="101600" dist="25400" dir="5400000">
+              <a:srgbClr val="223548">
+                <a:alpha val="16000"/>
+              </a:srgbClr>
+            </a:outerShdw>
+          </a:effectLst>
+        </p:spPr>
+      </p:sp>
+      <p:sp>
+        <p:nvSpPr>
+          <p:cNvPr id="11" name="Ícone validate"/>
+          <p:cNvSpPr/>
+          <p:nvPr/>
+        </p:nvSpPr>
+        <p:spPr>
+          <a:xfrm>
+            <a:off x="2572512" y="1865376"/>
+            <a:ext cx="438912" cy="438912"/>
+          </a:xfrm>
+          <a:prstGeom prst="roundRect">
+            <a:avLst>
+              <a:gd name="adj" fmla="val 22000"/>
+            </a:avLst>
+          </a:prstGeom>
+          <a:solidFill>
+            <a:srgbClr val="F5FAE5"/>
+          </a:solidFill>
+          <a:ln>
+            <a:noFill/>
+          </a:ln>
+        </p:spPr>
+      </p:sp>
+      <p:pic>
+        <p:nvPicPr>
+          <p:cNvPr id="12" name="Imagem" descr="validate"/>
+          <p:cNvPicPr>
+            <a:picLocks noChangeAspect="1"/>
+          </p:cNvPicPr>
+          <p:nvPr/>
+        </p:nvPicPr>
+        <p:blipFill>
+          <a:blip r:embed="rId2"/>
+          <a:stretch>
+            <a:fillRect/>
+          </a:stretch>
+        </p:blipFill>
+        <p:spPr>
+          <a:xfrm>
+            <a:off x="2677851" y="1970715"/>
+            <a:ext cx="228234" cy="228234"/>
+          </a:xfrm>
+          <a:prstGeom prst="rect">
+            <a:avLst/>
+          </a:prstGeom>
+        </p:spPr>
+      </p:pic>
+      <p:sp>
+        <p:nvSpPr>
+          <p:cNvPr id="13" name="Texto"/>
+          <p:cNvSpPr txBox="1"/>
+          <p:nvPr/>
+        </p:nvSpPr>
+        <p:spPr>
+          <a:xfrm>
+            <a:off x="3121152" y="1645920"/>
+            <a:ext cx="880872" cy="868680"/>
+          </a:xfrm>
+          <a:prstGeom prst="roundRect">
+            <a:avLst/>
+          </a:prstGeom>
+          <a:noFill/>
+          <a:ln>
+            <a:noFill/>
+          </a:ln>
+        </p:spPr>
+        <p:txBody>
+          <a:bodyPr wrap="square" lIns="0" tIns="0" rIns="0" bIns="0" rtlCol="0" anchor="ctr"/>
+          <a:lstStyle/>
+          <a:p>
+            <a:pPr algn="l" indent="0" marL="0">
+              <a:buNone/>
+            </a:pPr>
+            <a:r>
+              <a:rPr lang="pt-BR" sz="1250" b="1" dirty="0">
+                <a:solidFill>
+                  <a:srgbClr val="1D2D3E"/>
+                </a:solidFill>
+              </a:rPr>
+              <a:t>2. testes</a:t>
+            </a:r>
+            <a:endParaRPr lang="pt-BR" sz="1250" dirty="0"/>
+          </a:p>
+        </p:txBody>
+      </p:sp>
+      <p:cxnSp>
+        <p:nvCxnSpPr>
+          <p:cNvPr id="14" name="Conector"/>
+          <p:cNvCxnSpPr/>
+          <p:nvPr/>
+        </p:nvCxnSpPr>
+        <p:spPr>
+          <a:xfrm>
+            <a:off x="4120896" y="2080260"/>
+            <a:ext cx="173736" cy="0"/>
+          </a:xfrm>
+          <a:prstGeom prst="line">
+            <a:avLst/>
+          </a:prstGeom>
+          <a:noFill/>
+          <a:ln w="19050">
+            <a:solidFill>
+              <a:srgbClr val="556B82"/>
+            </a:solidFill>
+            <a:prstDash val="solid"/>
+            <a:round/>
+            <a:tailEnd type="triangle"/>
+          </a:ln>
+        </p:spPr>
+      </p:cxnSp>
+      <p:sp>
+        <p:nvSpPr>
+          <p:cNvPr id="15" name="Etapa UI5 linter"/>
+          <p:cNvSpPr/>
+          <p:nvPr/>
+        </p:nvSpPr>
+        <p:spPr>
+          <a:xfrm>
+            <a:off x="4322064" y="1645920"/>
+            <a:ext cx="1658112" cy="868680"/>
+          </a:xfrm>
+          <a:prstGeom prst="roundRect">
+            <a:avLst>
+              <a:gd name="adj" fmla="val 5217"/>
+            </a:avLst>
+          </a:prstGeom>
+          <a:solidFill>
+            <a:srgbClr val="FFFFFF"/>
+          </a:solidFill>
+          <a:ln>
+            <a:noFill/>
+          </a:ln>
+          <a:effectLst>
+            <a:outerShdw sx="100000" sy="100000" kx="0" ky="0" algn="bl" rotWithShape="0" blurRad="101600" dist="25400" dir="5400000">
+              <a:srgbClr val="223548">
+                <a:alpha val="16000"/>
+              </a:srgbClr>
+            </a:outerShdw>
+          </a:effectLst>
+        </p:spPr>
+      </p:sp>
+      <p:sp>
+        <p:nvSpPr>
+          <p:cNvPr id="16" name="Ícone syntax"/>
+          <p:cNvSpPr/>
+          <p:nvPr/>
+        </p:nvSpPr>
+        <p:spPr>
+          <a:xfrm>
+            <a:off x="4459224" y="1865376"/>
+            <a:ext cx="438912" cy="438912"/>
+          </a:xfrm>
+          <a:prstGeom prst="roundRect">
+            <a:avLst>
+              <a:gd name="adj" fmla="val 22000"/>
+            </a:avLst>
+          </a:prstGeom>
+          <a:solidFill>
+            <a:srgbClr val="FFF3E0"/>
+          </a:solidFill>
+          <a:ln>
+            <a:noFill/>
+          </a:ln>
+        </p:spPr>
+      </p:sp>
+      <p:pic>
+        <p:nvPicPr>
+          <p:cNvPr id="17" name="Imagem" descr="syntax"/>
+          <p:cNvPicPr>
+            <a:picLocks noChangeAspect="1"/>
+          </p:cNvPicPr>
+          <p:nvPr/>
+        </p:nvPicPr>
+        <p:blipFill>
+          <a:blip r:embed="rId3"/>
+          <a:stretch>
+            <a:fillRect/>
+          </a:stretch>
+        </p:blipFill>
+        <p:spPr>
+          <a:xfrm>
+            <a:off x="4564563" y="1970715"/>
+            <a:ext cx="228234" cy="228234"/>
+          </a:xfrm>
+          <a:prstGeom prst="rect">
+            <a:avLst/>
+          </a:prstGeom>
+        </p:spPr>
+      </p:pic>
+      <p:sp>
+        <p:nvSpPr>
+          <p:cNvPr id="18" name="Texto"/>
+          <p:cNvSpPr txBox="1"/>
+          <p:nvPr/>
+        </p:nvSpPr>
+        <p:spPr>
+          <a:xfrm>
+            <a:off x="5007864" y="1645920"/>
+            <a:ext cx="880872" cy="868680"/>
+          </a:xfrm>
+          <a:prstGeom prst="roundRect">
+            <a:avLst/>
+          </a:prstGeom>
+          <a:noFill/>
+          <a:ln>
+            <a:noFill/>
+          </a:ln>
+        </p:spPr>
+        <p:txBody>
+          <a:bodyPr wrap="square" lIns="0" tIns="0" rIns="0" bIns="0" rtlCol="0" anchor="ctr"/>
+          <a:lstStyle/>
+          <a:p>
+            <a:pPr algn="l" indent="0" marL="0">
+              <a:buNone/>
+            </a:pPr>
+            <a:r>
+              <a:rPr lang="pt-BR" sz="1250" b="1" dirty="0">
+                <a:solidFill>
+                  <a:srgbClr val="1D2D3E"/>
+                </a:solidFill>
+              </a:rPr>
+              <a:t>3. UI5 linter</a:t>
+            </a:r>
+            <a:endParaRPr lang="pt-BR" sz="1250" dirty="0"/>
+          </a:p>
+        </p:txBody>
+      </p:sp>
+      <p:cxnSp>
+        <p:nvCxnSpPr>
+          <p:cNvPr id="19" name="Conector"/>
+          <p:cNvCxnSpPr/>
+          <p:nvPr/>
+        </p:nvCxnSpPr>
+        <p:spPr>
+          <a:xfrm>
+            <a:off x="6007608" y="2080260"/>
+            <a:ext cx="173736" cy="0"/>
+          </a:xfrm>
+          <a:prstGeom prst="line">
+            <a:avLst/>
+          </a:prstGeom>
+          <a:noFill/>
+          <a:ln w="19050">
+            <a:solidFill>
+              <a:srgbClr val="556B82"/>
+            </a:solidFill>
+            <a:prstDash val="solid"/>
+            <a:round/>
+            <a:tailEnd type="triangle"/>
+          </a:ln>
+        </p:spPr>
+      </p:cxnSp>
+      <p:sp>
+        <p:nvSpPr>
+          <p:cNvPr id="20" name="Etapa build"/>
+          <p:cNvSpPr/>
+          <p:nvPr/>
+        </p:nvSpPr>
+        <p:spPr>
+          <a:xfrm>
+            <a:off x="6208776" y="1645920"/>
+            <a:ext cx="1658112" cy="868680"/>
+          </a:xfrm>
+          <a:prstGeom prst="roundRect">
+            <a:avLst>
+              <a:gd name="adj" fmla="val 5217"/>
+            </a:avLst>
+          </a:prstGeom>
+          <a:solidFill>
+            <a:srgbClr val="FFFFFF"/>
+          </a:solidFill>
+          <a:ln>
+            <a:noFill/>
+          </a:ln>
+          <a:effectLst>
+            <a:outerShdw sx="100000" sy="100000" kx="0" ky="0" algn="bl" rotWithShape="0" blurRad="101600" dist="25400" dir="5400000">
+              <a:srgbClr val="223548">
+                <a:alpha val="16000"/>
+              </a:srgbClr>
+            </a:outerShdw>
+          </a:effectLst>
+        </p:spPr>
+      </p:sp>
+      <p:sp>
+        <p:nvSpPr>
+          <p:cNvPr id="21" name="Ícone sap-box"/>
+          <p:cNvSpPr/>
+          <p:nvPr/>
+        </p:nvSpPr>
+        <p:spPr>
+          <a:xfrm>
+            <a:off x="6345936" y="1865376"/>
+            <a:ext cx="438912" cy="438912"/>
+          </a:xfrm>
+          <a:prstGeom prst="roundRect">
+            <a:avLst>
+              <a:gd name="adj" fmla="val 22000"/>
+            </a:avLst>
+          </a:prstGeom>
+          <a:solidFill>
+            <a:srgbClr val="E3F7F6"/>
+          </a:solidFill>
+          <a:ln>
+            <a:noFill/>
+          </a:ln>
+        </p:spPr>
+      </p:sp>
+      <p:pic>
+        <p:nvPicPr>
+          <p:cNvPr id="22" name="Imagem" descr="sap-box"/>
+          <p:cNvPicPr>
+            <a:picLocks noChangeAspect="1"/>
+          </p:cNvPicPr>
+          <p:nvPr/>
+        </p:nvPicPr>
+        <p:blipFill>
+          <a:blip r:embed="rId4"/>
+          <a:stretch>
+            <a:fillRect/>
+          </a:stretch>
+        </p:blipFill>
+        <p:spPr>
+          <a:xfrm>
+            <a:off x="6451275" y="1970715"/>
+            <a:ext cx="228234" cy="228234"/>
+          </a:xfrm>
+          <a:prstGeom prst="rect">
+            <a:avLst/>
+          </a:prstGeom>
+        </p:spPr>
+      </p:pic>
+      <p:sp>
+        <p:nvSpPr>
+          <p:cNvPr id="23" name="Texto"/>
+          <p:cNvSpPr txBox="1"/>
+          <p:nvPr/>
+        </p:nvSpPr>
+        <p:spPr>
+          <a:xfrm>
+            <a:off x="6894576" y="1645920"/>
+            <a:ext cx="880872" cy="868680"/>
+          </a:xfrm>
+          <a:prstGeom prst="roundRect">
+            <a:avLst/>
+          </a:prstGeom>
+          <a:noFill/>
+          <a:ln>
+            <a:noFill/>
+          </a:ln>
+        </p:spPr>
+        <p:txBody>
+          <a:bodyPr wrap="square" lIns="0" tIns="0" rIns="0" bIns="0" rtlCol="0" anchor="ctr"/>
+          <a:lstStyle/>
+          <a:p>
+            <a:pPr algn="l" indent="0" marL="0">
+              <a:buNone/>
+            </a:pPr>
+            <a:r>
+              <a:rPr lang="pt-BR" sz="1250" b="1" dirty="0">
+                <a:solidFill>
+                  <a:srgbClr val="1D2D3E"/>
+                </a:solidFill>
+              </a:rPr>
+              <a:t>4. build</a:t>
+            </a:r>
+            <a:endParaRPr lang="pt-BR" sz="1250" dirty="0"/>
+          </a:p>
+        </p:txBody>
+      </p:sp>
+      <p:cxnSp>
+        <p:nvCxnSpPr>
+          <p:cNvPr id="24" name="Conector"/>
+          <p:cNvCxnSpPr/>
+          <p:nvPr/>
+        </p:nvCxnSpPr>
+        <p:spPr>
+          <a:xfrm>
+            <a:off x="7894320" y="2080260"/>
+            <a:ext cx="173736" cy="0"/>
+          </a:xfrm>
+          <a:prstGeom prst="line">
+            <a:avLst/>
+          </a:prstGeom>
+          <a:noFill/>
+          <a:ln w="19050">
+            <a:solidFill>
+              <a:srgbClr val="556B82"/>
+            </a:solidFill>
+            <a:prstDash val="solid"/>
+            <a:round/>
+            <a:tailEnd type="triangle"/>
+          </a:ln>
+        </p:spPr>
+      </p:cxnSp>
+      <p:sp>
+        <p:nvSpPr>
+          <p:cNvPr id="25" name="Etapa deploy-test"/>
+          <p:cNvSpPr/>
+          <p:nvPr/>
+        </p:nvSpPr>
+        <p:spPr>
+          <a:xfrm>
+            <a:off x="8095488" y="1645920"/>
+            <a:ext cx="1658112" cy="868680"/>
+          </a:xfrm>
+          <a:prstGeom prst="roundRect">
+            <a:avLst>
+              <a:gd name="adj" fmla="val 5217"/>
+            </a:avLst>
+          </a:prstGeom>
+          <a:solidFill>
+            <a:srgbClr val="FFFFFF"/>
+          </a:solidFill>
+          <a:ln>
+            <a:noFill/>
+          </a:ln>
+          <a:effectLst>
+            <a:outerShdw sx="100000" sy="100000" kx="0" ky="0" algn="bl" rotWithShape="0" blurRad="101600" dist="25400" dir="5400000">
+              <a:srgbClr val="223548">
+                <a:alpha val="16000"/>
+              </a:srgbClr>
+            </a:outerShdw>
+          </a:effectLst>
+        </p:spPr>
+      </p:sp>
+      <p:sp>
+        <p:nvSpPr>
+          <p:cNvPr id="26" name="Ícone upload-to-cloud"/>
+          <p:cNvSpPr/>
+          <p:nvPr/>
+        </p:nvSpPr>
+        <p:spPr>
+          <a:xfrm>
+            <a:off x="8232648" y="1865376"/>
+            <a:ext cx="438912" cy="438912"/>
+          </a:xfrm>
+          <a:prstGeom prst="roundRect">
+            <a:avLst>
+              <a:gd name="adj" fmla="val 22000"/>
+            </a:avLst>
+          </a:prstGeom>
+          <a:solidFill>
+            <a:srgbClr val="FDE8F1"/>
+          </a:solidFill>
+          <a:ln>
+            <a:noFill/>
+          </a:ln>
+        </p:spPr>
+      </p:sp>
+      <p:pic>
+        <p:nvPicPr>
+          <p:cNvPr id="27" name="Imagem" descr="upload-to-cloud"/>
+          <p:cNvPicPr>
+            <a:picLocks noChangeAspect="1"/>
+          </p:cNvPicPr>
+          <p:nvPr/>
+        </p:nvPicPr>
+        <p:blipFill>
+          <a:blip r:embed="rId5"/>
+          <a:stretch>
+            <a:fillRect/>
+          </a:stretch>
+        </p:blipFill>
+        <p:spPr>
+          <a:xfrm>
+            <a:off x="8337987" y="1970715"/>
+            <a:ext cx="228234" cy="228234"/>
+          </a:xfrm>
+          <a:prstGeom prst="rect">
+            <a:avLst/>
+          </a:prstGeom>
+        </p:spPr>
+      </p:pic>
+      <p:sp>
+        <p:nvSpPr>
+          <p:cNvPr id="28" name="Texto"/>
+          <p:cNvSpPr txBox="1"/>
+          <p:nvPr/>
+        </p:nvSpPr>
+        <p:spPr>
+          <a:xfrm>
+            <a:off x="8781288" y="1645920"/>
+            <a:ext cx="880872" cy="868680"/>
+          </a:xfrm>
+          <a:prstGeom prst="roundRect">
+            <a:avLst/>
+          </a:prstGeom>
+          <a:noFill/>
+          <a:ln>
+            <a:noFill/>
+          </a:ln>
+        </p:spPr>
+        <p:txBody>
+          <a:bodyPr wrap="square" lIns="0" tIns="0" rIns="0" bIns="0" rtlCol="0" anchor="ctr"/>
+          <a:lstStyle/>
+          <a:p>
+            <a:pPr algn="l" indent="0" marL="0">
+              <a:buNone/>
+            </a:pPr>
+            <a:r>
+              <a:rPr lang="pt-BR" sz="1250" b="1" dirty="0">
+                <a:solidFill>
+                  <a:srgbClr val="1D2D3E"/>
+                </a:solidFill>
+              </a:rPr>
+              <a:t>5. deploy-test</a:t>
+            </a:r>
+            <a:endParaRPr lang="pt-BR" sz="1250" dirty="0"/>
+          </a:p>
+        </p:txBody>
+      </p:sp>
+      <p:cxnSp>
+        <p:nvCxnSpPr>
+          <p:cNvPr id="29" name="Conector"/>
+          <p:cNvCxnSpPr/>
+          <p:nvPr/>
+        </p:nvCxnSpPr>
+        <p:spPr>
+          <a:xfrm>
+            <a:off x="9781032" y="2080260"/>
+            <a:ext cx="173736" cy="0"/>
+          </a:xfrm>
+          <a:prstGeom prst="line">
+            <a:avLst/>
+          </a:prstGeom>
+          <a:noFill/>
+          <a:ln w="19050">
+            <a:solidFill>
+              <a:srgbClr val="556B82"/>
+            </a:solidFill>
+            <a:prstDash val="solid"/>
+            <a:round/>
+            <a:tailEnd type="triangle"/>
+          </a:ln>
+        </p:spPr>
+      </p:cxnSp>
+      <p:sp>
+        <p:nvSpPr>
+          <p:cNvPr id="30" name="Etapa deploy"/>
+          <p:cNvSpPr/>
+          <p:nvPr/>
+        </p:nvSpPr>
+        <p:spPr>
+          <a:xfrm>
+            <a:off x="9982200" y="1645920"/>
+            <a:ext cx="1658112" cy="868680"/>
+          </a:xfrm>
+          <a:prstGeom prst="roundRect">
+            <a:avLst>
+              <a:gd name="adj" fmla="val 5217"/>
+            </a:avLst>
+          </a:prstGeom>
+          <a:solidFill>
+            <a:srgbClr val="0070F2"/>
+          </a:solidFill>
+          <a:ln>
+            <a:noFill/>
+          </a:ln>
+        </p:spPr>
+      </p:sp>
+      <p:sp>
+        <p:nvSpPr>
+          <p:cNvPr id="31" name="Ícone upload-to-cloud"/>
+          <p:cNvSpPr/>
+          <p:nvPr/>
+        </p:nvSpPr>
+        <p:spPr>
+          <a:xfrm>
+            <a:off x="10119360" y="1865376"/>
+            <a:ext cx="438912" cy="438912"/>
+          </a:xfrm>
+          <a:prstGeom prst="roundRect">
+            <a:avLst>
+              <a:gd name="adj" fmla="val 22000"/>
+            </a:avLst>
+          </a:prstGeom>
+          <a:solidFill>
+            <a:srgbClr val="FFFFFF"/>
+          </a:solidFill>
+          <a:ln>
+            <a:noFill/>
+          </a:ln>
+        </p:spPr>
+      </p:sp>
+      <p:pic>
+        <p:nvPicPr>
+          <p:cNvPr id="32" name="Imagem" descr="upload-to-cloud"/>
+          <p:cNvPicPr>
+            <a:picLocks noChangeAspect="1"/>
+          </p:cNvPicPr>
+          <p:nvPr/>
+        </p:nvPicPr>
+        <p:blipFill>
+          <a:blip r:embed="rId6"/>
+          <a:stretch>
+            <a:fillRect/>
+          </a:stretch>
+        </p:blipFill>
+        <p:spPr>
+          <a:xfrm>
+            <a:off x="10224699" y="1970715"/>
+            <a:ext cx="228234" cy="228234"/>
+          </a:xfrm>
+          <a:prstGeom prst="rect">
+            <a:avLst/>
+          </a:prstGeom>
+        </p:spPr>
+      </p:pic>
+      <p:sp>
+        <p:nvSpPr>
+          <p:cNvPr id="33" name="Texto"/>
+          <p:cNvSpPr txBox="1"/>
+          <p:nvPr/>
+        </p:nvSpPr>
+        <p:spPr>
+          <a:xfrm>
+            <a:off x="10668000" y="1645920"/>
+            <a:ext cx="880872" cy="868680"/>
+          </a:xfrm>
+          <a:prstGeom prst="roundRect">
+            <a:avLst/>
+          </a:prstGeom>
+          <a:noFill/>
+          <a:ln>
+            <a:noFill/>
+          </a:ln>
+        </p:spPr>
+        <p:txBody>
+          <a:bodyPr wrap="square" lIns="0" tIns="0" rIns="0" bIns="0" rtlCol="0" anchor="ctr"/>
+          <a:lstStyle/>
+          <a:p>
+            <a:pPr algn="l" indent="0" marL="0">
+              <a:buNone/>
+            </a:pPr>
+            <a:r>
+              <a:rPr lang="pt-BR" sz="1250" b="1" dirty="0">
+                <a:solidFill>
+                  <a:srgbClr val="FFFFFF"/>
+                </a:solidFill>
+              </a:rPr>
+              <a:t>6. deploy</a:t>
+            </a:r>
+            <a:endParaRPr lang="pt-BR" sz="1250" dirty="0"/>
+          </a:p>
+        </p:txBody>
+      </p:sp>
+      <p:sp>
+        <p:nvSpPr>
+          <p:cNvPr id="34" name="Regra"/>
+          <p:cNvSpPr/>
+          <p:nvPr/>
+        </p:nvSpPr>
+        <p:spPr>
+          <a:xfrm>
+            <a:off x="548640" y="2697480"/>
+            <a:ext cx="11091672" cy="640080"/>
+          </a:xfrm>
+          <a:prstGeom prst="roundRect">
+            <a:avLst>
+              <a:gd name="adj" fmla="val 9000"/>
+            </a:avLst>
+          </a:prstGeom>
+          <a:solidFill>
+            <a:srgbClr val="FFEAF4"/>
+          </a:solidFill>
+          <a:ln>
+            <a:noFill/>
+          </a:ln>
+        </p:spPr>
+      </p:sp>
+      <p:sp>
+        <p:nvSpPr>
+          <p:cNvPr id="35" name="Ícone alert"/>
+          <p:cNvSpPr/>
+          <p:nvPr/>
+        </p:nvSpPr>
+        <p:spPr>
+          <a:xfrm>
+            <a:off x="713232" y="2798064"/>
+            <a:ext cx="438912" cy="438912"/>
+          </a:xfrm>
+          <a:prstGeom prst="roundRect">
+            <a:avLst>
+              <a:gd name="adj" fmla="val 22000"/>
+            </a:avLst>
+          </a:prstGeom>
+          <a:solidFill>
+            <a:srgbClr val="FFFFFF"/>
+          </a:solidFill>
+          <a:ln>
+            <a:noFill/>
+          </a:ln>
+        </p:spPr>
+      </p:sp>
+      <p:pic>
+        <p:nvPicPr>
+          <p:cNvPr id="36" name="Imagem" descr="alert"/>
+          <p:cNvPicPr>
+            <a:picLocks noChangeAspect="1"/>
+          </p:cNvPicPr>
+          <p:nvPr/>
+        </p:nvPicPr>
+        <p:blipFill>
+          <a:blip r:embed="rId7"/>
+          <a:stretch>
+            <a:fillRect/>
+          </a:stretch>
+        </p:blipFill>
+        <p:spPr>
+          <a:xfrm>
+            <a:off x="818571" y="2903403"/>
+            <a:ext cx="228234" cy="228234"/>
+          </a:xfrm>
+          <a:prstGeom prst="rect">
+            <a:avLst/>
+          </a:prstGeom>
+        </p:spPr>
+      </p:pic>
+      <p:sp>
+        <p:nvSpPr>
+          <p:cNvPr id="37" name="Texto"/>
+          <p:cNvSpPr txBox="1"/>
+          <p:nvPr/>
+        </p:nvSpPr>
+        <p:spPr>
+          <a:xfrm>
+            <a:off x="1325880" y="2697480"/>
+            <a:ext cx="10149840" cy="640080"/>
+          </a:xfrm>
+          <a:prstGeom prst="roundRect">
+            <a:avLst/>
+          </a:prstGeom>
+          <a:noFill/>
+          <a:ln>
+            <a:noFill/>
+          </a:ln>
+        </p:spPr>
+        <p:txBody>
+          <a:bodyPr wrap="square" lIns="0" tIns="0" rIns="0" bIns="0" rtlCol="0" anchor="ctr"/>
+          <a:lstStyle/>
+          <a:p>
+            <a:pPr algn="l" indent="0" marL="0">
+              <a:buNone/>
+            </a:pPr>
+            <a:r>
+              <a:rPr lang="pt-BR" sz="1250" b="1" dirty="0">
+                <a:solidFill>
+                  <a:srgbClr val="AA0808"/>
+                </a:solidFill>
+              </a:rPr>
+              <a:t xml:space="preserve">Regra: </a:t>
+            </a:r>
+            <a:r>
+              <a:rPr lang="pt-BR" sz="1250" dirty="0">
+                <a:solidFill>
+                  <a:srgbClr val="1D2D3E"/>
+                </a:solidFill>
+              </a:rPr>
+              <a:t>qualquer falha interrompe a sequência. Corrija, rode de novo desde o lint e só então siga para o deploy.</a:t>
+            </a:r>
+            <a:endParaRPr lang="pt-BR" sz="1250" dirty="0"/>
+          </a:p>
+        </p:txBody>
+      </p:sp>
+      <p:sp>
+        <p:nvSpPr>
+          <p:cNvPr id="38" name="Cartão"/>
+          <p:cNvSpPr/>
+          <p:nvPr/>
+        </p:nvSpPr>
+        <p:spPr>
+          <a:xfrm>
+            <a:off x="548640" y="3520440"/>
+            <a:ext cx="3511296" cy="2651760"/>
+          </a:xfrm>
+          <a:prstGeom prst="roundRect">
+            <a:avLst>
+              <a:gd name="adj" fmla="val 5217"/>
+            </a:avLst>
+          </a:prstGeom>
+          <a:solidFill>
+            <a:srgbClr val="FFFFFF"/>
+          </a:solidFill>
+          <a:ln>
+            <a:noFill/>
+          </a:ln>
+          <a:effectLst>
+            <a:outerShdw sx="100000" sy="100000" kx="0" ky="0" algn="bl" rotWithShape="0" blurRad="101600" dist="25400" dir="5400000">
+              <a:srgbClr val="223548">
+                <a:alpha val="16000"/>
+              </a:srgbClr>
+            </a:outerShdw>
+          </a:effectLst>
+        </p:spPr>
+      </p:sp>
+      <p:sp>
+        <p:nvSpPr>
+          <p:cNvPr id="39" name="Ícone person-placeholder"/>
+          <p:cNvSpPr/>
+          <p:nvPr/>
+        </p:nvSpPr>
+        <p:spPr>
+          <a:xfrm>
+            <a:off x="777240" y="3721608"/>
+            <a:ext cx="475488" cy="475488"/>
+          </a:xfrm>
+          <a:prstGeom prst="roundRect">
+            <a:avLst>
+              <a:gd name="adj" fmla="val 22000"/>
+            </a:avLst>
+          </a:prstGeom>
+          <a:solidFill>
+            <a:srgbClr val="E1F4FF"/>
+          </a:solidFill>
+          <a:ln>
+            <a:noFill/>
+          </a:ln>
+        </p:spPr>
+      </p:sp>
+      <p:pic>
+        <p:nvPicPr>
+          <p:cNvPr id="40" name="Imagem" descr="person-placeholder"/>
+          <p:cNvPicPr>
+            <a:picLocks noChangeAspect="1"/>
+          </p:cNvPicPr>
+          <p:nvPr/>
+        </p:nvPicPr>
+        <p:blipFill>
+          <a:blip r:embed="rId8"/>
+          <a:stretch>
+            <a:fillRect/>
+          </a:stretch>
+        </p:blipFill>
+        <p:spPr>
+          <a:xfrm>
+            <a:off x="891357" y="3835725"/>
+            <a:ext cx="247254" cy="247254"/>
+          </a:xfrm>
+          <a:prstGeom prst="rect">
+            <a:avLst/>
+          </a:prstGeom>
+        </p:spPr>
+      </p:pic>
+      <p:sp>
+        <p:nvSpPr>
+          <p:cNvPr id="41" name="Texto"/>
+          <p:cNvSpPr txBox="1"/>
+          <p:nvPr/>
+        </p:nvSpPr>
+        <p:spPr>
+          <a:xfrm>
+            <a:off x="1371600" y="3721608"/>
+            <a:ext cx="2560320" cy="475488"/>
+          </a:xfrm>
+          <a:prstGeom prst="roundRect">
+            <a:avLst/>
+          </a:prstGeom>
+          <a:noFill/>
+          <a:ln>
+            <a:noFill/>
+          </a:ln>
+        </p:spPr>
+        <p:txBody>
+          <a:bodyPr wrap="square" lIns="0" tIns="0" rIns="0" bIns="0" rtlCol="0" anchor="ctr"/>
+          <a:lstStyle/>
+          <a:p>
+            <a:pPr algn="l" indent="0" marL="0">
+              <a:buNone/>
+            </a:pPr>
+            <a:r>
+              <a:rPr lang="pt-BR" sz="1400" b="1" dirty="0">
+                <a:solidFill>
+                  <a:srgbClr val="1D2D3E"/>
+                </a:solidFill>
+              </a:rPr>
+              <a:t>Sem CI no repositório</a:t>
+            </a:r>
+            <a:endParaRPr lang="pt-BR" sz="1400" dirty="0"/>
+          </a:p>
+        </p:txBody>
+      </p:sp>
+      <p:sp>
+        <p:nvSpPr>
+          <p:cNvPr id="42" name="Texto"/>
+          <p:cNvSpPr txBox="1"/>
+          <p:nvPr/>
+        </p:nvSpPr>
+        <p:spPr>
+          <a:xfrm>
+            <a:off x="777240" y="4343400"/>
+            <a:ext cx="3063240" cy="1234440"/>
+          </a:xfrm>
+          <a:prstGeom prst="roundRect">
+            <a:avLst/>
+          </a:prstGeom>
+          <a:noFill/>
+          <a:ln>
+            <a:noFill/>
+          </a:ln>
+        </p:spPr>
+        <p:txBody>
+          <a:bodyPr wrap="square" lIns="0" tIns="0" rIns="0" bIns="0" rtlCol="0" anchor="t"/>
+          <a:lstStyle/>
+          <a:p>
+            <a:pPr algn="l" indent="0" marL="0">
+              <a:buNone/>
+            </a:pPr>
+            <a:r>
+              <a:rPr lang="pt-BR" sz="1200" dirty="0">
+                <a:solidFill>
+                  <a:srgbClr val="1D2D3E"/>
+                </a:solidFill>
+              </a:rPr>
+              <a:t>Nenhum pipeline roda os testes por você: a única barreira entre o código e o sistema é quem executa o npm run deploy.</a:t>
+            </a:r>
+            <a:endParaRPr lang="pt-BR" sz="1200" dirty="0"/>
+          </a:p>
+        </p:txBody>
+      </p:sp>
+      <p:cxnSp>
+        <p:nvCxnSpPr>
+          <p:cNvPr id="43" name="Conector"/>
+          <p:cNvCxnSpPr/>
+          <p:nvPr/>
+        </p:nvCxnSpPr>
+        <p:spPr>
+          <a:xfrm>
+            <a:off x="777240" y="5623560"/>
+            <a:ext cx="3054096" cy="0"/>
+          </a:xfrm>
+          <a:prstGeom prst="line">
+            <a:avLst/>
+          </a:prstGeom>
+          <a:noFill/>
+          <a:ln w="12700">
+            <a:solidFill>
+              <a:srgbClr val="E5E5E5"/>
+            </a:solidFill>
+            <a:prstDash val="solid"/>
+            <a:round/>
+          </a:ln>
+        </p:spPr>
+      </p:cxnSp>
+      <p:sp>
+        <p:nvSpPr>
+          <p:cNvPr id="44" name="Texto"/>
+          <p:cNvSpPr txBox="1"/>
+          <p:nvPr/>
+        </p:nvSpPr>
+        <p:spPr>
+          <a:xfrm>
+            <a:off x="777240" y="5687568"/>
+            <a:ext cx="3063240" cy="365760"/>
+          </a:xfrm>
+          <a:prstGeom prst="roundRect">
+            <a:avLst/>
+          </a:prstGeom>
+          <a:noFill/>
+          <a:ln>
+            <a:noFill/>
+          </a:ln>
+        </p:spPr>
+        <p:txBody>
+          <a:bodyPr wrap="square" lIns="0" tIns="0" rIns="0" bIns="0" rtlCol="0" anchor="ctr"/>
+          <a:lstStyle/>
+          <a:p>
+            <a:pPr algn="l" indent="0" marL="0">
+              <a:buNone/>
+            </a:pPr>
+            <a:r>
+              <a:rPr lang="pt-BR" sz="1100" b="1" dirty="0">
+                <a:solidFill>
+                  <a:srgbClr val="0070F2"/>
+                </a:solidFill>
+              </a:rPr>
+              <a:t>Responsável: quem publica</a:t>
+            </a:r>
+            <a:endParaRPr lang="pt-BR" sz="1100" dirty="0"/>
+          </a:p>
+        </p:txBody>
+      </p:sp>
+      <p:sp>
+        <p:nvSpPr>
+          <p:cNvPr id="45" name="Cartão"/>
+          <p:cNvSpPr/>
+          <p:nvPr/>
+        </p:nvSpPr>
+        <p:spPr>
+          <a:xfrm>
+            <a:off x="4338828" y="3520440"/>
+            <a:ext cx="3511296" cy="2651760"/>
+          </a:xfrm>
+          <a:prstGeom prst="roundRect">
+            <a:avLst>
+              <a:gd name="adj" fmla="val 5217"/>
+            </a:avLst>
+          </a:prstGeom>
+          <a:solidFill>
+            <a:srgbClr val="FFFFFF"/>
+          </a:solidFill>
+          <a:ln>
+            <a:noFill/>
+          </a:ln>
+          <a:effectLst>
+            <a:outerShdw sx="100000" sy="100000" kx="0" ky="0" algn="bl" rotWithShape="0" blurRad="101600" dist="25400" dir="5400000">
+              <a:srgbClr val="223548">
+                <a:alpha val="16000"/>
+              </a:srgbClr>
+            </a:outerShdw>
+          </a:effectLst>
+        </p:spPr>
+      </p:sp>
+      <p:sp>
+        <p:nvSpPr>
+          <p:cNvPr id="46" name="Ícone list"/>
+          <p:cNvSpPr/>
+          <p:nvPr/>
+        </p:nvSpPr>
+        <p:spPr>
+          <a:xfrm>
+            <a:off x="4567428" y="3721608"/>
+            <a:ext cx="475488" cy="475488"/>
+          </a:xfrm>
+          <a:prstGeom prst="roundRect">
+            <a:avLst>
+              <a:gd name="adj" fmla="val 22000"/>
+            </a:avLst>
+          </a:prstGeom>
+          <a:solidFill>
+            <a:srgbClr val="E3F7F6"/>
+          </a:solidFill>
+          <a:ln>
+            <a:noFill/>
+          </a:ln>
+        </p:spPr>
+      </p:sp>
+      <p:pic>
+        <p:nvPicPr>
+          <p:cNvPr id="47" name="Imagem" descr="list"/>
+          <p:cNvPicPr>
+            <a:picLocks noChangeAspect="1"/>
+          </p:cNvPicPr>
+          <p:nvPr/>
+        </p:nvPicPr>
+        <p:blipFill>
+          <a:blip r:embed="rId9"/>
+          <a:stretch>
+            <a:fillRect/>
+          </a:stretch>
+        </p:blipFill>
+        <p:spPr>
+          <a:xfrm>
+            <a:off x="4681545" y="3835725"/>
+            <a:ext cx="247254" cy="247254"/>
+          </a:xfrm>
+          <a:prstGeom prst="rect">
+            <a:avLst/>
+          </a:prstGeom>
+        </p:spPr>
+      </p:pic>
+      <p:sp>
+        <p:nvSpPr>
+          <p:cNvPr id="48" name="Texto"/>
+          <p:cNvSpPr txBox="1"/>
+          <p:nvPr/>
+        </p:nvSpPr>
+        <p:spPr>
+          <a:xfrm>
+            <a:off x="5161788" y="3721608"/>
+            <a:ext cx="2560320" cy="475488"/>
+          </a:xfrm>
+          <a:prstGeom prst="roundRect">
+            <a:avLst/>
+          </a:prstGeom>
+          <a:noFill/>
+          <a:ln>
+            <a:noFill/>
+          </a:ln>
+        </p:spPr>
+        <p:txBody>
+          <a:bodyPr wrap="square" lIns="0" tIns="0" rIns="0" bIns="0" rtlCol="0" anchor="ctr"/>
+          <a:lstStyle/>
+          <a:p>
+            <a:pPr algn="l" indent="0" marL="0">
+              <a:buNone/>
+            </a:pPr>
+            <a:r>
+              <a:rPr lang="pt-BR" sz="1400" b="1" dirty="0">
+                <a:solidFill>
+                  <a:srgbClr val="1D2D3E"/>
+                </a:solidFill>
+              </a:rPr>
+              <a:t>Cada app é um projeto</a:t>
+            </a:r>
+            <a:endParaRPr lang="pt-BR" sz="1400" dirty="0"/>
+          </a:p>
+        </p:txBody>
+      </p:sp>
+      <p:sp>
+        <p:nvSpPr>
+          <p:cNvPr id="49" name="Texto"/>
+          <p:cNvSpPr txBox="1"/>
+          <p:nvPr/>
+        </p:nvSpPr>
+        <p:spPr>
+          <a:xfrm>
+            <a:off x="4567428" y="4343400"/>
+            <a:ext cx="3063240" cy="1234440"/>
+          </a:xfrm>
+          <a:prstGeom prst="roundRect">
+            <a:avLst/>
+          </a:prstGeom>
+          <a:noFill/>
+          <a:ln>
+            <a:noFill/>
+          </a:ln>
+        </p:spPr>
+        <p:txBody>
+          <a:bodyPr wrap="square" lIns="0" tIns="0" rIns="0" bIns="0" rtlCol="0" anchor="t"/>
+          <a:lstStyle/>
+          <a:p>
+            <a:pPr algn="l" indent="0" marL="0">
+              <a:buNone/>
+            </a:pPr>
+            <a:r>
+              <a:rPr lang="pt-BR" sz="1200" dirty="0">
+                <a:solidFill>
+                  <a:srgbClr val="1D2D3E"/>
+                </a:solidFill>
+              </a:rPr>
+              <a:t>Os comandos rodam na pasta de cada app alterada. Uma correção no motor das análises vale para as quatro e exige rodar as quatro.</a:t>
+            </a:r>
+            <a:endParaRPr lang="pt-BR" sz="1200" dirty="0"/>
+          </a:p>
+        </p:txBody>
+      </p:sp>
+      <p:cxnSp>
+        <p:nvCxnSpPr>
+          <p:cNvPr id="50" name="Conector"/>
+          <p:cNvCxnSpPr/>
+          <p:nvPr/>
+        </p:nvCxnSpPr>
+        <p:spPr>
+          <a:xfrm>
+            <a:off x="4567428" y="5623560"/>
+            <a:ext cx="3054096" cy="0"/>
+          </a:xfrm>
+          <a:prstGeom prst="line">
+            <a:avLst/>
+          </a:prstGeom>
+          <a:noFill/>
+          <a:ln w="12700">
+            <a:solidFill>
+              <a:srgbClr val="E5E5E5"/>
+            </a:solidFill>
+            <a:prstDash val="solid"/>
+            <a:round/>
+          </a:ln>
+        </p:spPr>
+      </p:cxnSp>
+      <p:sp>
+        <p:nvSpPr>
+          <p:cNvPr id="51" name="Texto"/>
+          <p:cNvSpPr txBox="1"/>
+          <p:nvPr/>
+        </p:nvSpPr>
+        <p:spPr>
+          <a:xfrm>
+            <a:off x="4567428" y="5687568"/>
+            <a:ext cx="3063240" cy="365760"/>
+          </a:xfrm>
+          <a:prstGeom prst="roundRect">
+            <a:avLst/>
+          </a:prstGeom>
+          <a:noFill/>
+          <a:ln>
+            <a:noFill/>
+          </a:ln>
+        </p:spPr>
+        <p:txBody>
+          <a:bodyPr wrap="square" lIns="0" tIns="0" rIns="0" bIns="0" rtlCol="0" anchor="ctr"/>
+          <a:lstStyle/>
+          <a:p>
+            <a:pPr algn="l" indent="0" marL="0">
+              <a:buNone/>
+            </a:pPr>
+            <a:r>
+              <a:rPr lang="pt-BR" sz="1100" b="1" dirty="0">
+                <a:solidFill>
+                  <a:srgbClr val="049F9A"/>
+                </a:solidFill>
+              </a:rPr>
+              <a:t>Escopo: todas as apps tocadas</a:t>
+            </a:r>
+            <a:endParaRPr lang="pt-BR" sz="1100" dirty="0"/>
+          </a:p>
+        </p:txBody>
+      </p:sp>
+      <p:sp>
+        <p:nvSpPr>
+          <p:cNvPr id="52" name="Cartão"/>
+          <p:cNvSpPr/>
+          <p:nvPr/>
+        </p:nvSpPr>
+        <p:spPr>
+          <a:xfrm>
+            <a:off x="8129016" y="3520440"/>
+            <a:ext cx="3511296" cy="2651760"/>
+          </a:xfrm>
+          <a:prstGeom prst="roundRect">
+            <a:avLst>
+              <a:gd name="adj" fmla="val 5217"/>
+            </a:avLst>
+          </a:prstGeom>
+          <a:solidFill>
+            <a:srgbClr val="FFFFFF"/>
+          </a:solidFill>
+          <a:ln>
+            <a:noFill/>
+          </a:ln>
+          <a:effectLst>
+            <a:outerShdw sx="100000" sy="100000" kx="0" ky="0" algn="bl" rotWithShape="0" blurRad="101600" dist="25400" dir="5400000">
+              <a:srgbClr val="223548">
+                <a:alpha val="16000"/>
+              </a:srgbClr>
+            </a:outerShdw>
+          </a:effectLst>
+        </p:spPr>
+      </p:sp>
+      <p:sp>
+        <p:nvSpPr>
+          <p:cNvPr id="53" name="Ícone it-system"/>
+          <p:cNvSpPr/>
+          <p:nvPr/>
+        </p:nvSpPr>
+        <p:spPr>
+          <a:xfrm>
+            <a:off x="8357616" y="3721608"/>
+            <a:ext cx="475488" cy="475488"/>
+          </a:xfrm>
+          <a:prstGeom prst="roundRect">
+            <a:avLst>
+              <a:gd name="adj" fmla="val 22000"/>
+            </a:avLst>
+          </a:prstGeom>
+          <a:solidFill>
+            <a:srgbClr val="F3ECFB"/>
+          </a:solidFill>
+          <a:ln>
+            <a:noFill/>
+          </a:ln>
+        </p:spPr>
+      </p:sp>
+      <p:pic>
+        <p:nvPicPr>
+          <p:cNvPr id="54" name="Imagem" descr="it-system"/>
+          <p:cNvPicPr>
+            <a:picLocks noChangeAspect="1"/>
+          </p:cNvPicPr>
+          <p:nvPr/>
+        </p:nvPicPr>
+        <p:blipFill>
+          <a:blip r:embed="rId10"/>
+          <a:stretch>
+            <a:fillRect/>
+          </a:stretch>
+        </p:blipFill>
+        <p:spPr>
+          <a:xfrm>
+            <a:off x="8471733" y="3835725"/>
+            <a:ext cx="247254" cy="247254"/>
+          </a:xfrm>
+          <a:prstGeom prst="rect">
+            <a:avLst/>
+          </a:prstGeom>
+        </p:spPr>
+      </p:pic>
+      <p:sp>
+        <p:nvSpPr>
+          <p:cNvPr id="55" name="Texto"/>
+          <p:cNvSpPr txBox="1"/>
+          <p:nvPr/>
+        </p:nvSpPr>
+        <p:spPr>
+          <a:xfrm>
+            <a:off x="8951976" y="3721608"/>
+            <a:ext cx="2560320" cy="475488"/>
+          </a:xfrm>
+          <a:prstGeom prst="roundRect">
+            <a:avLst/>
+          </a:prstGeom>
+          <a:noFill/>
+          <a:ln>
+            <a:noFill/>
+          </a:ln>
+        </p:spPr>
+        <p:txBody>
+          <a:bodyPr wrap="square" lIns="0" tIns="0" rIns="0" bIns="0" rtlCol="0" anchor="ctr"/>
+          <a:lstStyle/>
+          <a:p>
+            <a:pPr algn="l" indent="0" marL="0">
+              <a:buNone/>
+            </a:pPr>
+            <a:r>
+              <a:rPr lang="pt-BR" sz="1400" b="1" dirty="0">
+                <a:solidFill>
+                  <a:srgbClr val="1D2D3E"/>
+                </a:solidFill>
+              </a:rPr>
+              <a:t>O sistema é compartilhado</a:t>
+            </a:r>
+            <a:endParaRPr lang="pt-BR" sz="1400" dirty="0"/>
+          </a:p>
+        </p:txBody>
+      </p:sp>
+      <p:sp>
+        <p:nvSpPr>
+          <p:cNvPr id="56" name="Texto"/>
+          <p:cNvSpPr txBox="1"/>
+          <p:nvPr/>
+        </p:nvSpPr>
+        <p:spPr>
+          <a:xfrm>
+            <a:off x="8357616" y="4343400"/>
+            <a:ext cx="3063240" cy="1234440"/>
+          </a:xfrm>
+          <a:prstGeom prst="roundRect">
+            <a:avLst/>
+          </a:prstGeom>
+          <a:noFill/>
+          <a:ln>
+            <a:noFill/>
+          </a:ln>
+        </p:spPr>
+        <p:txBody>
+          <a:bodyPr wrap="square" lIns="0" tIns="0" rIns="0" bIns="0" rtlCol="0" anchor="t"/>
+          <a:lstStyle/>
+          <a:p>
+            <a:pPr algn="l" indent="0" marL="0">
+              <a:buNone/>
+            </a:pPr>
+            <a:r>
+              <a:rPr lang="pt-BR" sz="1200" dirty="0">
+                <a:solidFill>
+                  <a:srgbClr val="1D2D3E"/>
+                </a:solidFill>
+              </a:rPr>
+              <a:t>No BTP trial o pacote ZLOCAL não tem transporte: a versão vale na hora. No On-Premise a ordem leva o mesmo código a QAS e PRD.</a:t>
+            </a:r>
+            <a:endParaRPr lang="pt-BR" sz="1200" dirty="0"/>
+          </a:p>
+        </p:txBody>
+      </p:sp>
+      <p:cxnSp>
+        <p:nvCxnSpPr>
+          <p:cNvPr id="57" name="Conector"/>
+          <p:cNvCxnSpPr/>
+          <p:nvPr/>
+        </p:nvCxnSpPr>
+        <p:spPr>
+          <a:xfrm>
+            <a:off x="8357616" y="5623560"/>
+            <a:ext cx="3054096" cy="0"/>
+          </a:xfrm>
+          <a:prstGeom prst="line">
+            <a:avLst/>
+          </a:prstGeom>
+          <a:noFill/>
+          <a:ln w="12700">
+            <a:solidFill>
+              <a:srgbClr val="E5E5E5"/>
+            </a:solidFill>
+            <a:prstDash val="solid"/>
+            <a:round/>
+          </a:ln>
+        </p:spPr>
+      </p:cxnSp>
+      <p:sp>
+        <p:nvSpPr>
+          <p:cNvPr id="58" name="Texto"/>
+          <p:cNvSpPr txBox="1"/>
+          <p:nvPr/>
+        </p:nvSpPr>
+        <p:spPr>
+          <a:xfrm>
+            <a:off x="8357616" y="5687568"/>
+            <a:ext cx="3063240" cy="365760"/>
+          </a:xfrm>
+          <a:prstGeom prst="roundRect">
+            <a:avLst/>
+          </a:prstGeom>
+          <a:noFill/>
+          <a:ln>
+            <a:noFill/>
+          </a:ln>
+        </p:spPr>
+        <p:txBody>
+          <a:bodyPr wrap="square" lIns="0" tIns="0" rIns="0" bIns="0" rtlCol="0" anchor="ctr"/>
+          <a:lstStyle/>
+          <a:p>
+            <a:pPr algn="l" indent="0" marL="0">
+              <a:buNone/>
+            </a:pPr>
+            <a:r>
+              <a:rPr lang="pt-BR" sz="1100" b="1" dirty="0">
+                <a:solidFill>
+                  <a:srgbClr val="8B47D7"/>
+                </a:solidFill>
+              </a:rPr>
+              <a:t>Impacto: todos os usuários</a:t>
+            </a:r>
+            <a:endParaRPr lang="pt-BR" sz="1100" dirty="0"/>
+          </a:p>
+        </p:txBody>
+      </p:sp>
+      <p:sp>
+        <p:nvSpPr>
+          <p:cNvPr id="59" name="Slide Number Placeholder 0"/>
+          <p:cNvSpPr>
+            <a:spLocks noGrp="1"/>
+          </p:cNvSpPr>
+          <p:nvPr>
+            <p:ph type="sldNum" sz="quarter" idx="4294967295"/>
+          </p:nvPr>
+        </p:nvSpPr>
+        <p:spPr>
+          <a:xfrm>
+            <a:off x="11183112" y="6419088"/>
+            <a:ext cx="457200" cy="274320"/>
+          </a:xfrm>
+          <a:prstGeom prst="rect">
+            <a:avLst/>
+          </a:prstGeom>
+        </p:spPr>
+        <p:txBody>
+          <a:bodyPr lIns="0" tIns="0" rIns="0" bIns="0" anchor="ctr"/>
+          <a:lstStyle>
+            <a:lvl1pPr>
+              <a:defRPr sz="900">
+                <a:solidFill>
+                  <a:srgbClr val="556B82"/>
+                </a:solidFill>
+              </a:defRPr>
+            </a:lvl1pPr>
+          </a:lstStyle>
+          <a:p>
+            <a:pPr algn="r"/>
+            <a:fld id="{F7021451-1387-4CA6-816F-3879F97B5CBC}" type="slidenum">
+              <a:rPr b="0" lang="en-US"/>
+              <a:t>1</a:t>
+            </a:fld>
+            <a:endParaRPr lang="en-US"/>
+          </a:p>
+        </p:txBody>
+      </p:sp>
+    </p:spTree>
+  </p:cSld>
+  <p:clrMapOvr>
+    <a:masterClrMapping/>
+  </p:clrMapOvr>
+</p:sld>
+</file>
+
 <file path=ppt/slides/slide4.xml><?xml version="1.0" encoding="utf-8"?>
 <p:sld xmlns:a="http://schemas.openxmlformats.org/drawingml/2006/main" xmlns:r="http://schemas.openxmlformats.org/officeDocument/2006/relationships" xmlns:p="http://schemas.openxmlformats.org/presentationml/2006/main">
   <p:cSld name="Slide 4">

</xml_diff>